<commit_message>
added the next plan
</commit_message>
<xml_diff>
--- a/presentations/Mini_Project_Review_0.pptx
+++ b/presentations/Mini_Project_Review_0.pptx
@@ -1,34 +1,34 @@
 
 <file path=ppt/presentation.xml><?xml version="1.0" encoding="utf-8"?>
-<p:presentation xmlns:a="http://schemas.openxmlformats.org/drawingml/2006/main" xmlns:r="http://schemas.openxmlformats.org/officeDocument/2006/relationships" xmlns:mc="http://schemas.openxmlformats.org/markup-compatibility/2006" xmlns:mv="urn:schemas-microsoft-com:mac:vml" xmlns:p="http://schemas.openxmlformats.org/presentationml/2006/main" xmlns:c="http://schemas.openxmlformats.org/drawingml/2006/chart" xmlns:dgm="http://schemas.openxmlformats.org/drawingml/2006/diagram" xmlns:o="urn:schemas-microsoft-com:office:office" xmlns:v="urn:schemas-microsoft-com:vml" xmlns:pvml="urn:schemas-microsoft-com:office:powerpoint" xmlns:com="http://schemas.openxmlformats.org/drawingml/2006/compatibility" xmlns:p14="http://schemas.microsoft.com/office/powerpoint/2010/main" xmlns:p15="http://schemas.microsoft.com/office/powerpoint/2012/main" xmlns:ahyp="http://schemas.microsoft.com/office/drawing/2018/hyperlinkcolor" autoCompressPictures="0" strictFirstAndLastChars="0" saveSubsetFonts="1">
+<p:presentation xmlns:a="http://schemas.openxmlformats.org/drawingml/2006/main" xmlns:r="http://schemas.openxmlformats.org/officeDocument/2006/relationships" xmlns:p="http://schemas.openxmlformats.org/presentationml/2006/main" strictFirstAndLastChars="0" saveSubsetFonts="1" autoCompressPictures="0">
   <p:sldMasterIdLst>
-    <p:sldMasterId id="2147483648" r:id="rId5"/>
+    <p:sldMasterId id="2147483648" r:id="rId1"/>
   </p:sldMasterIdLst>
   <p:notesMasterIdLst>
-    <p:notesMasterId r:id="rId6"/>
+    <p:notesMasterId r:id="rId14"/>
   </p:notesMasterIdLst>
   <p:sldIdLst>
-    <p:sldId id="256" r:id="rId7"/>
-    <p:sldId id="258" r:id="rId9"/>
-    <p:sldId id="259" r:id="rId10"/>
-    <p:sldId id="260" r:id="rId11"/>
-    <p:sldId id="261" r:id="rId12"/>
-    <p:sldId id="262" r:id="rId13"/>
-    <p:sldId id="263" r:id="rId14"/>
-    <p:sldId id="264" r:id="rId15"/>
-    <p:sldId id="265" r:id="rId16"/>
-    <p:sldId id="266" r:id="rId17"/>
-    <p:sldId id="267" r:id="rId18"/>
-    <p:sldId id="293" r:id="rId44"/>
+    <p:sldId id="256" r:id="rId2"/>
+    <p:sldId id="258" r:id="rId3"/>
+    <p:sldId id="259" r:id="rId4"/>
+    <p:sldId id="260" r:id="rId5"/>
+    <p:sldId id="261" r:id="rId6"/>
+    <p:sldId id="262" r:id="rId7"/>
+    <p:sldId id="263" r:id="rId8"/>
+    <p:sldId id="264" r:id="rId9"/>
+    <p:sldId id="265" r:id="rId10"/>
+    <p:sldId id="266" r:id="rId11"/>
+    <p:sldId id="267" r:id="rId12"/>
+    <p:sldId id="293" r:id="rId13"/>
   </p:sldIdLst>
-  <p:sldSz cy="6858000" cx="9144000"/>
-  <p:notesSz cx="6954825" cy="9309100"/>
+  <p:sldSz cx="9144000" cy="6858000" type="screen4x3"/>
+  <p:notesSz cx="6954838" cy="9309100"/>
   <p:defaultTextStyle>
     <a:defPPr lvl="0">
       <a:defRPr lang="en-US"/>
     </a:defPPr>
-    <a:lvl1pPr defTabSz="457200" eaLnBrk="1" hangingPunct="1" latinLnBrk="0" lvl="0" marL="0" rtl="0" algn="l">
-      <a:defRPr kern="1200" sz="1800">
+    <a:lvl1pPr marL="0" lvl="0" algn="l" defTabSz="457200" rtl="0" eaLnBrk="1" latinLnBrk="0" hangingPunct="1">
+      <a:defRPr sz="1800" kern="1200">
         <a:solidFill>
           <a:schemeClr val="tx1"/>
         </a:solidFill>
@@ -37,8 +37,8 @@
         <a:cs typeface="+mn-cs"/>
       </a:defRPr>
     </a:lvl1pPr>
-    <a:lvl2pPr defTabSz="457200" eaLnBrk="1" hangingPunct="1" latinLnBrk="0" lvl="1" marL="457200" rtl="0" algn="l">
-      <a:defRPr kern="1200" sz="1800">
+    <a:lvl2pPr marL="457200" lvl="1" algn="l" defTabSz="457200" rtl="0" eaLnBrk="1" latinLnBrk="0" hangingPunct="1">
+      <a:defRPr sz="1800" kern="1200">
         <a:solidFill>
           <a:schemeClr val="tx1"/>
         </a:solidFill>
@@ -47,8 +47,8 @@
         <a:cs typeface="+mn-cs"/>
       </a:defRPr>
     </a:lvl2pPr>
-    <a:lvl3pPr defTabSz="457200" eaLnBrk="1" hangingPunct="1" latinLnBrk="0" lvl="2" marL="914400" rtl="0" algn="l">
-      <a:defRPr kern="1200" sz="1800">
+    <a:lvl3pPr marL="914400" lvl="2" algn="l" defTabSz="457200" rtl="0" eaLnBrk="1" latinLnBrk="0" hangingPunct="1">
+      <a:defRPr sz="1800" kern="1200">
         <a:solidFill>
           <a:schemeClr val="tx1"/>
         </a:solidFill>
@@ -57,8 +57,8 @@
         <a:cs typeface="+mn-cs"/>
       </a:defRPr>
     </a:lvl3pPr>
-    <a:lvl4pPr defTabSz="457200" eaLnBrk="1" hangingPunct="1" latinLnBrk="0" lvl="3" marL="1371600" rtl="0" algn="l">
-      <a:defRPr kern="1200" sz="1800">
+    <a:lvl4pPr marL="1371600" lvl="3" algn="l" defTabSz="457200" rtl="0" eaLnBrk="1" latinLnBrk="0" hangingPunct="1">
+      <a:defRPr sz="1800" kern="1200">
         <a:solidFill>
           <a:schemeClr val="tx1"/>
         </a:solidFill>
@@ -67,8 +67,8 @@
         <a:cs typeface="+mn-cs"/>
       </a:defRPr>
     </a:lvl4pPr>
-    <a:lvl5pPr defTabSz="457200" eaLnBrk="1" hangingPunct="1" latinLnBrk="0" lvl="4" marL="1828800" rtl="0" algn="l">
-      <a:defRPr kern="1200" sz="1800">
+    <a:lvl5pPr marL="1828800" lvl="4" algn="l" defTabSz="457200" rtl="0" eaLnBrk="1" latinLnBrk="0" hangingPunct="1">
+      <a:defRPr sz="1800" kern="1200">
         <a:solidFill>
           <a:schemeClr val="tx1"/>
         </a:solidFill>
@@ -77,8 +77,8 @@
         <a:cs typeface="+mn-cs"/>
       </a:defRPr>
     </a:lvl5pPr>
-    <a:lvl6pPr defTabSz="457200" eaLnBrk="1" hangingPunct="1" latinLnBrk="0" lvl="5" marL="2286000" rtl="0" algn="l">
-      <a:defRPr kern="1200" sz="1800">
+    <a:lvl6pPr marL="2286000" lvl="5" algn="l" defTabSz="457200" rtl="0" eaLnBrk="1" latinLnBrk="0" hangingPunct="1">
+      <a:defRPr sz="1800" kern="1200">
         <a:solidFill>
           <a:schemeClr val="tx1"/>
         </a:solidFill>
@@ -87,8 +87,8 @@
         <a:cs typeface="+mn-cs"/>
       </a:defRPr>
     </a:lvl6pPr>
-    <a:lvl7pPr defTabSz="457200" eaLnBrk="1" hangingPunct="1" latinLnBrk="0" lvl="6" marL="2743200" rtl="0" algn="l">
-      <a:defRPr kern="1200" sz="1800">
+    <a:lvl7pPr marL="2743200" lvl="6" algn="l" defTabSz="457200" rtl="0" eaLnBrk="1" latinLnBrk="0" hangingPunct="1">
+      <a:defRPr sz="1800" kern="1200">
         <a:solidFill>
           <a:schemeClr val="tx1"/>
         </a:solidFill>
@@ -97,8 +97,8 @@
         <a:cs typeface="+mn-cs"/>
       </a:defRPr>
     </a:lvl7pPr>
-    <a:lvl8pPr defTabSz="457200" eaLnBrk="1" hangingPunct="1" latinLnBrk="0" lvl="7" marL="3200400" rtl="0" algn="l">
-      <a:defRPr kern="1200" sz="1800">
+    <a:lvl8pPr marL="3200400" lvl="7" algn="l" defTabSz="457200" rtl="0" eaLnBrk="1" latinLnBrk="0" hangingPunct="1">
+      <a:defRPr sz="1800" kern="1200">
         <a:solidFill>
           <a:schemeClr val="tx1"/>
         </a:solidFill>
@@ -107,8 +107,8 @@
         <a:cs typeface="+mn-cs"/>
       </a:defRPr>
     </a:lvl8pPr>
-    <a:lvl9pPr defTabSz="457200" eaLnBrk="1" hangingPunct="1" latinLnBrk="0" lvl="8" marL="3657600" rtl="0" algn="l">
-      <a:defRPr kern="1200" sz="1800">
+    <a:lvl9pPr marL="3657600" lvl="8" algn="l" defTabSz="457200" rtl="0" eaLnBrk="1" latinLnBrk="0" hangingPunct="1">
+      <a:defRPr sz="1800" kern="1200">
         <a:solidFill>
           <a:schemeClr val="tx1"/>
         </a:solidFill>
@@ -120,7 +120,7 @@
   </p:defaultTextStyle>
   <p:extLst>
     <p:ext uri="{EFAFB233-063F-42B5-8137-9DF3F51BA10A}">
-      <p15:sldGuideLst>
+      <p15:sldGuideLst xmlns:p15="http://schemas.microsoft.com/office/powerpoint/2012/main">
         <p15:guide id="1" orient="horz" pos="2160">
           <p15:clr>
             <a:srgbClr val="A4A3A4"/>
@@ -135,94 +135,6 @@
     </p:ext>
   </p:extLst>
 </p:presentation>
-</file>
-
-<file path=ppt/presProps1.xml><?xml version="1.0" encoding="utf-8"?>
-<p:presentationPr xmlns:a="http://schemas.openxmlformats.org/drawingml/2006/main" xmlns:r="http://schemas.openxmlformats.org/officeDocument/2006/relationships" xmlns:mc="http://schemas.openxmlformats.org/markup-compatibility/2006" xmlns:mv="urn:schemas-microsoft-com:mac:vml" xmlns:p="http://schemas.openxmlformats.org/presentationml/2006/main" xmlns:c="http://schemas.openxmlformats.org/drawingml/2006/chart" xmlns:dgm="http://schemas.openxmlformats.org/drawingml/2006/diagram" xmlns:o="urn:schemas-microsoft-com:office:office" xmlns:v="urn:schemas-microsoft-com:vml" xmlns:pvml="urn:schemas-microsoft-com:office:powerpoint" xmlns:com="http://schemas.openxmlformats.org/drawingml/2006/compatibility" xmlns:p14="http://schemas.microsoft.com/office/powerpoint/2010/main" xmlns:p15="http://schemas.microsoft.com/office/powerpoint/2012/main" xmlns:ahyp="http://schemas.microsoft.com/office/drawing/2018/hyperlinkcolor"/>
-</file>
-
-<file path=ppt/tableStyles1.xml><?xml version="1.0" encoding="utf-8"?>
-<a:tblStyleLst xmlns:a="http://schemas.openxmlformats.org/drawingml/2006/main" xmlns:r="http://schemas.openxmlformats.org/officeDocument/2006/relationships" def="{90651C3A-4460-11DB-9652-00E08161165F}">
-  <a:tblStyle styleId="{5940675A-B579-460E-94D1-54222C63F5DA}" styleName="No Style, Table Grid">
-    <a:wholeTbl>
-      <a:tcTxStyle>
-        <a:fontRef idx="minor">
-          <a:scrgbClr b="0" g="0" r="0"/>
-        </a:fontRef>
-        <a:schemeClr val="tx1"/>
-      </a:tcTxStyle>
-      <a:tcStyle>
-        <a:tcBdr>
-          <a:left>
-            <a:ln cmpd="sng" w="12700">
-              <a:solidFill>
-                <a:schemeClr val="tx1"/>
-              </a:solidFill>
-            </a:ln>
-          </a:left>
-          <a:right>
-            <a:ln cmpd="sng" w="12700">
-              <a:solidFill>
-                <a:schemeClr val="tx1"/>
-              </a:solidFill>
-            </a:ln>
-          </a:right>
-          <a:top>
-            <a:ln cmpd="sng" w="12700">
-              <a:solidFill>
-                <a:schemeClr val="tx1"/>
-              </a:solidFill>
-            </a:ln>
-          </a:top>
-          <a:bottom>
-            <a:ln cmpd="sng" w="12700">
-              <a:solidFill>
-                <a:schemeClr val="tx1"/>
-              </a:solidFill>
-            </a:ln>
-          </a:bottom>
-          <a:insideH>
-            <a:ln cmpd="sng" w="12700">
-              <a:solidFill>
-                <a:schemeClr val="tx1"/>
-              </a:solidFill>
-            </a:ln>
-          </a:insideH>
-          <a:insideV>
-            <a:ln cmpd="sng" w="12700">
-              <a:solidFill>
-                <a:schemeClr val="tx1"/>
-              </a:solidFill>
-            </a:ln>
-          </a:insideV>
-        </a:tcBdr>
-        <a:fill>
-          <a:noFill/>
-        </a:fill>
-      </a:tcStyle>
-    </a:wholeTbl>
-  </a:tblStyle>
-</a:tblStyleLst>
-</file>
-
-<file path=ppt/viewProps1.xml><?xml version="1.0" encoding="utf-8"?>
-<p:viewPr xmlns:a="http://schemas.openxmlformats.org/drawingml/2006/main" xmlns:r="http://schemas.openxmlformats.org/officeDocument/2006/relationships" xmlns:mc="http://schemas.openxmlformats.org/markup-compatibility/2006" xmlns:mv="urn:schemas-microsoft-com:mac:vml" xmlns:p="http://schemas.openxmlformats.org/presentationml/2006/main" xmlns:c="http://schemas.openxmlformats.org/drawingml/2006/chart" xmlns:dgm="http://schemas.openxmlformats.org/drawingml/2006/diagram" xmlns:o="urn:schemas-microsoft-com:office:office" xmlns:v="urn:schemas-microsoft-com:vml" xmlns:pvml="urn:schemas-microsoft-com:office:powerpoint" xmlns:com="http://schemas.openxmlformats.org/drawingml/2006/compatibility" xmlns:p14="http://schemas.microsoft.com/office/powerpoint/2010/main" xmlns:p15="http://schemas.microsoft.com/office/powerpoint/2012/main" xmlns:ahyp="http://schemas.microsoft.com/office/drawing/2018/hyperlinkcolor" showComments="0">
-  <p:slideViewPr>
-    <p:cSldViewPr snapToGrid="0">
-      <p:cViewPr varScale="1">
-        <p:scale>
-          <a:sx n="100" d="100"/>
-          <a:sy n="100" d="100"/>
-        </p:scale>
-        <p:origin x="0" y="0"/>
-      </p:cViewPr>
-      <p:guideLst>
-        <p:guide pos="2160" orient="horz"/>
-        <p:guide pos="2880"/>
-      </p:guideLst>
-    </p:cSldViewPr>
-  </p:slideViewPr>
-</p:viewPr>
 </file>
 
 <file path=ppt/notesMasters/notesMaster1.xml><?xml version="1.0" encoding="utf-8"?>
@@ -308,7 +220,7 @@
             <a:fld id="{71B727E3-9991-4B0C-8167-23E35F3043C3}" type="datetimeFigureOut">
               <a:rPr lang="en-US" smtClean="0"/>
               <a:pPr/>
-              <a:t>8/8/2026</a:t>
+              <a:t>8/25/2026</a:t>
             </a:fld>
             <a:endParaRPr lang="en-US"/>
           </a:p>
@@ -708,7 +620,7 @@
             <a:fld id="{6C6A3A6F-B049-4A3C-A314-6C5DC6ABA413}" type="datetime1">
               <a:rPr lang="en-US" smtClean="0"/>
               <a:pPr/>
-              <a:t>8/8/2026</a:t>
+              <a:t>8/25/2026</a:t>
             </a:fld>
             <a:endParaRPr lang="en-US"/>
           </a:p>
@@ -880,7 +792,7 @@
             <a:fld id="{BE0F1400-0AF8-4881-9500-1BCE077EF02C}" type="datetime1">
               <a:rPr lang="en-US" smtClean="0"/>
               <a:pPr/>
-              <a:t>8/8/2026</a:t>
+              <a:t>8/25/2026</a:t>
             </a:fld>
             <a:endParaRPr lang="en-US"/>
           </a:p>
@@ -1062,7 +974,7 @@
             <a:fld id="{5B520AC9-8025-43C3-9D7A-B30453D05E68}" type="datetime1">
               <a:rPr lang="en-US" smtClean="0"/>
               <a:pPr/>
-              <a:t>8/8/2026</a:t>
+              <a:t>8/25/2026</a:t>
             </a:fld>
             <a:endParaRPr lang="en-US"/>
           </a:p>
@@ -1234,7 +1146,7 @@
             <a:fld id="{880A0579-E4EA-4069-8E9E-A5661942CE83}" type="datetime1">
               <a:rPr lang="en-US" smtClean="0"/>
               <a:pPr/>
-              <a:t>8/8/2026</a:t>
+              <a:t>8/25/2026</a:t>
             </a:fld>
             <a:endParaRPr lang="en-US"/>
           </a:p>
@@ -1480,7 +1392,7 @@
             <a:fld id="{DCBAC4A0-A0AB-494A-9349-6940CE23F0BB}" type="datetime1">
               <a:rPr lang="en-US" smtClean="0"/>
               <a:pPr/>
-              <a:t>8/8/2026</a:t>
+              <a:t>8/25/2026</a:t>
             </a:fld>
             <a:endParaRPr lang="en-US"/>
           </a:p>
@@ -1714,7 +1626,7 @@
             <a:fld id="{8409F13F-E3C0-47E7-81E7-2D67CDFD97CE}" type="datetime1">
               <a:rPr lang="en-US" smtClean="0"/>
               <a:pPr/>
-              <a:t>8/8/2026</a:t>
+              <a:t>8/25/2026</a:t>
             </a:fld>
             <a:endParaRPr lang="en-US"/>
           </a:p>
@@ -2083,7 +1995,7 @@
             <a:fld id="{E2CB4F48-C21C-4E8E-AA43-BB8E3BD2F306}" type="datetime1">
               <a:rPr lang="en-US" smtClean="0"/>
               <a:pPr/>
-              <a:t>8/8/2026</a:t>
+              <a:t>8/25/2026</a:t>
             </a:fld>
             <a:endParaRPr lang="en-US"/>
           </a:p>
@@ -2203,7 +2115,7 @@
             <a:fld id="{9990D7BC-B940-4993-A11F-8FBB77BA204E}" type="datetime1">
               <a:rPr lang="en-US" smtClean="0"/>
               <a:pPr/>
-              <a:t>8/8/2026</a:t>
+              <a:t>8/25/2026</a:t>
             </a:fld>
             <a:endParaRPr lang="en-US"/>
           </a:p>
@@ -2300,7 +2212,7 @@
             <a:fld id="{F6094854-92A4-4BB6-9F1F-69BBC71788FF}" type="datetime1">
               <a:rPr lang="en-US" smtClean="0"/>
               <a:pPr/>
-              <a:t>8/8/2026</a:t>
+              <a:t>8/25/2026</a:t>
             </a:fld>
             <a:endParaRPr lang="en-US"/>
           </a:p>
@@ -2579,7 +2491,7 @@
             <a:fld id="{8CC6CBDC-D391-4FA9-8D6F-9BC119CA0B97}" type="datetime1">
               <a:rPr lang="en-US" smtClean="0"/>
               <a:pPr/>
-              <a:t>8/8/2026</a:t>
+              <a:t>8/25/2026</a:t>
             </a:fld>
             <a:endParaRPr lang="en-US"/>
           </a:p>
@@ -2838,7 +2750,7 @@
             <a:fld id="{129F212E-DE5B-4D49-B277-6F5AF26D6AF0}" type="datetime1">
               <a:rPr lang="en-US" smtClean="0"/>
               <a:pPr/>
-              <a:t>8/8/2026</a:t>
+              <a:t>8/25/2026</a:t>
             </a:fld>
             <a:endParaRPr lang="en-US"/>
           </a:p>
@@ -3053,7 +2965,7 @@
             <a:fld id="{505C9A0F-356B-4543-BBC4-6729314C25D3}" type="datetime1">
               <a:rPr lang="en-US" smtClean="0"/>
               <a:pPr/>
-              <a:t>8/8/2026</a:t>
+              <a:t>8/25/2026</a:t>
             </a:fld>
             <a:endParaRPr lang="en-US"/>
           </a:p>
@@ -3845,8 +3757,8 @@
         </p:nvSpPr>
         <p:spPr>
           <a:xfrm>
-            <a:off x="685800" y="3293700"/>
-            <a:ext cx="7772400" cy="791278"/>
+            <a:off x="685800" y="3026573"/>
+            <a:ext cx="7772400" cy="1058405"/>
           </a:xfrm>
           <a:prstGeom prst="rect">
             <a:avLst/>
@@ -3856,6 +3768,7 @@
           <a:bodyPr vert="horz" lIns="91440" tIns="45720" rIns="91440" bIns="45720" rtlCol="0" anchor="b">
             <a:noAutofit/>
           </a:bodyPr>
+          <a:lstStyle/>
           <a:p>
             <a:pPr marL="0" lvl="0" indent="0" algn="ctr">
               <a:spcAft>
@@ -3870,16 +3783,7 @@
                 </a:solidFill>
                 <a:latin typeface="Calisto MT" panose="02040603050505030304" pitchFamily="18" charset="0"/>
               </a:rPr>
-              <a:t xml:space="preserve">23CS7552: B. Tech Mini Project </a:t>
-            </a:r>
-            <a:r>
-              <a:rPr lang="en-US" sz="2000" b="1" dirty="0">
-                <a:solidFill>
-                  <a:srgbClr val="252525"/>
-                </a:solidFill>
-                <a:latin typeface="Calisto MT" panose="02040603050505030304" pitchFamily="18" charset="0"/>
-              </a:rPr>
-              <a:t>(0</a:t>
+              <a:t>23CS7552: B. Tech Mini Project (0</a:t>
             </a:r>
             <a:r>
               <a:rPr lang="en-US" sz="2000" b="1" baseline="30000" dirty="0">
@@ -3928,8 +3832,23 @@
                 </a:solidFill>
                 <a:latin typeface="Calisto MT" panose="02040603050505030304" pitchFamily="18" charset="0"/>
               </a:rPr>
-              <a:t>Batch No: __</a:t>
-            </a:r>
+              <a:t>Batch No: </a:t>
+            </a:r>
+            <a:r>
+              <a:rPr lang="en-US" b="1" dirty="0">
+                <a:solidFill>
+                  <a:srgbClr val="252525"/>
+                </a:solidFill>
+                <a:latin typeface="Calisto MT" panose="02040603050505030304" pitchFamily="18" charset="0"/>
+              </a:rPr>
+              <a:t>19</a:t>
+            </a:r>
+            <a:endParaRPr lang="en-US" sz="1800" b="1" dirty="0">
+              <a:solidFill>
+                <a:srgbClr val="252525"/>
+              </a:solidFill>
+              <a:latin typeface="Calisto MT" panose="02040603050505030304" pitchFamily="18" charset="0"/>
+            </a:endParaRPr>
           </a:p>
         </p:txBody>
       </p:sp>
@@ -4168,7 +4087,7 @@
                 </a:solidFill>
                 <a:latin typeface="Calisto MT" panose="02040603050505030304" pitchFamily="18" charset="0"/>
               </a:rPr>
-              <a:t>6. Objectives</a:t>
+              <a:t>7. Scope</a:t>
             </a:r>
           </a:p>
         </p:txBody>
@@ -4191,8 +4110,8 @@
         </p:nvSpPr>
         <p:spPr>
           <a:xfrm>
-            <a:off x="358218" y="867265"/>
-            <a:ext cx="8314441" cy="5870705"/>
+            <a:off x="358218" y="1018094"/>
+            <a:ext cx="8314441" cy="5338257"/>
           </a:xfrm>
         </p:spPr>
         <p:txBody>
@@ -4203,7 +4122,7 @@
           <a:p>
             <a:pPr marL="457200" lvl="0" indent="-457200" algn="just">
               <a:spcAft>
-                <a:spcPts val="800"/>
+                <a:spcPts val="900"/>
               </a:spcAft>
               <a:buFont typeface="+mj-lt"/>
               <a:buAutoNum type="arabicPeriod"/>
@@ -4215,13 +4134,13 @@
                 </a:solidFill>
                 <a:latin typeface="Calisto MT" panose="02040603050505030304" pitchFamily="18" charset="0"/>
               </a:rPr>
-              <a:t>To construct a paired sequence + Hi-C pilot dataset (GM12878, chr9, GRCh38) with an 8-feature per-bin structural vector validated against independent 4D Nucleome tracks (target r &gt; 0.95).</a:t>
+              <a:t>The pilot is restricted to one chromosome of one cell line of one species human GM12878, chr9, 5 kb Hi-C resolution; every claim inherits this limitation and is stated accordingly.</a:t>
             </a:r>
           </a:p>
           <a:p>
             <a:pPr marL="457200" lvl="0" indent="-457200" algn="just">
               <a:spcAft>
-                <a:spcPts val="800"/>
+                <a:spcPts val="900"/>
               </a:spcAft>
               <a:buFont typeface="+mj-lt"/>
               <a:buAutoNum type="arabicPeriod"/>
@@ -4233,25 +4152,7 @@
                 </a:solidFill>
                 <a:latin typeface="Calisto MT" panose="02040603050505030304" pitchFamily="18" charset="0"/>
               </a:rPr>
-              <a:t>To design and implement a structural-bias mechanism inside a bidirectional Mamba recurrence, matching the sequence-only baseline’s parameter count within 5% (achieved: +0.43%).</a:t>
-            </a:r>
-          </a:p>
-          <a:p>
-            <a:pPr marL="457200" lvl="0" indent="-457200" algn="just">
-              <a:spcAft>
-                <a:spcPts val="800"/>
-              </a:spcAft>
-              <a:buFont typeface="+mj-lt"/>
-              <a:buAutoNum type="arabicPeriod"/>
-            </a:pPr>
-            <a:r>
-              <a:rPr lang="en-US" sz="1800" dirty="0">
-                <a:solidFill>
-                  <a:srgbClr val="252525"/>
-                </a:solidFill>
-                <a:latin typeface="Calisto MT" panose="02040603050505030304" pitchFamily="18" charset="0"/>
-              </a:rPr>
-              <a:t>To pretrain and compare four matched arms — sequence-only, CHROME-style post-hoc, Evo2HiC-style distillation, and the proposed model — with at least 3 seeds per configuration.</a:t>
+              <a:t>Model scale is bounded by the available compute (2× NVIDIA L40S, 96 GB total): a ~7.7 M-parameter backbone on 32,768-bp windows — the small-model regime, not a 7B-scale reproduction.</a:t>
             </a:r>
           </a:p>
           <a:p>
@@ -4266,7 +4167,7 @@
                 </a:solidFill>
                 <a:latin typeface="Calisto MT" panose="02040603050505030304" pitchFamily="18" charset="0"/>
               </a:rPr>
-              <a:t>To verify via shuffled-structure controls (S0–S3) that any gain derives from genuine 3D structure, and to evaluate transfer on DNALongBench-style regulatory and variant tasks.</a:t>
+              <a:t>Evaluation covers masked-token loss plus selected regulatory/variant transfer tasks; cross-species modeling (DNA Zoo) and genome-wide scaling are explicitly out of scope for this phase.</a:t>
             </a:r>
           </a:p>
         </p:txBody>
@@ -4314,7 +4215,7 @@
     </p:spTree>
     <p:extLst>
       <p:ext uri="{BB962C8B-B14F-4D97-AF65-F5344CB8AC3E}">
-        <p14:creationId xmlns:p14="http://schemas.microsoft.com/office/powerpoint/2010/main" val="441088729"/>
+        <p14:creationId xmlns:p14="http://schemas.microsoft.com/office/powerpoint/2010/main" val="2834744801"/>
       </p:ext>
     </p:extLst>
   </p:cSld>
@@ -4359,18 +4260,18 @@
         </p:nvSpPr>
         <p:spPr>
           <a:xfrm>
-            <a:off x="202676" y="120029"/>
-            <a:ext cx="8738648" cy="747237"/>
+            <a:off x="509047" y="270858"/>
+            <a:ext cx="8006303" cy="549273"/>
           </a:xfrm>
         </p:spPr>
         <p:txBody>
           <a:bodyPr>
-            <a:noAutofit/>
+            <a:normAutofit fontScale="90000"/>
           </a:bodyPr>
           <a:lstStyle/>
           <a:p>
             <a:r>
-              <a:rPr lang="en-US" sz="3000" b="1" dirty="0">
+              <a:rPr lang="en-US" sz="4000" b="1" dirty="0">
                 <a:solidFill>
                   <a:schemeClr val="accent2">
                     <a:lumMod val="50000"/>
@@ -4378,7 +4279,7 @@
                 </a:solidFill>
                 <a:latin typeface="Calisto MT" panose="02040603050505030304" pitchFamily="18" charset="0"/>
               </a:rPr>
-              <a:t>7. Scope</a:t>
+              <a:t>8. Timeline Chart</a:t>
             </a:r>
           </a:p>
         </p:txBody>
@@ -4401,8 +4302,8 @@
         </p:nvSpPr>
         <p:spPr>
           <a:xfrm>
-            <a:off x="358218" y="1018094"/>
-            <a:ext cx="8314441" cy="5338257"/>
+            <a:off x="292232" y="950000"/>
+            <a:ext cx="8564253" cy="400000"/>
           </a:xfrm>
         </p:spPr>
         <p:txBody>
@@ -4411,54 +4312,17 @@
           </a:bodyPr>
           <a:lstStyle/>
           <a:p>
-            <a:pPr marL="457200" lvl="0" indent="-457200" algn="just">
-              <a:spcAft>
-                <a:spcPts val="900"/>
-              </a:spcAft>
-              <a:buFont typeface="+mj-lt"/>
-              <a:buAutoNum type="arabicPeriod"/>
+            <a:pPr marL="0" lvl="0" indent="0" algn="ctr">
+              <a:buNone/>
             </a:pPr>
             <a:r>
-              <a:rPr lang="en-US" sz="1800" dirty="0">
-                <a:solidFill>
-                  <a:srgbClr val="252525"/>
-                </a:solidFill>
-                <a:latin typeface="Calisto MT" panose="02040603050505030304" pitchFamily="18" charset="0"/>
-              </a:rPr>
-              <a:t>The pilot is restricted to one chromosome of one cell line of one species — human GM12878, chr9, 5 kb Hi-C resolution; every claim inherits this limitation and is stated accordingly.</a:t>
-            </a:r>
-          </a:p>
-          <a:p>
-            <a:pPr marL="457200" lvl="0" indent="-457200" algn="just">
-              <a:spcAft>
-                <a:spcPts val="900"/>
-              </a:spcAft>
-              <a:buFont typeface="+mj-lt"/>
-              <a:buAutoNum type="arabicPeriod"/>
-            </a:pPr>
-            <a:r>
-              <a:rPr lang="en-US" sz="1800" dirty="0">
-                <a:solidFill>
-                  <a:srgbClr val="252525"/>
-                </a:solidFill>
-                <a:latin typeface="Calisto MT" panose="02040603050505030304" pitchFamily="18" charset="0"/>
-              </a:rPr>
-              <a:t>Model scale is bounded by the available compute (2× NVIDIA L40S, 96 GB total): a ~7.7 M-parameter backbone on 32,768-bp windows — the small-model regime, not a 7B-scale reproduction.</a:t>
-            </a:r>
-          </a:p>
-          <a:p>
-            <a:pPr marL="457200" lvl="0" indent="-457200" algn="just">
-              <a:buFont typeface="+mj-lt"/>
-              <a:buAutoNum type="arabicPeriod"/>
-            </a:pPr>
-            <a:r>
-              <a:rPr lang="en-US" sz="1800" dirty="0">
-                <a:solidFill>
-                  <a:srgbClr val="252525"/>
-                </a:solidFill>
-                <a:latin typeface="Calisto MT" panose="02040603050505030304" pitchFamily="18" charset="0"/>
-              </a:rPr>
-              <a:t>Evaluation covers masked-token loss plus selected regulatory/variant transfer tasks; cross-species modeling (DNA Zoo) and genome-wide scaling are explicitly out of scope for this phase.</a:t>
+              <a:rPr lang="en-US" sz="1400" b="1" dirty="0">
+                <a:solidFill>
+                  <a:srgbClr val="252525"/>
+                </a:solidFill>
+                <a:latin typeface="Calisto MT" panose="02040603050505030304" pitchFamily="18" charset="0"/>
+              </a:rPr>
+              <a:t>Table 1. Timeline chart for the Mini Project work (August – November 2026)</a:t>
             </a:r>
           </a:p>
         </p:txBody>
@@ -4493,161 +4357,6 @@
               </a:rPr>
               <a:pPr/>
               <a:t>11</a:t>
-            </a:fld>
-            <a:endParaRPr lang="en-US" sz="1400" b="1" dirty="0">
-              <a:solidFill>
-                <a:schemeClr val="tx1"/>
-              </a:solidFill>
-              <a:latin typeface="Calisto MT" panose="02040603050505030304" pitchFamily="18" charset="0"/>
-            </a:endParaRPr>
-          </a:p>
-        </p:txBody>
-      </p:sp>
-    </p:spTree>
-    <p:extLst>
-      <p:ext uri="{BB962C8B-B14F-4D97-AF65-F5344CB8AC3E}">
-        <p14:creationId xmlns:p14="http://schemas.microsoft.com/office/powerpoint/2010/main" val="2834744801"/>
-      </p:ext>
-    </p:extLst>
-  </p:cSld>
-  <p:clrMapOvr>
-    <a:masterClrMapping/>
-  </p:clrMapOvr>
-</p:sld>
-</file>
-
-<file path=ppt/slides/slide12.xml><?xml version="1.0" encoding="utf-8"?>
-<p:sld xmlns:a="http://schemas.openxmlformats.org/drawingml/2006/main" xmlns:r="http://schemas.openxmlformats.org/officeDocument/2006/relationships" xmlns:p="http://schemas.openxmlformats.org/presentationml/2006/main">
-  <p:cSld>
-    <p:spTree>
-      <p:nvGrpSpPr>
-        <p:cNvPr id="1" name=""/>
-        <p:cNvGrpSpPr/>
-        <p:nvPr/>
-      </p:nvGrpSpPr>
-      <p:grpSpPr>
-        <a:xfrm>
-          <a:off x="0" y="0"/>
-          <a:ext cx="0" cy="0"/>
-          <a:chOff x="0" y="0"/>
-          <a:chExt cx="0" cy="0"/>
-        </a:xfrm>
-      </p:grpSpPr>
-      <p:sp>
-        <p:nvSpPr>
-          <p:cNvPr id="2" name="Title 1">
-            <a:extLst>
-              <a:ext uri="{FF2B5EF4-FFF2-40B4-BE49-F238E27FC236}">
-                <a16:creationId xmlns:a16="http://schemas.microsoft.com/office/drawing/2014/main" id="{5B738971-B764-E045-F92B-01E3322A0123}"/>
-              </a:ext>
-            </a:extLst>
-          </p:cNvPr>
-          <p:cNvSpPr>
-            <a:spLocks noGrp="1"/>
-          </p:cNvSpPr>
-          <p:nvPr>
-            <p:ph type="title"/>
-          </p:nvPr>
-        </p:nvSpPr>
-        <p:spPr>
-          <a:xfrm>
-            <a:off x="509047" y="270858"/>
-            <a:ext cx="8006303" cy="549273"/>
-          </a:xfrm>
-        </p:spPr>
-        <p:txBody>
-          <a:bodyPr>
-            <a:normAutofit fontScale="90000"/>
-          </a:bodyPr>
-          <a:lstStyle/>
-          <a:p>
-            <a:r>
-              <a:rPr lang="en-US" sz="4000" b="1" dirty="0">
-                <a:solidFill>
-                  <a:schemeClr val="accent2">
-                    <a:lumMod val="50000"/>
-                  </a:schemeClr>
-                </a:solidFill>
-                <a:latin typeface="Calisto MT" panose="02040603050505030304" pitchFamily="18" charset="0"/>
-              </a:rPr>
-              <a:t>8. Timeline Chart</a:t>
-            </a:r>
-          </a:p>
-        </p:txBody>
-      </p:sp>
-      <p:sp>
-        <p:nvSpPr>
-          <p:cNvPr id="3" name="Content Placeholder 2">
-            <a:extLst>
-              <a:ext uri="{FF2B5EF4-FFF2-40B4-BE49-F238E27FC236}">
-                <a16:creationId xmlns:a16="http://schemas.microsoft.com/office/drawing/2014/main" id="{E5D502BE-F636-7D1D-85F0-BAFFD3E05E1C}"/>
-              </a:ext>
-            </a:extLst>
-          </p:cNvPr>
-          <p:cNvSpPr>
-            <a:spLocks noGrp="1"/>
-          </p:cNvSpPr>
-          <p:nvPr>
-            <p:ph idx="1"/>
-          </p:nvPr>
-        </p:nvSpPr>
-        <p:spPr>
-          <a:xfrm>
-            <a:off x="292232" y="950000"/>
-            <a:ext cx="8564253" cy="400000"/>
-          </a:xfrm>
-        </p:spPr>
-        <p:txBody>
-          <a:bodyPr numCol="1">
-            <a:normAutofit fontScale="92500" lnSpcReduction="20000"/>
-          </a:bodyPr>
-          <a:lstStyle/>
-          <a:p>
-            <a:pPr marL="0" lvl="0" indent="0" algn="ctr">
-              <a:buNone/>
-            </a:pPr>
-            <a:r>
-              <a:rPr lang="en-US" sz="1400" b="1" dirty="0">
-                <a:solidFill>
-                  <a:srgbClr val="252525"/>
-                </a:solidFill>
-                <a:latin typeface="Calisto MT" panose="02040603050505030304" pitchFamily="18" charset="0"/>
-              </a:rPr>
-              <a:t>Table 1. Timeline chart for the Mini Project work (August – November 2026)</a:t>
-            </a:r>
-          </a:p>
-        </p:txBody>
-      </p:sp>
-      <p:sp>
-        <p:nvSpPr>
-          <p:cNvPr id="7" name="Slide Number Placeholder 6">
-            <a:extLst>
-              <a:ext uri="{FF2B5EF4-FFF2-40B4-BE49-F238E27FC236}">
-                <a16:creationId xmlns:a16="http://schemas.microsoft.com/office/drawing/2014/main" id="{14F45621-8939-04E9-03B4-11AF180D5862}"/>
-              </a:ext>
-            </a:extLst>
-          </p:cNvPr>
-          <p:cNvSpPr>
-            <a:spLocks noGrp="1"/>
-          </p:cNvSpPr>
-          <p:nvPr>
-            <p:ph type="sldNum" sz="quarter" idx="12"/>
-          </p:nvPr>
-        </p:nvSpPr>
-        <p:spPr/>
-        <p:txBody>
-          <a:bodyPr/>
-          <a:lstStyle/>
-          <a:p>
-            <a:fld id="{D90542D4-23E8-43E0-BA8E-C972DA1A005D}" type="slidenum">
-              <a:rPr lang="en-US" sz="1400" b="1" smtClean="0">
-                <a:solidFill>
-                  <a:schemeClr val="tx1"/>
-                </a:solidFill>
-                <a:latin typeface="Calisto MT" panose="02040603050505030304" pitchFamily="18" charset="0"/>
-              </a:rPr>
-              <a:pPr/>
-              <a:t>12</a:t>
             </a:fld>
             <a:endParaRPr lang="en-US" sz="1400" b="1" dirty="0">
               <a:solidFill>
@@ -4677,12 +4386,48 @@
                 <a:tableStyleId>{5940675A-B579-460E-94D1-54222C63F5DA}</a:tableStyleId>
               </a:tblPr>
               <a:tblGrid>
-                <a:gridCol w="560000"/>
-                <a:gridCol w="3340000"/>
-                <a:gridCol w="830000"/>
-                <a:gridCol w="830000"/>
-                <a:gridCol w="830000"/>
-                <a:gridCol w="830000"/>
+                <a:gridCol w="560000">
+                  <a:extLst>
+                    <a:ext uri="{9D8B030D-6E8A-4147-A177-3AD203B41FA5}">
+                      <a16:colId xmlns:a16="http://schemas.microsoft.com/office/drawing/2014/main" val="20000"/>
+                    </a:ext>
+                  </a:extLst>
+                </a:gridCol>
+                <a:gridCol w="3340000">
+                  <a:extLst>
+                    <a:ext uri="{9D8B030D-6E8A-4147-A177-3AD203B41FA5}">
+                      <a16:colId xmlns:a16="http://schemas.microsoft.com/office/drawing/2014/main" val="20001"/>
+                    </a:ext>
+                  </a:extLst>
+                </a:gridCol>
+                <a:gridCol w="830000">
+                  <a:extLst>
+                    <a:ext uri="{9D8B030D-6E8A-4147-A177-3AD203B41FA5}">
+                      <a16:colId xmlns:a16="http://schemas.microsoft.com/office/drawing/2014/main" val="20002"/>
+                    </a:ext>
+                  </a:extLst>
+                </a:gridCol>
+                <a:gridCol w="830000">
+                  <a:extLst>
+                    <a:ext uri="{9D8B030D-6E8A-4147-A177-3AD203B41FA5}">
+                      <a16:colId xmlns:a16="http://schemas.microsoft.com/office/drawing/2014/main" val="20003"/>
+                    </a:ext>
+                  </a:extLst>
+                </a:gridCol>
+                <a:gridCol w="830000">
+                  <a:extLst>
+                    <a:ext uri="{9D8B030D-6E8A-4147-A177-3AD203B41FA5}">
+                      <a16:colId xmlns:a16="http://schemas.microsoft.com/office/drawing/2014/main" val="20004"/>
+                    </a:ext>
+                  </a:extLst>
+                </a:gridCol>
+                <a:gridCol w="830000">
+                  <a:extLst>
+                    <a:ext uri="{9D8B030D-6E8A-4147-A177-3AD203B41FA5}">
+                      <a16:colId xmlns:a16="http://schemas.microsoft.com/office/drawing/2014/main" val="20005"/>
+                    </a:ext>
+                  </a:extLst>
+                </a:gridCol>
               </a:tblGrid>
               <a:tr h="430000">
                 <a:tc>
@@ -4823,6 +4568,11 @@
                   </a:txBody>
                   <a:tcPr marL="36576" marR="36576" marT="18288" marB="18288" anchor="ctr"/>
                 </a:tc>
+                <a:extLst>
+                  <a:ext uri="{0D108BD9-81ED-4DB2-BD59-A6C34878D82A}">
+                    <a16:rowId xmlns:a16="http://schemas.microsoft.com/office/drawing/2014/main" val="10000"/>
+                  </a:ext>
+                </a:extLst>
               </a:tr>
               <a:tr h="430000">
                 <a:tc>
@@ -4888,7 +4638,7 @@
                           </a:solidFill>
                           <a:latin typeface="Calisto MT" panose="02040603050505030304" pitchFamily="18" charset="0"/>
                         </a:rPr>
-                        <a:t xml:space="preserve"> </a:t>
+                        <a:t> </a:t>
                       </a:r>
                     </a:p>
                   </a:txBody>
@@ -4915,7 +4665,7 @@
                           </a:solidFill>
                           <a:latin typeface="Calisto MT" panose="02040603050505030304" pitchFamily="18" charset="0"/>
                         </a:rPr>
-                        <a:t xml:space="preserve"> </a:t>
+                        <a:t> </a:t>
                       </a:r>
                     </a:p>
                   </a:txBody>
@@ -4938,7 +4688,7 @@
                           </a:solidFill>
                           <a:latin typeface="Calisto MT" panose="02040603050505030304" pitchFamily="18" charset="0"/>
                         </a:rPr>
-                        <a:t xml:space="preserve"> </a:t>
+                        <a:t> </a:t>
                       </a:r>
                     </a:p>
                   </a:txBody>
@@ -4961,12 +4711,17 @@
                           </a:solidFill>
                           <a:latin typeface="Calisto MT" panose="02040603050505030304" pitchFamily="18" charset="0"/>
                         </a:rPr>
-                        <a:t xml:space="preserve"> </a:t>
+                        <a:t> </a:t>
                       </a:r>
                     </a:p>
                   </a:txBody>
                   <a:tcPr marL="36576" marR="36576" marT="18288" marB="18288" anchor="ctr"/>
                 </a:tc>
+                <a:extLst>
+                  <a:ext uri="{0D108BD9-81ED-4DB2-BD59-A6C34878D82A}">
+                    <a16:rowId xmlns:a16="http://schemas.microsoft.com/office/drawing/2014/main" val="10001"/>
+                  </a:ext>
+                </a:extLst>
               </a:tr>
               <a:tr h="430000">
                 <a:tc>
@@ -5032,7 +4787,7 @@
                           </a:solidFill>
                           <a:latin typeface="Calisto MT" panose="02040603050505030304" pitchFamily="18" charset="0"/>
                         </a:rPr>
-                        <a:t xml:space="preserve"> </a:t>
+                        <a:t> </a:t>
                       </a:r>
                     </a:p>
                   </a:txBody>
@@ -5059,7 +4814,7 @@
                           </a:solidFill>
                           <a:latin typeface="Calisto MT" panose="02040603050505030304" pitchFamily="18" charset="0"/>
                         </a:rPr>
-                        <a:t xml:space="preserve"> </a:t>
+                        <a:t> </a:t>
                       </a:r>
                     </a:p>
                   </a:txBody>
@@ -5082,7 +4837,7 @@
                           </a:solidFill>
                           <a:latin typeface="Calisto MT" panose="02040603050505030304" pitchFamily="18" charset="0"/>
                         </a:rPr>
-                        <a:t xml:space="preserve"> </a:t>
+                        <a:t> </a:t>
                       </a:r>
                     </a:p>
                   </a:txBody>
@@ -5105,12 +4860,17 @@
                           </a:solidFill>
                           <a:latin typeface="Calisto MT" panose="02040603050505030304" pitchFamily="18" charset="0"/>
                         </a:rPr>
-                        <a:t xml:space="preserve"> </a:t>
+                        <a:t> </a:t>
                       </a:r>
                     </a:p>
                   </a:txBody>
                   <a:tcPr marL="36576" marR="36576" marT="18288" marB="18288" anchor="ctr"/>
                 </a:tc>
+                <a:extLst>
+                  <a:ext uri="{0D108BD9-81ED-4DB2-BD59-A6C34878D82A}">
+                    <a16:rowId xmlns:a16="http://schemas.microsoft.com/office/drawing/2014/main" val="10002"/>
+                  </a:ext>
+                </a:extLst>
               </a:tr>
               <a:tr h="430000">
                 <a:tc>
@@ -5176,7 +4936,7 @@
                           </a:solidFill>
                           <a:latin typeface="Calisto MT" panose="02040603050505030304" pitchFamily="18" charset="0"/>
                         </a:rPr>
-                        <a:t xml:space="preserve"> </a:t>
+                        <a:t> </a:t>
                       </a:r>
                     </a:p>
                   </a:txBody>
@@ -5203,7 +4963,7 @@
                           </a:solidFill>
                           <a:latin typeface="Calisto MT" panose="02040603050505030304" pitchFamily="18" charset="0"/>
                         </a:rPr>
-                        <a:t xml:space="preserve"> </a:t>
+                        <a:t> </a:t>
                       </a:r>
                     </a:p>
                   </a:txBody>
@@ -5230,7 +4990,7 @@
                           </a:solidFill>
                           <a:latin typeface="Calisto MT" panose="02040603050505030304" pitchFamily="18" charset="0"/>
                         </a:rPr>
-                        <a:t xml:space="preserve"> </a:t>
+                        <a:t> </a:t>
                       </a:r>
                     </a:p>
                   </a:txBody>
@@ -5253,12 +5013,17 @@
                           </a:solidFill>
                           <a:latin typeface="Calisto MT" panose="02040603050505030304" pitchFamily="18" charset="0"/>
                         </a:rPr>
-                        <a:t xml:space="preserve"> </a:t>
+                        <a:t> </a:t>
                       </a:r>
                     </a:p>
                   </a:txBody>
                   <a:tcPr marL="36576" marR="36576" marT="18288" marB="18288" anchor="ctr"/>
                 </a:tc>
+                <a:extLst>
+                  <a:ext uri="{0D108BD9-81ED-4DB2-BD59-A6C34878D82A}">
+                    <a16:rowId xmlns:a16="http://schemas.microsoft.com/office/drawing/2014/main" val="10003"/>
+                  </a:ext>
+                </a:extLst>
               </a:tr>
               <a:tr h="430000">
                 <a:tc>
@@ -5324,7 +5089,7 @@
                           </a:solidFill>
                           <a:latin typeface="Calisto MT" panose="02040603050505030304" pitchFamily="18" charset="0"/>
                         </a:rPr>
-                        <a:t xml:space="preserve"> </a:t>
+                        <a:t> </a:t>
                       </a:r>
                     </a:p>
                   </a:txBody>
@@ -5347,7 +5112,7 @@
                           </a:solidFill>
                           <a:latin typeface="Calisto MT" panose="02040603050505030304" pitchFamily="18" charset="0"/>
                         </a:rPr>
-                        <a:t xml:space="preserve"> </a:t>
+                        <a:t> </a:t>
                       </a:r>
                     </a:p>
                   </a:txBody>
@@ -5374,7 +5139,7 @@
                           </a:solidFill>
                           <a:latin typeface="Calisto MT" panose="02040603050505030304" pitchFamily="18" charset="0"/>
                         </a:rPr>
-                        <a:t xml:space="preserve"> </a:t>
+                        <a:t> </a:t>
                       </a:r>
                     </a:p>
                   </a:txBody>
@@ -5397,12 +5162,17 @@
                           </a:solidFill>
                           <a:latin typeface="Calisto MT" panose="02040603050505030304" pitchFamily="18" charset="0"/>
                         </a:rPr>
-                        <a:t xml:space="preserve"> </a:t>
+                        <a:t> </a:t>
                       </a:r>
                     </a:p>
                   </a:txBody>
                   <a:tcPr marL="36576" marR="36576" marT="18288" marB="18288" anchor="ctr"/>
                 </a:tc>
+                <a:extLst>
+                  <a:ext uri="{0D108BD9-81ED-4DB2-BD59-A6C34878D82A}">
+                    <a16:rowId xmlns:a16="http://schemas.microsoft.com/office/drawing/2014/main" val="10004"/>
+                  </a:ext>
+                </a:extLst>
               </a:tr>
               <a:tr h="430000">
                 <a:tc>
@@ -5468,7 +5238,7 @@
                           </a:solidFill>
                           <a:latin typeface="Calisto MT" panose="02040603050505030304" pitchFamily="18" charset="0"/>
                         </a:rPr>
-                        <a:t xml:space="preserve"> </a:t>
+                        <a:t> </a:t>
                       </a:r>
                     </a:p>
                   </a:txBody>
@@ -5491,7 +5261,7 @@
                           </a:solidFill>
                           <a:latin typeface="Calisto MT" panose="02040603050505030304" pitchFamily="18" charset="0"/>
                         </a:rPr>
-                        <a:t xml:space="preserve"> </a:t>
+                        <a:t> </a:t>
                       </a:r>
                     </a:p>
                   </a:txBody>
@@ -5518,7 +5288,7 @@
                           </a:solidFill>
                           <a:latin typeface="Calisto MT" panose="02040603050505030304" pitchFamily="18" charset="0"/>
                         </a:rPr>
-                        <a:t xml:space="preserve"> </a:t>
+                        <a:t> </a:t>
                       </a:r>
                     </a:p>
                   </a:txBody>
@@ -5545,12 +5315,17 @@
                           </a:solidFill>
                           <a:latin typeface="Calisto MT" panose="02040603050505030304" pitchFamily="18" charset="0"/>
                         </a:rPr>
-                        <a:t xml:space="preserve"> </a:t>
+                        <a:t> </a:t>
                       </a:r>
                     </a:p>
                   </a:txBody>
                   <a:tcPr marL="36576" marR="36576" marT="18288" marB="18288" anchor="ctr"/>
                 </a:tc>
+                <a:extLst>
+                  <a:ext uri="{0D108BD9-81ED-4DB2-BD59-A6C34878D82A}">
+                    <a16:rowId xmlns:a16="http://schemas.microsoft.com/office/drawing/2014/main" val="10005"/>
+                  </a:ext>
+                </a:extLst>
               </a:tr>
               <a:tr h="430000">
                 <a:tc>
@@ -5616,7 +5391,7 @@
                           </a:solidFill>
                           <a:latin typeface="Calisto MT" panose="02040603050505030304" pitchFamily="18" charset="0"/>
                         </a:rPr>
-                        <a:t xml:space="preserve"> </a:t>
+                        <a:t> </a:t>
                       </a:r>
                     </a:p>
                   </a:txBody>
@@ -5639,7 +5414,7 @@
                           </a:solidFill>
                           <a:latin typeface="Calisto MT" panose="02040603050505030304" pitchFamily="18" charset="0"/>
                         </a:rPr>
-                        <a:t xml:space="preserve"> </a:t>
+                        <a:t> </a:t>
                       </a:r>
                     </a:p>
                   </a:txBody>
@@ -5662,7 +5437,7 @@
                           </a:solidFill>
                           <a:latin typeface="Calisto MT" panose="02040603050505030304" pitchFamily="18" charset="0"/>
                         </a:rPr>
-                        <a:t xml:space="preserve"> </a:t>
+                        <a:t> </a:t>
                       </a:r>
                     </a:p>
                   </a:txBody>
@@ -5689,12 +5464,17 @@
                           </a:solidFill>
                           <a:latin typeface="Calisto MT" panose="02040603050505030304" pitchFamily="18" charset="0"/>
                         </a:rPr>
-                        <a:t xml:space="preserve"> </a:t>
+                        <a:t> </a:t>
                       </a:r>
                     </a:p>
                   </a:txBody>
                   <a:tcPr marL="36576" marR="36576" marT="18288" marB="18288" anchor="ctr"/>
                 </a:tc>
+                <a:extLst>
+                  <a:ext uri="{0D108BD9-81ED-4DB2-BD59-A6C34878D82A}">
+                    <a16:rowId xmlns:a16="http://schemas.microsoft.com/office/drawing/2014/main" val="10006"/>
+                  </a:ext>
+                </a:extLst>
               </a:tr>
               <a:tr h="430000">
                 <a:tc>
@@ -5760,7 +5540,7 @@
                           </a:solidFill>
                           <a:latin typeface="Calisto MT" panose="02040603050505030304" pitchFamily="18" charset="0"/>
                         </a:rPr>
-                        <a:t xml:space="preserve"> </a:t>
+                        <a:t> </a:t>
                       </a:r>
                     </a:p>
                   </a:txBody>
@@ -5783,7 +5563,7 @@
                           </a:solidFill>
                           <a:latin typeface="Calisto MT" panose="02040603050505030304" pitchFamily="18" charset="0"/>
                         </a:rPr>
-                        <a:t xml:space="preserve"> </a:t>
+                        <a:t> </a:t>
                       </a:r>
                     </a:p>
                   </a:txBody>
@@ -5806,7 +5586,7 @@
                           </a:solidFill>
                           <a:latin typeface="Calisto MT" panose="02040603050505030304" pitchFamily="18" charset="0"/>
                         </a:rPr>
-                        <a:t xml:space="preserve"> </a:t>
+                        <a:t> </a:t>
                       </a:r>
                     </a:p>
                   </a:txBody>
@@ -5833,7 +5613,7 @@
                           </a:solidFill>
                           <a:latin typeface="Calisto MT" panose="02040603050505030304" pitchFamily="18" charset="0"/>
                         </a:rPr>
-                        <a:t xml:space="preserve"> </a:t>
+                        <a:t> </a:t>
                       </a:r>
                     </a:p>
                   </a:txBody>
@@ -5843,6 +5623,11 @@
                     </a:solidFill>
                   </a:tcPr>
                 </a:tc>
+                <a:extLst>
+                  <a:ext uri="{0D108BD9-81ED-4DB2-BD59-A6C34878D82A}">
+                    <a16:rowId xmlns:a16="http://schemas.microsoft.com/office/drawing/2014/main" val="10007"/>
+                  </a:ext>
+                </a:extLst>
               </a:tr>
               <a:tr h="430000">
                 <a:tc>
@@ -5908,7 +5693,7 @@
                           </a:solidFill>
                           <a:latin typeface="Calisto MT" panose="02040603050505030304" pitchFamily="18" charset="0"/>
                         </a:rPr>
-                        <a:t xml:space="preserve"> </a:t>
+                        <a:t> </a:t>
                       </a:r>
                     </a:p>
                   </a:txBody>
@@ -5931,7 +5716,7 @@
                           </a:solidFill>
                           <a:latin typeface="Calisto MT" panose="02040603050505030304" pitchFamily="18" charset="0"/>
                         </a:rPr>
-                        <a:t xml:space="preserve"> </a:t>
+                        <a:t> </a:t>
                       </a:r>
                     </a:p>
                   </a:txBody>
@@ -5954,7 +5739,7 @@
                           </a:solidFill>
                           <a:latin typeface="Calisto MT" panose="02040603050505030304" pitchFamily="18" charset="0"/>
                         </a:rPr>
-                        <a:t xml:space="preserve"> </a:t>
+                        <a:t> </a:t>
                       </a:r>
                     </a:p>
                   </a:txBody>
@@ -5977,7 +5762,7 @@
                           </a:solidFill>
                           <a:latin typeface="Calisto MT" panose="02040603050505030304" pitchFamily="18" charset="0"/>
                         </a:rPr>
-                        <a:t xml:space="preserve"> </a:t>
+                        <a:t> </a:t>
                       </a:r>
                     </a:p>
                   </a:txBody>
@@ -5987,6 +5772,11 @@
                     </a:solidFill>
                   </a:tcPr>
                 </a:tc>
+                <a:extLst>
+                  <a:ext uri="{0D108BD9-81ED-4DB2-BD59-A6C34878D82A}">
+                    <a16:rowId xmlns:a16="http://schemas.microsoft.com/office/drawing/2014/main" val="10008"/>
+                  </a:ext>
+                </a:extLst>
               </a:tr>
               <a:tr h="430000">
                 <a:tc>
@@ -6052,7 +5842,7 @@
                           </a:solidFill>
                           <a:latin typeface="Calisto MT" panose="02040603050505030304" pitchFamily="18" charset="0"/>
                         </a:rPr>
-                        <a:t xml:space="preserve"> </a:t>
+                        <a:t> </a:t>
                       </a:r>
                     </a:p>
                   </a:txBody>
@@ -6075,7 +5865,7 @@
                           </a:solidFill>
                           <a:latin typeface="Calisto MT" panose="02040603050505030304" pitchFamily="18" charset="0"/>
                         </a:rPr>
-                        <a:t xml:space="preserve"> </a:t>
+                        <a:t> </a:t>
                       </a:r>
                     </a:p>
                   </a:txBody>
@@ -6098,7 +5888,7 @@
                           </a:solidFill>
                           <a:latin typeface="Calisto MT" panose="02040603050505030304" pitchFamily="18" charset="0"/>
                         </a:rPr>
-                        <a:t xml:space="preserve"> </a:t>
+                        <a:t> </a:t>
                       </a:r>
                     </a:p>
                   </a:txBody>
@@ -6121,7 +5911,7 @@
                           </a:solidFill>
                           <a:latin typeface="Calisto MT" panose="02040603050505030304" pitchFamily="18" charset="0"/>
                         </a:rPr>
-                        <a:t xml:space="preserve"> </a:t>
+                        <a:t> </a:t>
                       </a:r>
                     </a:p>
                   </a:txBody>
@@ -6131,6 +5921,11 @@
                     </a:solidFill>
                   </a:tcPr>
                 </a:tc>
+                <a:extLst>
+                  <a:ext uri="{0D108BD9-81ED-4DB2-BD59-A6C34878D82A}">
+                    <a16:rowId xmlns:a16="http://schemas.microsoft.com/office/drawing/2014/main" val="10009"/>
+                  </a:ext>
+                </a:extLst>
               </a:tr>
               <a:tr h="430000">
                 <a:tc>
@@ -6196,7 +5991,7 @@
                           </a:solidFill>
                           <a:latin typeface="Calisto MT" panose="02040603050505030304" pitchFamily="18" charset="0"/>
                         </a:rPr>
-                        <a:t xml:space="preserve"> </a:t>
+                        <a:t> </a:t>
                       </a:r>
                     </a:p>
                   </a:txBody>
@@ -6223,7 +6018,7 @@
                           </a:solidFill>
                           <a:latin typeface="Calisto MT" panose="02040603050505030304" pitchFamily="18" charset="0"/>
                         </a:rPr>
-                        <a:t xml:space="preserve"> </a:t>
+                        <a:t> </a:t>
                       </a:r>
                     </a:p>
                   </a:txBody>
@@ -6250,7 +6045,7 @@
                           </a:solidFill>
                           <a:latin typeface="Calisto MT" panose="02040603050505030304" pitchFamily="18" charset="0"/>
                         </a:rPr>
-                        <a:t xml:space="preserve"> </a:t>
+                        <a:t> </a:t>
                       </a:r>
                     </a:p>
                   </a:txBody>
@@ -6277,7 +6072,7 @@
                           </a:solidFill>
                           <a:latin typeface="Calisto MT" panose="02040603050505030304" pitchFamily="18" charset="0"/>
                         </a:rPr>
-                        <a:t xml:space="preserve"> </a:t>
+                        <a:t> </a:t>
                       </a:r>
                     </a:p>
                   </a:txBody>
@@ -6287,6 +6082,11 @@
                     </a:solidFill>
                   </a:tcPr>
                 </a:tc>
+                <a:extLst>
+                  <a:ext uri="{0D108BD9-81ED-4DB2-BD59-A6C34878D82A}">
+                    <a16:rowId xmlns:a16="http://schemas.microsoft.com/office/drawing/2014/main" val="10010"/>
+                  </a:ext>
+                </a:extLst>
               </a:tr>
             </a:tbl>
           </a:graphicData>
@@ -6296,6 +6096,1140 @@
     <p:extLst>
       <p:ext uri="{BB962C8B-B14F-4D97-AF65-F5344CB8AC3E}">
         <p14:creationId xmlns:p14="http://schemas.microsoft.com/office/powerpoint/2010/main" val="313617486"/>
+      </p:ext>
+    </p:extLst>
+  </p:cSld>
+  <p:clrMapOvr>
+    <a:masterClrMapping/>
+  </p:clrMapOvr>
+</p:sld>
+</file>
+
+<file path=ppt/slides/slide12.xml><?xml version="1.0" encoding="utf-8"?>
+<p:sld xmlns:a="http://schemas.openxmlformats.org/drawingml/2006/main" xmlns:r="http://schemas.openxmlformats.org/officeDocument/2006/relationships" xmlns:p="http://schemas.openxmlformats.org/presentationml/2006/main">
+  <p:cSld>
+    <p:spTree>
+      <p:nvGrpSpPr>
+        <p:cNvPr id="1" name=""/>
+        <p:cNvGrpSpPr/>
+        <p:nvPr/>
+      </p:nvGrpSpPr>
+      <p:grpSpPr>
+        <a:xfrm>
+          <a:off x="0" y="0"/>
+          <a:ext cx="0" cy="0"/>
+          <a:chOff x="0" y="0"/>
+          <a:chExt cx="0" cy="0"/>
+        </a:xfrm>
+      </p:grpSpPr>
+      <p:sp>
+        <p:nvSpPr>
+          <p:cNvPr id="2" name="Title 1">
+            <a:extLst>
+              <a:ext uri="{FF2B5EF4-FFF2-40B4-BE49-F238E27FC236}">
+                <a16:creationId xmlns:a16="http://schemas.microsoft.com/office/drawing/2014/main" id="{5B738971-B764-E045-F92B-01E3322A0123}"/>
+              </a:ext>
+            </a:extLst>
+          </p:cNvPr>
+          <p:cNvSpPr>
+            <a:spLocks noGrp="1"/>
+          </p:cNvSpPr>
+          <p:nvPr>
+            <p:ph type="title"/>
+          </p:nvPr>
+        </p:nvSpPr>
+        <p:spPr>
+          <a:xfrm>
+            <a:off x="399166" y="155378"/>
+            <a:ext cx="8006303" cy="549273"/>
+          </a:xfrm>
+        </p:spPr>
+        <p:txBody>
+          <a:bodyPr>
+            <a:normAutofit fontScale="90000"/>
+          </a:bodyPr>
+          <a:lstStyle/>
+          <a:p>
+            <a:r>
+              <a:rPr lang="en-US" sz="4000" b="1" dirty="0">
+                <a:solidFill>
+                  <a:schemeClr val="accent2">
+                    <a:lumMod val="50000"/>
+                  </a:schemeClr>
+                </a:solidFill>
+                <a:latin typeface="Calisto MT" panose="02040603050505030304" pitchFamily="18" charset="0"/>
+              </a:rPr>
+              <a:t>References</a:t>
+            </a:r>
+          </a:p>
+        </p:txBody>
+      </p:sp>
+      <p:sp>
+        <p:nvSpPr>
+          <p:cNvPr id="3" name="Content Placeholder 2">
+            <a:extLst>
+              <a:ext uri="{FF2B5EF4-FFF2-40B4-BE49-F238E27FC236}">
+                <a16:creationId xmlns:a16="http://schemas.microsoft.com/office/drawing/2014/main" id="{E5D502BE-F636-7D1D-85F0-BAFFD3E05E1C}"/>
+              </a:ext>
+            </a:extLst>
+          </p:cNvPr>
+          <p:cNvSpPr>
+            <a:spLocks noGrp="1"/>
+          </p:cNvSpPr>
+          <p:nvPr>
+            <p:ph idx="1"/>
+          </p:nvPr>
+        </p:nvSpPr>
+        <p:spPr>
+          <a:xfrm>
+            <a:off x="445564" y="790755"/>
+            <a:ext cx="4268899" cy="5748157"/>
+          </a:xfrm>
+        </p:spPr>
+        <p:txBody>
+          <a:bodyPr numCol="1">
+            <a:normAutofit/>
+          </a:bodyPr>
+          <a:lstStyle/>
+          <a:p>
+            <a:pPr marL="342900" lvl="0" indent="-342900" algn="l">
+              <a:spcAft>
+                <a:spcPts val="280"/>
+              </a:spcAft>
+              <a:buNone/>
+            </a:pPr>
+            <a:r>
+              <a:rPr lang="en-US" sz="1200" b="1" dirty="0">
+                <a:solidFill>
+                  <a:srgbClr val="252525"/>
+                </a:solidFill>
+                <a:latin typeface="Calisto MT" panose="02040603050505030304" pitchFamily="18" charset="0"/>
+              </a:rPr>
+              <a:t>[1] </a:t>
+            </a:r>
+            <a:r>
+              <a:rPr lang="en-US" sz="1200" dirty="0">
+                <a:solidFill>
+                  <a:srgbClr val="252525"/>
+                </a:solidFill>
+                <a:latin typeface="Calisto MT" panose="02040603050505030304" pitchFamily="18" charset="0"/>
+              </a:rPr>
+              <a:t>Lieberman-Aiden, E., et al. (2009). Comprehensive mapping of long-range interactions reveals folding principles of the human genome. Science, 326(5950), 289–293.</a:t>
+            </a:r>
+          </a:p>
+          <a:p>
+            <a:pPr marL="342900" lvl="0" indent="-342900" algn="l">
+              <a:spcAft>
+                <a:spcPts val="280"/>
+              </a:spcAft>
+              <a:buNone/>
+            </a:pPr>
+            <a:r>
+              <a:rPr lang="en-US" sz="1200" b="1" dirty="0">
+                <a:solidFill>
+                  <a:srgbClr val="252525"/>
+                </a:solidFill>
+                <a:latin typeface="Calisto MT" panose="02040603050505030304" pitchFamily="18" charset="0"/>
+              </a:rPr>
+              <a:t>[2] </a:t>
+            </a:r>
+            <a:r>
+              <a:rPr lang="en-US" sz="1200" dirty="0">
+                <a:solidFill>
+                  <a:srgbClr val="252525"/>
+                </a:solidFill>
+                <a:latin typeface="Calisto MT" panose="02040603050505030304" pitchFamily="18" charset="0"/>
+              </a:rPr>
+              <a:t>Dixon, J. R., et al. (2012). Topological domains in mammalian genomes identified by analysis of chromatin interactions. Nature, 485, 376–380.</a:t>
+            </a:r>
+          </a:p>
+          <a:p>
+            <a:pPr marL="342900" lvl="0" indent="-342900" algn="l">
+              <a:spcAft>
+                <a:spcPts val="280"/>
+              </a:spcAft>
+              <a:buNone/>
+            </a:pPr>
+            <a:r>
+              <a:rPr lang="en-US" sz="1200" b="1" dirty="0">
+                <a:solidFill>
+                  <a:srgbClr val="252525"/>
+                </a:solidFill>
+                <a:latin typeface="Calisto MT" panose="02040603050505030304" pitchFamily="18" charset="0"/>
+              </a:rPr>
+              <a:t>[3] </a:t>
+            </a:r>
+            <a:r>
+              <a:rPr lang="en-US" sz="1200" dirty="0">
+                <a:solidFill>
+                  <a:srgbClr val="252525"/>
+                </a:solidFill>
+                <a:latin typeface="Calisto MT" panose="02040603050505030304" pitchFamily="18" charset="0"/>
+              </a:rPr>
+              <a:t>Rao, S. S. P., et al. (2014). A 3D map of the human genome at kilobase resolution reveals principles of chromatin looping. Cell, 159(7), 1665–1680.</a:t>
+            </a:r>
+          </a:p>
+          <a:p>
+            <a:pPr marL="342900" lvl="0" indent="-342900" algn="l">
+              <a:spcAft>
+                <a:spcPts val="280"/>
+              </a:spcAft>
+              <a:buNone/>
+            </a:pPr>
+            <a:r>
+              <a:rPr lang="en-US" sz="1200" b="1" dirty="0">
+                <a:solidFill>
+                  <a:srgbClr val="252525"/>
+                </a:solidFill>
+                <a:latin typeface="Calisto MT" panose="02040603050505030304" pitchFamily="18" charset="0"/>
+              </a:rPr>
+              <a:t>[4] </a:t>
+            </a:r>
+            <a:r>
+              <a:rPr lang="en-US" sz="1200" dirty="0">
+                <a:solidFill>
+                  <a:srgbClr val="252525"/>
+                </a:solidFill>
+                <a:latin typeface="Calisto MT" panose="02040603050505030304" pitchFamily="18" charset="0"/>
+              </a:rPr>
+              <a:t>Schiff, Y., Kao, C.-H., et al. (2024). Caduceus: Bi-directional equivariant long-range DNA sequence modeling. Proceedings of ICML 2024, PMLR 235. arXiv:2403.03234.</a:t>
+            </a:r>
+          </a:p>
+          <a:p>
+            <a:pPr marL="342900" lvl="0" indent="-342900" algn="l">
+              <a:spcAft>
+                <a:spcPts val="280"/>
+              </a:spcAft>
+              <a:buNone/>
+            </a:pPr>
+            <a:r>
+              <a:rPr lang="en-US" sz="1200" b="1" dirty="0">
+                <a:solidFill>
+                  <a:srgbClr val="252525"/>
+                </a:solidFill>
+                <a:latin typeface="Calisto MT" panose="02040603050505030304" pitchFamily="18" charset="0"/>
+              </a:rPr>
+              <a:t>[5] </a:t>
+            </a:r>
+            <a:r>
+              <a:rPr lang="en-US" sz="1200" dirty="0">
+                <a:solidFill>
+                  <a:srgbClr val="252525"/>
+                </a:solidFill>
+                <a:latin typeface="Calisto MT" panose="02040603050505030304" pitchFamily="18" charset="0"/>
+              </a:rPr>
+              <a:t>Brixi, G., et al. (2026). Genome modelling and design across all domains of life with Evo 2. Nature. (Preprint: bioRxiv 10.1101/2025.02.18.638918).</a:t>
+            </a:r>
+          </a:p>
+          <a:p>
+            <a:pPr marL="342900" lvl="0" indent="-342900" algn="l">
+              <a:spcAft>
+                <a:spcPts val="280"/>
+              </a:spcAft>
+              <a:buNone/>
+            </a:pPr>
+            <a:r>
+              <a:rPr lang="en-US" sz="1200" b="1" dirty="0">
+                <a:solidFill>
+                  <a:srgbClr val="252525"/>
+                </a:solidFill>
+                <a:latin typeface="Calisto MT" panose="02040603050505030304" pitchFamily="18" charset="0"/>
+              </a:rPr>
+              <a:t>[6] </a:t>
+            </a:r>
+            <a:r>
+              <a:rPr lang="en-US" sz="1200" dirty="0">
+                <a:solidFill>
+                  <a:srgbClr val="252525"/>
+                </a:solidFill>
+                <a:latin typeface="Calisto MT" panose="02040603050505030304" pitchFamily="18" charset="0"/>
+              </a:rPr>
+              <a:t>Wang, X., et al. (2026). A generalizable Hi-C foundation model for chromatin architecture, single-cell and multi-omics analysis across species. Nature Methods. (Preprint: bioRxiv 10.1101/2024.12.16.628821).</a:t>
+            </a:r>
+          </a:p>
+          <a:p>
+            <a:pPr marL="342900" lvl="0" indent="-342900" algn="l">
+              <a:spcAft>
+                <a:spcPts val="280"/>
+              </a:spcAft>
+              <a:buNone/>
+            </a:pPr>
+            <a:r>
+              <a:rPr lang="en-US" sz="1200" b="1" dirty="0">
+                <a:solidFill>
+                  <a:srgbClr val="252525"/>
+                </a:solidFill>
+                <a:latin typeface="Calisto MT" panose="02040603050505030304" pitchFamily="18" charset="0"/>
+              </a:rPr>
+              <a:t>[7] </a:t>
+            </a:r>
+            <a:r>
+              <a:rPr lang="en-US" sz="1200" dirty="0">
+                <a:solidFill>
+                  <a:srgbClr val="252525"/>
+                </a:solidFill>
+                <a:latin typeface="Calisto MT" panose="02040603050505030304" pitchFamily="18" charset="0"/>
+              </a:rPr>
+              <a:t>Wu, X., Chen, X., &amp; Jiang, R. (2025). Hi-Cformer enables multi-scale chromatin contact map modeling for single-cell Hi-C data analysis. bioRxiv 10.1101/2025.08.04.668453.</a:t>
+            </a:r>
+          </a:p>
+        </p:txBody>
+      </p:sp>
+      <p:sp>
+        <p:nvSpPr>
+          <p:cNvPr id="6" name="Slide Number Placeholder 5">
+            <a:extLst>
+              <a:ext uri="{FF2B5EF4-FFF2-40B4-BE49-F238E27FC236}">
+                <a16:creationId xmlns:a16="http://schemas.microsoft.com/office/drawing/2014/main" id="{1F9ED706-BAAD-007D-D4CC-247F422DF465}"/>
+              </a:ext>
+            </a:extLst>
+          </p:cNvPr>
+          <p:cNvSpPr>
+            <a:spLocks noGrp="1"/>
+          </p:cNvSpPr>
+          <p:nvPr>
+            <p:ph type="sldNum" sz="quarter" idx="12"/>
+          </p:nvPr>
+        </p:nvSpPr>
+        <p:spPr/>
+        <p:txBody>
+          <a:bodyPr/>
+          <a:lstStyle/>
+          <a:p>
+            <a:fld id="{D90542D4-23E8-43E0-BA8E-C972DA1A005D}" type="slidenum">
+              <a:rPr lang="en-US" sz="1400" b="1" smtClean="0">
+                <a:solidFill>
+                  <a:schemeClr val="tx1"/>
+                </a:solidFill>
+                <a:latin typeface="Calisto MT" panose="02040603050505030304" pitchFamily="18" charset="0"/>
+              </a:rPr>
+              <a:pPr/>
+              <a:t>12</a:t>
+            </a:fld>
+            <a:endParaRPr lang="en-US" sz="1400" b="1" dirty="0">
+              <a:solidFill>
+                <a:schemeClr val="tx1"/>
+              </a:solidFill>
+              <a:latin typeface="Calisto MT" panose="02040603050505030304" pitchFamily="18" charset="0"/>
+            </a:endParaRPr>
+          </a:p>
+        </p:txBody>
+      </p:sp>
+      <p:sp>
+        <p:nvSpPr>
+          <p:cNvPr id="4" name="Content Placeholder 2">
+            <a:extLst>
+              <a:ext uri="{FF2B5EF4-FFF2-40B4-BE49-F238E27FC236}">
+                <a16:creationId xmlns:a16="http://schemas.microsoft.com/office/drawing/2014/main" id="{113500B2-5D78-46B4-2E7E-95274C6B8F42}"/>
+              </a:ext>
+            </a:extLst>
+          </p:cNvPr>
+          <p:cNvSpPr txBox="1">
+            <a:spLocks/>
+          </p:cNvSpPr>
+          <p:nvPr/>
+        </p:nvSpPr>
+        <p:spPr>
+          <a:xfrm>
+            <a:off x="4714463" y="790755"/>
+            <a:ext cx="4268899" cy="5748157"/>
+          </a:xfrm>
+          <a:prstGeom prst="rect">
+            <a:avLst/>
+          </a:prstGeom>
+        </p:spPr>
+        <p:txBody>
+          <a:bodyPr vert="horz" lIns="91440" tIns="45720" rIns="91440" bIns="45720" numCol="1" rtlCol="0">
+            <a:normAutofit/>
+          </a:bodyPr>
+          <a:lstStyle>
+            <a:lvl1pPr marL="228600" indent="-228600" algn="l" defTabSz="914400" rtl="0" eaLnBrk="1" latinLnBrk="0" hangingPunct="1">
+              <a:lnSpc>
+                <a:spcPct val="90000"/>
+              </a:lnSpc>
+              <a:spcBef>
+                <a:spcPts val="1000"/>
+              </a:spcBef>
+              <a:buFont typeface="Arial" panose="020B0604020202020204" pitchFamily="34" charset="0"/>
+              <a:buChar char="•"/>
+              <a:defRPr sz="2800" kern="1200">
+                <a:solidFill>
+                  <a:schemeClr val="tx1"/>
+                </a:solidFill>
+                <a:latin typeface="+mn-lt"/>
+                <a:ea typeface="+mn-ea"/>
+                <a:cs typeface="+mn-cs"/>
+              </a:defRPr>
+            </a:lvl1pPr>
+            <a:lvl2pPr marL="685800" indent="-228600" algn="l" defTabSz="914400" rtl="0" eaLnBrk="1" latinLnBrk="0" hangingPunct="1">
+              <a:lnSpc>
+                <a:spcPct val="90000"/>
+              </a:lnSpc>
+              <a:spcBef>
+                <a:spcPts val="500"/>
+              </a:spcBef>
+              <a:buFont typeface="Arial" panose="020B0604020202020204" pitchFamily="34" charset="0"/>
+              <a:buChar char="•"/>
+              <a:defRPr sz="2400" kern="1200">
+                <a:solidFill>
+                  <a:schemeClr val="tx1"/>
+                </a:solidFill>
+                <a:latin typeface="+mn-lt"/>
+                <a:ea typeface="+mn-ea"/>
+                <a:cs typeface="+mn-cs"/>
+              </a:defRPr>
+            </a:lvl2pPr>
+            <a:lvl3pPr marL="1143000" indent="-228600" algn="l" defTabSz="914400" rtl="0" eaLnBrk="1" latinLnBrk="0" hangingPunct="1">
+              <a:lnSpc>
+                <a:spcPct val="90000"/>
+              </a:lnSpc>
+              <a:spcBef>
+                <a:spcPts val="500"/>
+              </a:spcBef>
+              <a:buFont typeface="Arial" panose="020B0604020202020204" pitchFamily="34" charset="0"/>
+              <a:buChar char="•"/>
+              <a:defRPr sz="2000" kern="1200">
+                <a:solidFill>
+                  <a:schemeClr val="tx1"/>
+                </a:solidFill>
+                <a:latin typeface="+mn-lt"/>
+                <a:ea typeface="+mn-ea"/>
+                <a:cs typeface="+mn-cs"/>
+              </a:defRPr>
+            </a:lvl3pPr>
+            <a:lvl4pPr marL="1600200" indent="-228600" algn="l" defTabSz="914400" rtl="0" eaLnBrk="1" latinLnBrk="0" hangingPunct="1">
+              <a:lnSpc>
+                <a:spcPct val="90000"/>
+              </a:lnSpc>
+              <a:spcBef>
+                <a:spcPts val="500"/>
+              </a:spcBef>
+              <a:buFont typeface="Arial" panose="020B0604020202020204" pitchFamily="34" charset="0"/>
+              <a:buChar char="•"/>
+              <a:defRPr sz="1800" kern="1200">
+                <a:solidFill>
+                  <a:schemeClr val="tx1"/>
+                </a:solidFill>
+                <a:latin typeface="+mn-lt"/>
+                <a:ea typeface="+mn-ea"/>
+                <a:cs typeface="+mn-cs"/>
+              </a:defRPr>
+            </a:lvl4pPr>
+            <a:lvl5pPr marL="2057400" indent="-228600" algn="l" defTabSz="914400" rtl="0" eaLnBrk="1" latinLnBrk="0" hangingPunct="1">
+              <a:lnSpc>
+                <a:spcPct val="90000"/>
+              </a:lnSpc>
+              <a:spcBef>
+                <a:spcPts val="500"/>
+              </a:spcBef>
+              <a:buFont typeface="Arial" panose="020B0604020202020204" pitchFamily="34" charset="0"/>
+              <a:buChar char="•"/>
+              <a:defRPr sz="1800" kern="1200">
+                <a:solidFill>
+                  <a:schemeClr val="tx1"/>
+                </a:solidFill>
+                <a:latin typeface="+mn-lt"/>
+                <a:ea typeface="+mn-ea"/>
+                <a:cs typeface="+mn-cs"/>
+              </a:defRPr>
+            </a:lvl5pPr>
+            <a:lvl6pPr marL="2514600" indent="-228600" algn="l" defTabSz="914400" rtl="0" eaLnBrk="1" latinLnBrk="0" hangingPunct="1">
+              <a:lnSpc>
+                <a:spcPct val="90000"/>
+              </a:lnSpc>
+              <a:spcBef>
+                <a:spcPts val="500"/>
+              </a:spcBef>
+              <a:buFont typeface="Arial" panose="020B0604020202020204" pitchFamily="34" charset="0"/>
+              <a:buChar char="•"/>
+              <a:defRPr sz="1800" kern="1200">
+                <a:solidFill>
+                  <a:schemeClr val="tx1"/>
+                </a:solidFill>
+                <a:latin typeface="+mn-lt"/>
+                <a:ea typeface="+mn-ea"/>
+                <a:cs typeface="+mn-cs"/>
+              </a:defRPr>
+            </a:lvl6pPr>
+            <a:lvl7pPr marL="2971800" indent="-228600" algn="l" defTabSz="914400" rtl="0" eaLnBrk="1" latinLnBrk="0" hangingPunct="1">
+              <a:lnSpc>
+                <a:spcPct val="90000"/>
+              </a:lnSpc>
+              <a:spcBef>
+                <a:spcPts val="500"/>
+              </a:spcBef>
+              <a:buFont typeface="Arial" panose="020B0604020202020204" pitchFamily="34" charset="0"/>
+              <a:buChar char="•"/>
+              <a:defRPr sz="1800" kern="1200">
+                <a:solidFill>
+                  <a:schemeClr val="tx1"/>
+                </a:solidFill>
+                <a:latin typeface="+mn-lt"/>
+                <a:ea typeface="+mn-ea"/>
+                <a:cs typeface="+mn-cs"/>
+              </a:defRPr>
+            </a:lvl7pPr>
+            <a:lvl8pPr marL="3429000" indent="-228600" algn="l" defTabSz="914400" rtl="0" eaLnBrk="1" latinLnBrk="0" hangingPunct="1">
+              <a:lnSpc>
+                <a:spcPct val="90000"/>
+              </a:lnSpc>
+              <a:spcBef>
+                <a:spcPts val="500"/>
+              </a:spcBef>
+              <a:buFont typeface="Arial" panose="020B0604020202020204" pitchFamily="34" charset="0"/>
+              <a:buChar char="•"/>
+              <a:defRPr sz="1800" kern="1200">
+                <a:solidFill>
+                  <a:schemeClr val="tx1"/>
+                </a:solidFill>
+                <a:latin typeface="+mn-lt"/>
+                <a:ea typeface="+mn-ea"/>
+                <a:cs typeface="+mn-cs"/>
+              </a:defRPr>
+            </a:lvl8pPr>
+            <a:lvl9pPr marL="3886200" indent="-228600" algn="l" defTabSz="914400" rtl="0" eaLnBrk="1" latinLnBrk="0" hangingPunct="1">
+              <a:lnSpc>
+                <a:spcPct val="90000"/>
+              </a:lnSpc>
+              <a:spcBef>
+                <a:spcPts val="500"/>
+              </a:spcBef>
+              <a:buFont typeface="Arial" panose="020B0604020202020204" pitchFamily="34" charset="0"/>
+              <a:buChar char="•"/>
+              <a:defRPr sz="1800" kern="1200">
+                <a:solidFill>
+                  <a:schemeClr val="tx1"/>
+                </a:solidFill>
+                <a:latin typeface="+mn-lt"/>
+                <a:ea typeface="+mn-ea"/>
+                <a:cs typeface="+mn-cs"/>
+              </a:defRPr>
+            </a:lvl9pPr>
+          </a:lstStyle>
+          <a:p>
+            <a:pPr marL="342900" lvl="0" indent="-342900">
+              <a:spcAft>
+                <a:spcPts val="280"/>
+              </a:spcAft>
+              <a:buNone/>
+            </a:pPr>
+            <a:r>
+              <a:rPr lang="en-US" sz="1200" b="1" dirty="0">
+                <a:solidFill>
+                  <a:srgbClr val="252525"/>
+                </a:solidFill>
+                <a:latin typeface="Calisto MT" panose="02040603050505030304" pitchFamily="18" charset="0"/>
+              </a:rPr>
+              <a:t>[8] </a:t>
+            </a:r>
+            <a:r>
+              <a:rPr lang="en-US" sz="1200" dirty="0" err="1">
+                <a:solidFill>
+                  <a:srgbClr val="252525"/>
+                </a:solidFill>
+                <a:latin typeface="Calisto MT" panose="02040603050505030304" pitchFamily="18" charset="0"/>
+              </a:rPr>
+              <a:t>Karbalayghareh</a:t>
+            </a:r>
+            <a:r>
+              <a:rPr lang="en-US" sz="1200" dirty="0">
+                <a:solidFill>
+                  <a:srgbClr val="252525"/>
+                </a:solidFill>
+                <a:latin typeface="Calisto MT" panose="02040603050505030304" pitchFamily="18" charset="0"/>
+              </a:rPr>
+              <a:t>, A., et al. (2022). Chromatin interaction–aware gene regulatory modeling with graph attention networks. Genome Research, 32(5), 930–944.</a:t>
+            </a:r>
+          </a:p>
+          <a:p>
+            <a:pPr marL="342900" lvl="0" indent="-342900">
+              <a:spcAft>
+                <a:spcPts val="280"/>
+              </a:spcAft>
+              <a:buNone/>
+            </a:pPr>
+            <a:r>
+              <a:rPr lang="en-US" sz="1200" b="1" dirty="0">
+                <a:solidFill>
+                  <a:srgbClr val="252525"/>
+                </a:solidFill>
+                <a:latin typeface="Calisto MT" panose="02040603050505030304" pitchFamily="18" charset="0"/>
+              </a:rPr>
+              <a:t>[9] </a:t>
+            </a:r>
+            <a:r>
+              <a:rPr lang="en-US" sz="1200" dirty="0">
+                <a:solidFill>
+                  <a:srgbClr val="252525"/>
+                </a:solidFill>
+                <a:latin typeface="Calisto MT" panose="02040603050505030304" pitchFamily="18" charset="0"/>
+              </a:rPr>
+              <a:t>Ye, F., et al. (2026). A chromatin-structure-guided framework for predictive and interpretable regulatory genomics. Briefings in Bioinformatics, 27(4), bbag360.</a:t>
+            </a:r>
+          </a:p>
+          <a:p>
+            <a:pPr marL="342900" lvl="0" indent="-342900">
+              <a:spcAft>
+                <a:spcPts val="280"/>
+              </a:spcAft>
+              <a:buNone/>
+            </a:pPr>
+            <a:r>
+              <a:rPr lang="en-US" sz="1200" b="1" dirty="0">
+                <a:solidFill>
+                  <a:srgbClr val="252525"/>
+                </a:solidFill>
+                <a:latin typeface="Calisto MT" panose="02040603050505030304" pitchFamily="18" charset="0"/>
+              </a:rPr>
+              <a:t>[10] </a:t>
+            </a:r>
+            <a:r>
+              <a:rPr lang="en-US" sz="1200" dirty="0">
+                <a:solidFill>
+                  <a:srgbClr val="252525"/>
+                </a:solidFill>
+                <a:latin typeface="Calisto MT" panose="02040603050505030304" pitchFamily="18" charset="0"/>
+              </a:rPr>
+              <a:t>Fang, T., Wang, X., Xiao, Z., et al. (2025). Evo2HiC: A multimodal foundation model for integrative analysis of genome sequence and architecture. bioRxiv 10.1101/2025.11.18.689171.</a:t>
+            </a:r>
+          </a:p>
+          <a:p>
+            <a:pPr marL="342900" lvl="0" indent="-342900">
+              <a:spcAft>
+                <a:spcPts val="280"/>
+              </a:spcAft>
+              <a:buNone/>
+            </a:pPr>
+            <a:r>
+              <a:rPr lang="en-US" sz="1200" b="1" dirty="0">
+                <a:solidFill>
+                  <a:srgbClr val="252525"/>
+                </a:solidFill>
+                <a:latin typeface="Calisto MT" panose="02040603050505030304" pitchFamily="18" charset="0"/>
+              </a:rPr>
+              <a:t>[11] </a:t>
+            </a:r>
+            <a:r>
+              <a:rPr lang="en-US" sz="1200" dirty="0" err="1">
+                <a:solidFill>
+                  <a:srgbClr val="252525"/>
+                </a:solidFill>
+                <a:latin typeface="Calisto MT" panose="02040603050505030304" pitchFamily="18" charset="0"/>
+              </a:rPr>
+              <a:t>Fudenberg</a:t>
+            </a:r>
+            <a:r>
+              <a:rPr lang="en-US" sz="1200" dirty="0">
+                <a:solidFill>
+                  <a:srgbClr val="252525"/>
+                </a:solidFill>
+                <a:latin typeface="Calisto MT" panose="02040603050505030304" pitchFamily="18" charset="0"/>
+              </a:rPr>
+              <a:t>, G., Kelley, D. R., &amp; Pollard, K. S. (2020). Predicting 3D genome folding from DNA sequence with Akita. Nature Methods, 17, 1111–1117.</a:t>
+            </a:r>
+          </a:p>
+          <a:p>
+            <a:pPr marL="342900" lvl="0" indent="-342900">
+              <a:spcAft>
+                <a:spcPts val="280"/>
+              </a:spcAft>
+              <a:buNone/>
+            </a:pPr>
+            <a:r>
+              <a:rPr lang="en-US" sz="1200" b="1" dirty="0">
+                <a:solidFill>
+                  <a:srgbClr val="252525"/>
+                </a:solidFill>
+                <a:latin typeface="Calisto MT" panose="02040603050505030304" pitchFamily="18" charset="0"/>
+              </a:rPr>
+              <a:t>[12] </a:t>
+            </a:r>
+            <a:r>
+              <a:rPr lang="en-US" sz="1200" dirty="0">
+                <a:solidFill>
+                  <a:srgbClr val="252525"/>
+                </a:solidFill>
+                <a:latin typeface="Calisto MT" panose="02040603050505030304" pitchFamily="18" charset="0"/>
+              </a:rPr>
+              <a:t>Zhou, J. (2022). Sequence-based modeling of three-dimensional genome architecture from kilobase to chromosome scale. Nature Genetics, 54, 725–734.</a:t>
+            </a:r>
+          </a:p>
+          <a:p>
+            <a:pPr marL="342900" lvl="0" indent="-342900">
+              <a:spcAft>
+                <a:spcPts val="280"/>
+              </a:spcAft>
+              <a:buNone/>
+            </a:pPr>
+            <a:r>
+              <a:rPr lang="en-US" sz="1200" b="1" dirty="0">
+                <a:solidFill>
+                  <a:srgbClr val="252525"/>
+                </a:solidFill>
+                <a:latin typeface="Calisto MT" panose="02040603050505030304" pitchFamily="18" charset="0"/>
+              </a:rPr>
+              <a:t>[13] </a:t>
+            </a:r>
+            <a:r>
+              <a:rPr lang="en-US" sz="1200" dirty="0">
+                <a:solidFill>
+                  <a:srgbClr val="252525"/>
+                </a:solidFill>
+                <a:latin typeface="Calisto MT" panose="02040603050505030304" pitchFamily="18" charset="0"/>
+              </a:rPr>
+              <a:t>Lee, U. (2026). Probing 3D chromatin structure awareness in Evo2 DNA language model. arXiv:2604.07196.</a:t>
+            </a:r>
+          </a:p>
+          <a:p>
+            <a:pPr marL="342900" lvl="0" indent="-342900">
+              <a:buNone/>
+            </a:pPr>
+            <a:r>
+              <a:rPr lang="en-US" sz="1200" b="1" dirty="0">
+                <a:solidFill>
+                  <a:srgbClr val="252525"/>
+                </a:solidFill>
+                <a:latin typeface="Calisto MT" panose="02040603050505030304" pitchFamily="18" charset="0"/>
+              </a:rPr>
+              <a:t>[14] </a:t>
+            </a:r>
+            <a:r>
+              <a:rPr lang="en-US" sz="1200" dirty="0">
+                <a:solidFill>
+                  <a:srgbClr val="252525"/>
+                </a:solidFill>
+                <a:latin typeface="Calisto MT" panose="02040603050505030304" pitchFamily="18" charset="0"/>
+              </a:rPr>
+              <a:t>Cheng, W., et al. (2025). </a:t>
+            </a:r>
+            <a:r>
+              <a:rPr lang="en-US" sz="1200" dirty="0" err="1">
+                <a:solidFill>
+                  <a:srgbClr val="252525"/>
+                </a:solidFill>
+                <a:latin typeface="Calisto MT" panose="02040603050505030304" pitchFamily="18" charset="0"/>
+              </a:rPr>
+              <a:t>DNALongBench</a:t>
+            </a:r>
+            <a:r>
+              <a:rPr lang="en-US" sz="1200" dirty="0">
+                <a:solidFill>
+                  <a:srgbClr val="252525"/>
+                </a:solidFill>
+                <a:latin typeface="Calisto MT" panose="02040603050505030304" pitchFamily="18" charset="0"/>
+              </a:rPr>
+              <a:t>: A benchmark suite for long-range DNA prediction tasks. Nature Communications, 16(1), 10108.</a:t>
+            </a:r>
+          </a:p>
+        </p:txBody>
+      </p:sp>
+    </p:spTree>
+    <p:extLst>
+      <p:ext uri="{BB962C8B-B14F-4D97-AF65-F5344CB8AC3E}">
+        <p14:creationId xmlns:p14="http://schemas.microsoft.com/office/powerpoint/2010/main" val="4037050892"/>
+      </p:ext>
+    </p:extLst>
+  </p:cSld>
+  <p:clrMapOvr>
+    <a:masterClrMapping/>
+  </p:clrMapOvr>
+</p:sld>
+</file>
+
+<file path=ppt/slides/slide2.xml><?xml version="1.0" encoding="utf-8"?>
+<p:sld xmlns:a="http://schemas.openxmlformats.org/drawingml/2006/main" xmlns:r="http://schemas.openxmlformats.org/officeDocument/2006/relationships" xmlns:p="http://schemas.openxmlformats.org/presentationml/2006/main">
+  <p:cSld>
+    <p:spTree>
+      <p:nvGrpSpPr>
+        <p:cNvPr id="1" name=""/>
+        <p:cNvGrpSpPr/>
+        <p:nvPr/>
+      </p:nvGrpSpPr>
+      <p:grpSpPr>
+        <a:xfrm>
+          <a:off x="0" y="0"/>
+          <a:ext cx="0" cy="0"/>
+          <a:chOff x="0" y="0"/>
+          <a:chExt cx="0" cy="0"/>
+        </a:xfrm>
+      </p:grpSpPr>
+      <p:sp>
+        <p:nvSpPr>
+          <p:cNvPr id="2" name="Title 1">
+            <a:extLst>
+              <a:ext uri="{FF2B5EF4-FFF2-40B4-BE49-F238E27FC236}">
+                <a16:creationId xmlns:a16="http://schemas.microsoft.com/office/drawing/2014/main" id="{5B738971-B764-E045-F92B-01E3322A0123}"/>
+              </a:ext>
+            </a:extLst>
+          </p:cNvPr>
+          <p:cNvSpPr>
+            <a:spLocks noGrp="1"/>
+          </p:cNvSpPr>
+          <p:nvPr>
+            <p:ph type="title"/>
+          </p:nvPr>
+        </p:nvSpPr>
+        <p:spPr>
+          <a:xfrm>
+            <a:off x="628650" y="214298"/>
+            <a:ext cx="7886700" cy="709530"/>
+          </a:xfrm>
+        </p:spPr>
+        <p:txBody>
+          <a:bodyPr/>
+          <a:lstStyle/>
+          <a:p>
+            <a:r>
+              <a:rPr lang="en-US" sz="3600" b="1" dirty="0">
+                <a:solidFill>
+                  <a:schemeClr val="accent2">
+                    <a:lumMod val="50000"/>
+                  </a:schemeClr>
+                </a:solidFill>
+                <a:latin typeface="Calisto MT" panose="02040603050505030304" pitchFamily="18" charset="0"/>
+              </a:rPr>
+              <a:t>Abstract</a:t>
+            </a:r>
+            <a:endParaRPr lang="en-US" b="1" dirty="0">
+              <a:solidFill>
+                <a:schemeClr val="accent2">
+                  <a:lumMod val="50000"/>
+                </a:schemeClr>
+              </a:solidFill>
+              <a:latin typeface="Calisto MT" panose="02040603050505030304" pitchFamily="18" charset="0"/>
+            </a:endParaRPr>
+          </a:p>
+        </p:txBody>
+      </p:sp>
+      <p:sp>
+        <p:nvSpPr>
+          <p:cNvPr id="3" name="Content Placeholder 2">
+            <a:extLst>
+              <a:ext uri="{FF2B5EF4-FFF2-40B4-BE49-F238E27FC236}">
+                <a16:creationId xmlns:a16="http://schemas.microsoft.com/office/drawing/2014/main" id="{E5D502BE-F636-7D1D-85F0-BAFFD3E05E1C}"/>
+              </a:ext>
+            </a:extLst>
+          </p:cNvPr>
+          <p:cNvSpPr>
+            <a:spLocks noGrp="1"/>
+          </p:cNvSpPr>
+          <p:nvPr>
+            <p:ph idx="1"/>
+          </p:nvPr>
+        </p:nvSpPr>
+        <p:spPr>
+          <a:xfrm>
+            <a:off x="628649" y="1046376"/>
+            <a:ext cx="8062863" cy="5253135"/>
+          </a:xfrm>
+        </p:spPr>
+        <p:txBody>
+          <a:bodyPr>
+            <a:normAutofit/>
+          </a:bodyPr>
+          <a:lstStyle/>
+          <a:p>
+            <a:pPr marL="0" lvl="0" indent="0" algn="just">
+              <a:spcAft>
+                <a:spcPts val="800"/>
+              </a:spcAft>
+              <a:buNone/>
+            </a:pPr>
+            <a:r>
+              <a:rPr lang="en-US" sz="1600" dirty="0">
+                <a:solidFill>
+                  <a:srgbClr val="252525"/>
+                </a:solidFill>
+                <a:latin typeface="Calisto MT" panose="02040603050505030304" pitchFamily="18" charset="0"/>
+              </a:rPr>
+              <a:t>Genomic foundation models such as </a:t>
+            </a:r>
+            <a:r>
+              <a:rPr lang="en-US" sz="1600" b="1" dirty="0">
+                <a:solidFill>
+                  <a:srgbClr val="252525"/>
+                </a:solidFill>
+                <a:latin typeface="Calisto MT" panose="02040603050505030304" pitchFamily="18" charset="0"/>
+              </a:rPr>
+              <a:t>Evo 2</a:t>
+            </a:r>
+            <a:r>
+              <a:rPr lang="en-US" sz="1600" dirty="0">
+                <a:solidFill>
+                  <a:srgbClr val="252525"/>
+                </a:solidFill>
+                <a:latin typeface="Calisto MT" panose="02040603050505030304" pitchFamily="18" charset="0"/>
+              </a:rPr>
+              <a:t> and </a:t>
+            </a:r>
+            <a:r>
+              <a:rPr lang="en-US" sz="1600" b="1" dirty="0">
+                <a:solidFill>
+                  <a:srgbClr val="252525"/>
+                </a:solidFill>
+                <a:latin typeface="Calisto MT" panose="02040603050505030304" pitchFamily="18" charset="0"/>
+              </a:rPr>
+              <a:t>Caduceus</a:t>
+            </a:r>
+            <a:r>
+              <a:rPr lang="en-US" sz="1600" dirty="0">
+                <a:solidFill>
+                  <a:srgbClr val="252525"/>
+                </a:solidFill>
+                <a:latin typeface="Calisto MT" panose="02040603050505030304" pitchFamily="18" charset="0"/>
+              </a:rPr>
+              <a:t> learn powerful representations of DNA, yet they read the genome as a one-dimensional string. Inside the nucleus, chromatin folds into compartments, </a:t>
+            </a:r>
+            <a:r>
+              <a:rPr lang="en-US" sz="1600" b="1" dirty="0">
+                <a:solidFill>
+                  <a:srgbClr val="252525"/>
+                </a:solidFill>
+                <a:latin typeface="Calisto MT" panose="02040603050505030304" pitchFamily="18" charset="0"/>
+              </a:rPr>
+              <a:t>topologically associating domains (TADs)</a:t>
+            </a:r>
+            <a:r>
+              <a:rPr lang="en-US" sz="1600" dirty="0">
+                <a:solidFill>
+                  <a:srgbClr val="252525"/>
+                </a:solidFill>
+                <a:latin typeface="Calisto MT" panose="02040603050505030304" pitchFamily="18" charset="0"/>
+              </a:rPr>
+              <a:t> and </a:t>
+            </a:r>
+            <a:r>
+              <a:rPr lang="en-US" sz="1600" b="1" dirty="0">
+                <a:solidFill>
+                  <a:srgbClr val="252525"/>
+                </a:solidFill>
+                <a:latin typeface="Calisto MT" panose="02040603050505030304" pitchFamily="18" charset="0"/>
+              </a:rPr>
+              <a:t>loops</a:t>
+            </a:r>
+            <a:r>
+              <a:rPr lang="en-US" sz="1600" dirty="0">
+                <a:solidFill>
+                  <a:srgbClr val="252525"/>
+                </a:solidFill>
+                <a:latin typeface="Calisto MT" panose="02040603050505030304" pitchFamily="18" charset="0"/>
+              </a:rPr>
+              <a:t> that physically decide which enhancers can reach which promoters and recent probing shows that even a 7-billion-parameter sequence-only model fails to capture this higher-order organization. Existing structure-aware methods bolt a graph module onto an already-trained encoder (</a:t>
+            </a:r>
+            <a:r>
+              <a:rPr lang="en-US" sz="1600" b="1" dirty="0">
+                <a:solidFill>
+                  <a:srgbClr val="252525"/>
+                </a:solidFill>
+                <a:latin typeface="Calisto MT" panose="02040603050505030304" pitchFamily="18" charset="0"/>
+              </a:rPr>
+              <a:t>CHROME</a:t>
+            </a:r>
+            <a:r>
+              <a:rPr lang="en-US" sz="1600" dirty="0">
+                <a:solidFill>
+                  <a:srgbClr val="252525"/>
+                </a:solidFill>
+                <a:latin typeface="Calisto MT" panose="02040603050505030304" pitchFamily="18" charset="0"/>
+              </a:rPr>
+              <a:t>) or align embeddings to Hi-C patches by contrastive distillation (</a:t>
+            </a:r>
+            <a:r>
+              <a:rPr lang="en-US" sz="1600" b="1" dirty="0">
+                <a:solidFill>
+                  <a:srgbClr val="252525"/>
+                </a:solidFill>
+                <a:latin typeface="Calisto MT" panose="02040603050505030304" pitchFamily="18" charset="0"/>
+              </a:rPr>
+              <a:t>Evo2HiC</a:t>
+            </a:r>
+            <a:r>
+              <a:rPr lang="en-US" sz="1600" dirty="0">
+                <a:solidFill>
+                  <a:srgbClr val="252525"/>
+                </a:solidFill>
+                <a:latin typeface="Calisto MT" panose="02040603050505030304" pitchFamily="18" charset="0"/>
+              </a:rPr>
+              <a:t>); in no published model does 3D structure shape a </a:t>
+            </a:r>
+            <a:r>
+              <a:rPr lang="en-US" sz="1600" b="1" dirty="0">
+                <a:solidFill>
+                  <a:srgbClr val="252525"/>
+                </a:solidFill>
+                <a:latin typeface="Calisto MT" panose="02040603050505030304" pitchFamily="18" charset="0"/>
+              </a:rPr>
+              <a:t>self-supervised pretraining objective</a:t>
+            </a:r>
+            <a:r>
+              <a:rPr lang="en-US" sz="1600" dirty="0">
+                <a:solidFill>
+                  <a:srgbClr val="252525"/>
+                </a:solidFill>
+                <a:latin typeface="Calisto MT" panose="02040603050505030304" pitchFamily="18" charset="0"/>
+              </a:rPr>
+              <a:t> over nucleotides. This project fills that gap: a </a:t>
+            </a:r>
+            <a:r>
+              <a:rPr lang="en-US" sz="1600" b="1" dirty="0">
+                <a:solidFill>
+                  <a:srgbClr val="252525"/>
+                </a:solidFill>
+                <a:latin typeface="Calisto MT" panose="02040603050505030304" pitchFamily="18" charset="0"/>
+              </a:rPr>
+              <a:t>bidirectional Mamba DNA language model</a:t>
+            </a:r>
+            <a:r>
+              <a:rPr lang="en-US" sz="1600" dirty="0">
+                <a:solidFill>
+                  <a:srgbClr val="252525"/>
+                </a:solidFill>
+                <a:latin typeface="Calisto MT" panose="02040603050505030304" pitchFamily="18" charset="0"/>
+              </a:rPr>
+              <a:t> whose recurrence is modulated by </a:t>
+            </a:r>
+            <a:r>
+              <a:rPr lang="en-US" sz="1600" b="1" dirty="0">
+                <a:solidFill>
+                  <a:srgbClr val="252525"/>
+                </a:solidFill>
+                <a:latin typeface="Calisto MT" panose="02040603050505030304" pitchFamily="18" charset="0"/>
+              </a:rPr>
+              <a:t>Hi-C-derived structural features</a:t>
+            </a:r>
+            <a:r>
+              <a:rPr lang="en-US" sz="1600" dirty="0">
+                <a:solidFill>
+                  <a:srgbClr val="252525"/>
+                </a:solidFill>
+                <a:latin typeface="Calisto MT" panose="02040603050505030304" pitchFamily="18" charset="0"/>
+              </a:rPr>
+              <a:t>, so that structure controls how far information propagates during </a:t>
+            </a:r>
+            <a:r>
+              <a:rPr lang="en-US" sz="1600" b="1" dirty="0">
+                <a:solidFill>
+                  <a:srgbClr val="252525"/>
+                </a:solidFill>
+                <a:latin typeface="Calisto MT" panose="02040603050505030304" pitchFamily="18" charset="0"/>
+              </a:rPr>
+              <a:t>masked-token pretraining</a:t>
+            </a:r>
+            <a:r>
+              <a:rPr lang="en-US" sz="1600" dirty="0">
+                <a:solidFill>
+                  <a:srgbClr val="252525"/>
+                </a:solidFill>
+                <a:latin typeface="Calisto MT" panose="02040603050505030304" pitchFamily="18" charset="0"/>
+              </a:rPr>
+              <a:t>. On a GM12878 chromosome-9 pilot, the model is compared against sequence-only, post-hoc and distillation arms at </a:t>
+            </a:r>
+            <a:r>
+              <a:rPr lang="en-US" sz="1600" b="1" dirty="0">
+                <a:solidFill>
+                  <a:srgbClr val="252525"/>
+                </a:solidFill>
+                <a:latin typeface="Calisto MT" panose="02040603050505030304" pitchFamily="18" charset="0"/>
+              </a:rPr>
+              <a:t>matched parameters (+0.43%) and compute</a:t>
+            </a:r>
+            <a:r>
+              <a:rPr lang="en-US" sz="1600" dirty="0">
+                <a:solidFill>
+                  <a:srgbClr val="252525"/>
+                </a:solidFill>
+                <a:latin typeface="Calisto MT" panose="02040603050505030304" pitchFamily="18" charset="0"/>
+              </a:rPr>
+              <a:t>, with </a:t>
+            </a:r>
+            <a:r>
+              <a:rPr lang="en-US" sz="1600" b="1" dirty="0">
+                <a:solidFill>
+                  <a:srgbClr val="252525"/>
+                </a:solidFill>
+                <a:latin typeface="Calisto MT" panose="02040603050505030304" pitchFamily="18" charset="0"/>
+              </a:rPr>
+              <a:t>shuffled-structure controls</a:t>
+            </a:r>
+            <a:r>
+              <a:rPr lang="en-US" sz="1600" dirty="0">
+                <a:solidFill>
+                  <a:srgbClr val="252525"/>
+                </a:solidFill>
+                <a:latin typeface="Calisto MT" panose="02040603050505030304" pitchFamily="18" charset="0"/>
+              </a:rPr>
+              <a:t> verifying that gains reflect genuine 3D structure rather than genomic distance.</a:t>
+            </a:r>
+          </a:p>
+          <a:p>
+            <a:pPr marL="0" lvl="0" indent="0" algn="just">
+              <a:buNone/>
+            </a:pPr>
+            <a:r>
+              <a:rPr lang="en-US" sz="1600" b="1" dirty="0">
+                <a:solidFill>
+                  <a:srgbClr val="833C00"/>
+                </a:solidFill>
+                <a:latin typeface="Calisto MT" panose="02040603050505030304" pitchFamily="18" charset="0"/>
+              </a:rPr>
+              <a:t>Keywords: </a:t>
+            </a:r>
+            <a:r>
+              <a:rPr lang="en-US" sz="1600" i="1" dirty="0">
+                <a:solidFill>
+                  <a:srgbClr val="252525"/>
+                </a:solidFill>
+                <a:latin typeface="Calisto MT" panose="02040603050505030304" pitchFamily="18" charset="0"/>
+              </a:rPr>
+              <a:t>genomic foundation model; 3D chromatin structure; Hi-C; topologically associating domains; state space models (Mamba); self-supervised pretraining; variant effect prediction</a:t>
+            </a:r>
+          </a:p>
+        </p:txBody>
+      </p:sp>
+      <p:sp>
+        <p:nvSpPr>
+          <p:cNvPr id="5" name="Slide Number Placeholder 4">
+            <a:extLst>
+              <a:ext uri="{FF2B5EF4-FFF2-40B4-BE49-F238E27FC236}">
+                <a16:creationId xmlns:a16="http://schemas.microsoft.com/office/drawing/2014/main" id="{02E3089C-7D4B-76D0-EDD6-D1FEEE855B77}"/>
+              </a:ext>
+            </a:extLst>
+          </p:cNvPr>
+          <p:cNvSpPr>
+            <a:spLocks noGrp="1"/>
+          </p:cNvSpPr>
+          <p:nvPr>
+            <p:ph type="sldNum" sz="quarter" idx="12"/>
+          </p:nvPr>
+        </p:nvSpPr>
+        <p:spPr/>
+        <p:txBody>
+          <a:bodyPr/>
+          <a:lstStyle/>
+          <a:p>
+            <a:fld id="{D90542D4-23E8-43E0-BA8E-C972DA1A005D}" type="slidenum">
+              <a:rPr lang="en-US" sz="1400" b="1" smtClean="0">
+                <a:solidFill>
+                  <a:schemeClr val="tx1"/>
+                </a:solidFill>
+                <a:latin typeface="Calisto MT" panose="02040603050505030304" pitchFamily="18" charset="0"/>
+              </a:rPr>
+              <a:pPr/>
+              <a:t>2</a:t>
+            </a:fld>
+            <a:endParaRPr lang="en-US" sz="1400" b="1" dirty="0">
+              <a:solidFill>
+                <a:schemeClr val="tx1"/>
+              </a:solidFill>
+              <a:latin typeface="Calisto MT" panose="02040603050505030304" pitchFamily="18" charset="0"/>
+            </a:endParaRPr>
+          </a:p>
+        </p:txBody>
+      </p:sp>
+    </p:spTree>
+    <p:extLst>
+      <p:ext uri="{BB962C8B-B14F-4D97-AF65-F5344CB8AC3E}">
+        <p14:creationId xmlns:p14="http://schemas.microsoft.com/office/powerpoint/2010/main" val="3775680061"/>
       </p:ext>
     </p:extLst>
   </p:cSld>
@@ -6340,16 +7274,18 @@
         </p:nvSpPr>
         <p:spPr>
           <a:xfrm>
-            <a:off x="628650" y="214298"/>
-            <a:ext cx="7886700" cy="709530"/>
+            <a:off x="405352" y="120030"/>
+            <a:ext cx="7886700" cy="549273"/>
           </a:xfrm>
         </p:spPr>
         <p:txBody>
-          <a:bodyPr/>
+          <a:bodyPr>
+            <a:noAutofit/>
+          </a:bodyPr>
           <a:lstStyle/>
           <a:p>
             <a:r>
-              <a:rPr lang="en-US" sz="3600" b="1">
+              <a:rPr lang="en-US" b="1" dirty="0">
                 <a:solidFill>
                   <a:schemeClr val="accent2">
                     <a:lumMod val="50000"/>
@@ -6357,16 +7293,8 @@
                 </a:solidFill>
                 <a:latin typeface="Calisto MT" panose="02040603050505030304" pitchFamily="18" charset="0"/>
               </a:rPr>
-              <a:t>Abstract</a:t>
-            </a:r>
-            <a:endParaRPr lang="en-US" b="1" dirty="0">
-              <a:solidFill>
-                <a:schemeClr val="accent2">
-                  <a:lumMod val="50000"/>
-                </a:schemeClr>
-              </a:solidFill>
-              <a:latin typeface="Calisto MT" panose="02040603050505030304" pitchFamily="18" charset="0"/>
-            </a:endParaRPr>
+              <a:t>Presentation Outline</a:t>
+            </a:r>
           </a:p>
         </p:txBody>
       </p:sp>
@@ -6388,923 +7316,13 @@
         </p:nvSpPr>
         <p:spPr>
           <a:xfrm>
-            <a:off x="628649" y="1046376"/>
-            <a:ext cx="8062863" cy="5253135"/>
-          </a:xfrm>
-        </p:spPr>
-        <p:txBody>
-          <a:bodyPr>
-            <a:normAutofit/>
-          </a:bodyPr>
-          <a:lstStyle/>
-          <a:p>
-            <a:pPr marL="0" lvl="0" indent="0" algn="just">
-              <a:spcAft>
-                <a:spcPts val="800"/>
-              </a:spcAft>
-              <a:buNone/>
-            </a:pPr>
-            <a:r>
-              <a:rPr lang="en-US" sz="1500" dirty="0">
-                <a:solidFill>
-                  <a:srgbClr val="252525"/>
-                </a:solidFill>
-                <a:latin typeface="Calisto MT" panose="02040603050505030304" pitchFamily="18" charset="0"/>
-              </a:rPr>
-              <a:t xml:space="preserve">Genomic foundation models such as </a:t>
-            </a:r>
-            <a:r>
-              <a:rPr lang="en-US" sz="1500" b="1" dirty="0">
-                <a:solidFill>
-                  <a:srgbClr val="252525"/>
-                </a:solidFill>
-                <a:latin typeface="Calisto MT" panose="02040603050505030304" pitchFamily="18" charset="0"/>
-              </a:rPr>
-              <a:t>Evo 2</a:t>
-            </a:r>
-            <a:r>
-              <a:rPr lang="en-US" sz="1500" dirty="0">
-                <a:solidFill>
-                  <a:srgbClr val="252525"/>
-                </a:solidFill>
-                <a:latin typeface="Calisto MT" panose="02040603050505030304" pitchFamily="18" charset="0"/>
-              </a:rPr>
-              <a:t xml:space="preserve"> and </a:t>
-            </a:r>
-            <a:r>
-              <a:rPr lang="en-US" sz="1500" b="1" dirty="0">
-                <a:solidFill>
-                  <a:srgbClr val="252525"/>
-                </a:solidFill>
-                <a:latin typeface="Calisto MT" panose="02040603050505030304" pitchFamily="18" charset="0"/>
-              </a:rPr>
-              <a:t>Caduceus</a:t>
-            </a:r>
-            <a:r>
-              <a:rPr lang="en-US" sz="1500" dirty="0">
-                <a:solidFill>
-                  <a:srgbClr val="252525"/>
-                </a:solidFill>
-                <a:latin typeface="Calisto MT" panose="02040603050505030304" pitchFamily="18" charset="0"/>
-              </a:rPr>
-              <a:t xml:space="preserve"> learn powerful representations of DNA, yet they read the genome as a one-dimensional string. Inside the nucleus, chromatin folds into compartments, </a:t>
-            </a:r>
-            <a:r>
-              <a:rPr lang="en-US" sz="1500" b="1" dirty="0">
-                <a:solidFill>
-                  <a:srgbClr val="252525"/>
-                </a:solidFill>
-                <a:latin typeface="Calisto MT" panose="02040603050505030304" pitchFamily="18" charset="0"/>
-              </a:rPr>
-              <a:t>topologically associating domains (TADs)</a:t>
-            </a:r>
-            <a:r>
-              <a:rPr lang="en-US" sz="1500" dirty="0">
-                <a:solidFill>
-                  <a:srgbClr val="252525"/>
-                </a:solidFill>
-                <a:latin typeface="Calisto MT" panose="02040603050505030304" pitchFamily="18" charset="0"/>
-              </a:rPr>
-              <a:t xml:space="preserve"> and </a:t>
-            </a:r>
-            <a:r>
-              <a:rPr lang="en-US" sz="1500" b="1" dirty="0">
-                <a:solidFill>
-                  <a:srgbClr val="252525"/>
-                </a:solidFill>
-                <a:latin typeface="Calisto MT" panose="02040603050505030304" pitchFamily="18" charset="0"/>
-              </a:rPr>
-              <a:t>loops</a:t>
-            </a:r>
-            <a:r>
-              <a:rPr lang="en-US" sz="1500" dirty="0">
-                <a:solidFill>
-                  <a:srgbClr val="252525"/>
-                </a:solidFill>
-                <a:latin typeface="Calisto MT" panose="02040603050505030304" pitchFamily="18" charset="0"/>
-              </a:rPr>
-              <a:t xml:space="preserve"> that physically decide which enhancers can reach which promoters — and recent probing shows that even a 7-billion-parameter sequence-only model fails to capture this higher-order organization. Existing structure-aware methods bolt a graph module onto an already-trained encoder (</a:t>
-            </a:r>
-            <a:r>
-              <a:rPr lang="en-US" sz="1500" b="1" dirty="0">
-                <a:solidFill>
-                  <a:srgbClr val="252525"/>
-                </a:solidFill>
-                <a:latin typeface="Calisto MT" panose="02040603050505030304" pitchFamily="18" charset="0"/>
-              </a:rPr>
-              <a:t>CHROME</a:t>
-            </a:r>
-            <a:r>
-              <a:rPr lang="en-US" sz="1500" dirty="0">
-                <a:solidFill>
-                  <a:srgbClr val="252525"/>
-                </a:solidFill>
-                <a:latin typeface="Calisto MT" panose="02040603050505030304" pitchFamily="18" charset="0"/>
-              </a:rPr>
-              <a:t>) or align embeddings to Hi-C patches by contrastive distillation (</a:t>
-            </a:r>
-            <a:r>
-              <a:rPr lang="en-US" sz="1500" b="1" dirty="0">
-                <a:solidFill>
-                  <a:srgbClr val="252525"/>
-                </a:solidFill>
-                <a:latin typeface="Calisto MT" panose="02040603050505030304" pitchFamily="18" charset="0"/>
-              </a:rPr>
-              <a:t>Evo2HiC</a:t>
-            </a:r>
-            <a:r>
-              <a:rPr lang="en-US" sz="1500" dirty="0">
-                <a:solidFill>
-                  <a:srgbClr val="252525"/>
-                </a:solidFill>
-                <a:latin typeface="Calisto MT" panose="02040603050505030304" pitchFamily="18" charset="0"/>
-              </a:rPr>
-              <a:t xml:space="preserve">); in no published model does 3D structure shape a </a:t>
-            </a:r>
-            <a:r>
-              <a:rPr lang="en-US" sz="1500" b="1" dirty="0">
-                <a:solidFill>
-                  <a:srgbClr val="252525"/>
-                </a:solidFill>
-                <a:latin typeface="Calisto MT" panose="02040603050505030304" pitchFamily="18" charset="0"/>
-              </a:rPr>
-              <a:t>self-supervised pretraining objective</a:t>
-            </a:r>
-            <a:r>
-              <a:rPr lang="en-US" sz="1500" dirty="0">
-                <a:solidFill>
-                  <a:srgbClr val="252525"/>
-                </a:solidFill>
-                <a:latin typeface="Calisto MT" panose="02040603050505030304" pitchFamily="18" charset="0"/>
-              </a:rPr>
-              <a:t xml:space="preserve"> over nucleotides. This project fills that gap: a </a:t>
-            </a:r>
-            <a:r>
-              <a:rPr lang="en-US" sz="1500" b="1" dirty="0">
-                <a:solidFill>
-                  <a:srgbClr val="252525"/>
-                </a:solidFill>
-                <a:latin typeface="Calisto MT" panose="02040603050505030304" pitchFamily="18" charset="0"/>
-              </a:rPr>
-              <a:t>bidirectional Mamba DNA language model</a:t>
-            </a:r>
-            <a:r>
-              <a:rPr lang="en-US" sz="1500" dirty="0">
-                <a:solidFill>
-                  <a:srgbClr val="252525"/>
-                </a:solidFill>
-                <a:latin typeface="Calisto MT" panose="02040603050505030304" pitchFamily="18" charset="0"/>
-              </a:rPr>
-              <a:t xml:space="preserve"> whose recurrence is modulated by </a:t>
-            </a:r>
-            <a:r>
-              <a:rPr lang="en-US" sz="1500" b="1" dirty="0">
-                <a:solidFill>
-                  <a:srgbClr val="252525"/>
-                </a:solidFill>
-                <a:latin typeface="Calisto MT" panose="02040603050505030304" pitchFamily="18" charset="0"/>
-              </a:rPr>
-              <a:t>Hi-C-derived structural features</a:t>
-            </a:r>
-            <a:r>
-              <a:rPr lang="en-US" sz="1500" dirty="0">
-                <a:solidFill>
-                  <a:srgbClr val="252525"/>
-                </a:solidFill>
-                <a:latin typeface="Calisto MT" panose="02040603050505030304" pitchFamily="18" charset="0"/>
-              </a:rPr>
-              <a:t xml:space="preserve">, so that structure controls how far information propagates during </a:t>
-            </a:r>
-            <a:r>
-              <a:rPr lang="en-US" sz="1500" b="1" dirty="0">
-                <a:solidFill>
-                  <a:srgbClr val="252525"/>
-                </a:solidFill>
-                <a:latin typeface="Calisto MT" panose="02040603050505030304" pitchFamily="18" charset="0"/>
-              </a:rPr>
-              <a:t>masked-token pretraining</a:t>
-            </a:r>
-            <a:r>
-              <a:rPr lang="en-US" sz="1500" dirty="0">
-                <a:solidFill>
-                  <a:srgbClr val="252525"/>
-                </a:solidFill>
-                <a:latin typeface="Calisto MT" panose="02040603050505030304" pitchFamily="18" charset="0"/>
-              </a:rPr>
-              <a:t xml:space="preserve">. On a GM12878 chromosome-9 pilot, the model is compared against sequence-only, post-hoc and distillation arms at </a:t>
-            </a:r>
-            <a:r>
-              <a:rPr lang="en-US" sz="1500" b="1" dirty="0">
-                <a:solidFill>
-                  <a:srgbClr val="252525"/>
-                </a:solidFill>
-                <a:latin typeface="Calisto MT" panose="02040603050505030304" pitchFamily="18" charset="0"/>
-              </a:rPr>
-              <a:t>matched parameters (+0.43%) and compute</a:t>
-            </a:r>
-            <a:r>
-              <a:rPr lang="en-US" sz="1500" dirty="0">
-                <a:solidFill>
-                  <a:srgbClr val="252525"/>
-                </a:solidFill>
-                <a:latin typeface="Calisto MT" panose="02040603050505030304" pitchFamily="18" charset="0"/>
-              </a:rPr>
-              <a:t xml:space="preserve">, with </a:t>
-            </a:r>
-            <a:r>
-              <a:rPr lang="en-US" sz="1500" b="1" dirty="0">
-                <a:solidFill>
-                  <a:srgbClr val="252525"/>
-                </a:solidFill>
-                <a:latin typeface="Calisto MT" panose="02040603050505030304" pitchFamily="18" charset="0"/>
-              </a:rPr>
-              <a:t>shuffled-structure controls</a:t>
-            </a:r>
-            <a:r>
-              <a:rPr lang="en-US" sz="1500" dirty="0">
-                <a:solidFill>
-                  <a:srgbClr val="252525"/>
-                </a:solidFill>
-                <a:latin typeface="Calisto MT" panose="02040603050505030304" pitchFamily="18" charset="0"/>
-              </a:rPr>
-              <a:t xml:space="preserve"> verifying that gains reflect genuine 3D structure rather than genomic distance.</a:t>
-            </a:r>
-          </a:p>
-          <a:p>
-            <a:pPr marL="0" lvl="0" indent="0" algn="just">
-              <a:buNone/>
-            </a:pPr>
-            <a:r>
-              <a:rPr lang="en-US" sz="1500" b="1" dirty="0">
-                <a:solidFill>
-                  <a:srgbClr val="833C00"/>
-                </a:solidFill>
-                <a:latin typeface="Calisto MT" panose="02040603050505030304" pitchFamily="18" charset="0"/>
-              </a:rPr>
-              <a:t xml:space="preserve">Keywords: </a:t>
-            </a:r>
-            <a:r>
-              <a:rPr lang="en-US" sz="1500" i="1" dirty="0">
-                <a:solidFill>
-                  <a:srgbClr val="252525"/>
-                </a:solidFill>
-                <a:latin typeface="Calisto MT" panose="02040603050505030304" pitchFamily="18" charset="0"/>
-              </a:rPr>
-              <a:t>genomic foundation model; 3D chromatin structure; Hi-C; topologically associating domains; state space models (Mamba); self-supervised pretraining; variant effect prediction</a:t>
-            </a:r>
-          </a:p>
-        </p:txBody>
-      </p:sp>
-      <p:sp>
-        <p:nvSpPr>
-          <p:cNvPr id="5" name="Slide Number Placeholder 4">
-            <a:extLst>
-              <a:ext uri="{FF2B5EF4-FFF2-40B4-BE49-F238E27FC236}">
-                <a16:creationId xmlns:a16="http://schemas.microsoft.com/office/drawing/2014/main" id="{02E3089C-7D4B-76D0-EDD6-D1FEEE855B77}"/>
-              </a:ext>
-            </a:extLst>
-          </p:cNvPr>
-          <p:cNvSpPr>
-            <a:spLocks noGrp="1"/>
-          </p:cNvSpPr>
-          <p:nvPr>
-            <p:ph type="sldNum" sz="quarter" idx="12"/>
-          </p:nvPr>
-        </p:nvSpPr>
-        <p:spPr/>
-        <p:txBody>
-          <a:bodyPr/>
-          <a:lstStyle/>
-          <a:p>
-            <a:fld id="{D90542D4-23E8-43E0-BA8E-C972DA1A005D}" type="slidenum">
-              <a:rPr lang="en-US" sz="1400" b="1" smtClean="0">
-                <a:solidFill>
-                  <a:schemeClr val="tx1"/>
-                </a:solidFill>
-                <a:latin typeface="Calisto MT" panose="02040603050505030304" pitchFamily="18" charset="0"/>
-              </a:rPr>
-              <a:pPr/>
-              <a:t>3</a:t>
-            </a:fld>
-            <a:endParaRPr lang="en-US" sz="1400" b="1" dirty="0">
-              <a:solidFill>
-                <a:schemeClr val="tx1"/>
-              </a:solidFill>
-              <a:latin typeface="Calisto MT" panose="02040603050505030304" pitchFamily="18" charset="0"/>
-            </a:endParaRPr>
-          </a:p>
-        </p:txBody>
-      </p:sp>
-    </p:spTree>
-    <p:extLst>
-      <p:ext uri="{BB962C8B-B14F-4D97-AF65-F5344CB8AC3E}">
-        <p14:creationId xmlns:p14="http://schemas.microsoft.com/office/powerpoint/2010/main" val="3775680061"/>
-      </p:ext>
-    </p:extLst>
-  </p:cSld>
-  <p:clrMapOvr>
-    <a:masterClrMapping/>
-  </p:clrMapOvr>
-</p:sld>
-</file>
-
-<file path=ppt/slides/slide38.xml><?xml version="1.0" encoding="utf-8"?>
-<p:sld xmlns:a="http://schemas.openxmlformats.org/drawingml/2006/main" xmlns:r="http://schemas.openxmlformats.org/officeDocument/2006/relationships" xmlns:p="http://schemas.openxmlformats.org/presentationml/2006/main">
-  <p:cSld>
-    <p:spTree>
-      <p:nvGrpSpPr>
-        <p:cNvPr id="1" name=""/>
-        <p:cNvGrpSpPr/>
-        <p:nvPr/>
-      </p:nvGrpSpPr>
-      <p:grpSpPr>
-        <a:xfrm>
-          <a:off x="0" y="0"/>
-          <a:ext cx="0" cy="0"/>
-          <a:chOff x="0" y="0"/>
-          <a:chExt cx="0" cy="0"/>
-        </a:xfrm>
-      </p:grpSpPr>
-      <p:sp>
-        <p:nvSpPr>
-          <p:cNvPr id="2" name="Title 1">
-            <a:extLst>
-              <a:ext uri="{FF2B5EF4-FFF2-40B4-BE49-F238E27FC236}">
-                <a16:creationId xmlns:a16="http://schemas.microsoft.com/office/drawing/2014/main" id="{5B738971-B764-E045-F92B-01E3322A0123}"/>
-              </a:ext>
-            </a:extLst>
-          </p:cNvPr>
-          <p:cNvSpPr>
-            <a:spLocks noGrp="1"/>
-          </p:cNvSpPr>
-          <p:nvPr>
-            <p:ph type="title"/>
-          </p:nvPr>
-        </p:nvSpPr>
-        <p:spPr>
-          <a:xfrm>
-            <a:off x="399166" y="155378"/>
-            <a:ext cx="8006303" cy="549273"/>
-          </a:xfrm>
-        </p:spPr>
-        <p:txBody>
-          <a:bodyPr>
-            <a:normAutofit fontScale="90000"/>
-          </a:bodyPr>
-          <a:lstStyle/>
-          <a:p>
-            <a:r>
-              <a:rPr lang="en-US" sz="4000" b="1" dirty="0">
-                <a:solidFill>
-                  <a:schemeClr val="accent2">
-                    <a:lumMod val="50000"/>
-                  </a:schemeClr>
-                </a:solidFill>
-                <a:latin typeface="Calisto MT" panose="02040603050505030304" pitchFamily="18" charset="0"/>
-              </a:rPr>
-              <a:t>References</a:t>
-            </a:r>
-          </a:p>
-        </p:txBody>
-      </p:sp>
-      <p:sp>
-        <p:nvSpPr>
-          <p:cNvPr id="3" name="Content Placeholder 2">
-            <a:extLst>
-              <a:ext uri="{FF2B5EF4-FFF2-40B4-BE49-F238E27FC236}">
-                <a16:creationId xmlns:a16="http://schemas.microsoft.com/office/drawing/2014/main" id="{E5D502BE-F636-7D1D-85F0-BAFFD3E05E1C}"/>
-              </a:ext>
-            </a:extLst>
-          </p:cNvPr>
-          <p:cNvSpPr>
-            <a:spLocks noGrp="1"/>
-          </p:cNvSpPr>
-          <p:nvPr>
-            <p:ph idx="1"/>
-          </p:nvPr>
-        </p:nvSpPr>
-        <p:spPr>
-          <a:xfrm>
-            <a:off x="509047" y="790756"/>
-            <a:ext cx="8006303" cy="5748157"/>
-          </a:xfrm>
-        </p:spPr>
-        <p:txBody>
-          <a:bodyPr numCol="1">
-            <a:normAutofit/>
-          </a:bodyPr>
-          <a:lstStyle/>
-          <a:p>
-            <a:pPr marL="342900" lvl="0" indent="-342900" algn="l">
-              <a:spcAft>
-                <a:spcPts val="280"/>
-              </a:spcAft>
-              <a:buNone/>
-            </a:pPr>
-            <a:r>
-              <a:rPr lang="en-US" sz="1200" b="1" dirty="0">
-                <a:solidFill>
-                  <a:srgbClr val="252525"/>
-                </a:solidFill>
-                <a:latin typeface="Calisto MT" panose="02040603050505030304" pitchFamily="18" charset="0"/>
-              </a:rPr>
-              <a:t xml:space="preserve">[1] </a:t>
-            </a:r>
-            <a:r>
-              <a:rPr lang="en-US" sz="1200" dirty="0">
-                <a:solidFill>
-                  <a:srgbClr val="252525"/>
-                </a:solidFill>
-                <a:latin typeface="Calisto MT" panose="02040603050505030304" pitchFamily="18" charset="0"/>
-              </a:rPr>
-              <a:t>Lieberman-Aiden, E., et al. (2009). Comprehensive mapping of long-range interactions reveals folding principles of the human genome. Science, 326(5950), 289–293.</a:t>
-            </a:r>
-          </a:p>
-          <a:p>
-            <a:pPr marL="342900" lvl="0" indent="-342900" algn="l">
-              <a:spcAft>
-                <a:spcPts val="280"/>
-              </a:spcAft>
-              <a:buNone/>
-            </a:pPr>
-            <a:r>
-              <a:rPr lang="en-US" sz="1200" b="1" dirty="0">
-                <a:solidFill>
-                  <a:srgbClr val="252525"/>
-                </a:solidFill>
-                <a:latin typeface="Calisto MT" panose="02040603050505030304" pitchFamily="18" charset="0"/>
-              </a:rPr>
-              <a:t xml:space="preserve">[2] </a:t>
-            </a:r>
-            <a:r>
-              <a:rPr lang="en-US" sz="1200" dirty="0">
-                <a:solidFill>
-                  <a:srgbClr val="252525"/>
-                </a:solidFill>
-                <a:latin typeface="Calisto MT" panose="02040603050505030304" pitchFamily="18" charset="0"/>
-              </a:rPr>
-              <a:t>Dixon, J. R., et al. (2012). Topological domains in mammalian genomes identified by analysis of chromatin interactions. Nature, 485, 376–380.</a:t>
-            </a:r>
-          </a:p>
-          <a:p>
-            <a:pPr marL="342900" lvl="0" indent="-342900" algn="l">
-              <a:spcAft>
-                <a:spcPts val="280"/>
-              </a:spcAft>
-              <a:buNone/>
-            </a:pPr>
-            <a:r>
-              <a:rPr lang="en-US" sz="1200" b="1" dirty="0">
-                <a:solidFill>
-                  <a:srgbClr val="252525"/>
-                </a:solidFill>
-                <a:latin typeface="Calisto MT" panose="02040603050505030304" pitchFamily="18" charset="0"/>
-              </a:rPr>
-              <a:t xml:space="preserve">[3] </a:t>
-            </a:r>
-            <a:r>
-              <a:rPr lang="en-US" sz="1200" dirty="0">
-                <a:solidFill>
-                  <a:srgbClr val="252525"/>
-                </a:solidFill>
-                <a:latin typeface="Calisto MT" panose="02040603050505030304" pitchFamily="18" charset="0"/>
-              </a:rPr>
-              <a:t>Rao, S. S. P., et al. (2014). A 3D map of the human genome at kilobase resolution reveals principles of chromatin looping. Cell, 159(7), 1665–1680.</a:t>
-            </a:r>
-          </a:p>
-          <a:p>
-            <a:pPr marL="342900" lvl="0" indent="-342900" algn="l">
-              <a:spcAft>
-                <a:spcPts val="280"/>
-              </a:spcAft>
-              <a:buNone/>
-            </a:pPr>
-            <a:r>
-              <a:rPr lang="en-US" sz="1200" b="1" dirty="0">
-                <a:solidFill>
-                  <a:srgbClr val="252525"/>
-                </a:solidFill>
-                <a:latin typeface="Calisto MT" panose="02040603050505030304" pitchFamily="18" charset="0"/>
-              </a:rPr>
-              <a:t xml:space="preserve">[4] </a:t>
-            </a:r>
-            <a:r>
-              <a:rPr lang="en-US" sz="1200" dirty="0">
-                <a:solidFill>
-                  <a:srgbClr val="252525"/>
-                </a:solidFill>
-                <a:latin typeface="Calisto MT" panose="02040603050505030304" pitchFamily="18" charset="0"/>
-              </a:rPr>
-              <a:t>Schiff, Y., Kao, C.-H., et al. (2024). Caduceus: Bi-directional equivariant long-range DNA sequence modeling. Proceedings of ICML 2024, PMLR 235. arXiv:2403.03234.</a:t>
-            </a:r>
-          </a:p>
-          <a:p>
-            <a:pPr marL="342900" lvl="0" indent="-342900" algn="l">
-              <a:spcAft>
-                <a:spcPts val="280"/>
-              </a:spcAft>
-              <a:buNone/>
-            </a:pPr>
-            <a:r>
-              <a:rPr lang="en-US" sz="1200" b="1" dirty="0">
-                <a:solidFill>
-                  <a:srgbClr val="252525"/>
-                </a:solidFill>
-                <a:latin typeface="Calisto MT" panose="02040603050505030304" pitchFamily="18" charset="0"/>
-              </a:rPr>
-              <a:t xml:space="preserve">[5] </a:t>
-            </a:r>
-            <a:r>
-              <a:rPr lang="en-US" sz="1200" dirty="0">
-                <a:solidFill>
-                  <a:srgbClr val="252525"/>
-                </a:solidFill>
-                <a:latin typeface="Calisto MT" panose="02040603050505030304" pitchFamily="18" charset="0"/>
-              </a:rPr>
-              <a:t>Brixi, G., et al. (2026). Genome modelling and design across all domains of life with Evo 2. Nature. (Preprint: bioRxiv 10.1101/2025.02.18.638918).</a:t>
-            </a:r>
-          </a:p>
-          <a:p>
-            <a:pPr marL="342900" lvl="0" indent="-342900" algn="l">
-              <a:spcAft>
-                <a:spcPts val="280"/>
-              </a:spcAft>
-              <a:buNone/>
-            </a:pPr>
-            <a:r>
-              <a:rPr lang="en-US" sz="1200" b="1" dirty="0">
-                <a:solidFill>
-                  <a:srgbClr val="252525"/>
-                </a:solidFill>
-                <a:latin typeface="Calisto MT" panose="02040603050505030304" pitchFamily="18" charset="0"/>
-              </a:rPr>
-              <a:t xml:space="preserve">[6] </a:t>
-            </a:r>
-            <a:r>
-              <a:rPr lang="en-US" sz="1200" dirty="0">
-                <a:solidFill>
-                  <a:srgbClr val="252525"/>
-                </a:solidFill>
-                <a:latin typeface="Calisto MT" panose="02040603050505030304" pitchFamily="18" charset="0"/>
-              </a:rPr>
-              <a:t>Wang, X., et al. (2026). A generalizable Hi-C foundation model for chromatin architecture, single-cell and multi-omics analysis across species. Nature Methods. (Preprint: bioRxiv 10.1101/2024.12.16.628821).</a:t>
-            </a:r>
-          </a:p>
-          <a:p>
-            <a:pPr marL="342900" lvl="0" indent="-342900" algn="l">
-              <a:spcAft>
-                <a:spcPts val="280"/>
-              </a:spcAft>
-              <a:buNone/>
-            </a:pPr>
-            <a:r>
-              <a:rPr lang="en-US" sz="1200" b="1" dirty="0">
-                <a:solidFill>
-                  <a:srgbClr val="252525"/>
-                </a:solidFill>
-                <a:latin typeface="Calisto MT" panose="02040603050505030304" pitchFamily="18" charset="0"/>
-              </a:rPr>
-              <a:t xml:space="preserve">[7] </a:t>
-            </a:r>
-            <a:r>
-              <a:rPr lang="en-US" sz="1200" dirty="0">
-                <a:solidFill>
-                  <a:srgbClr val="252525"/>
-                </a:solidFill>
-                <a:latin typeface="Calisto MT" panose="02040603050505030304" pitchFamily="18" charset="0"/>
-              </a:rPr>
-              <a:t>Wu, X., Chen, X., &amp; Jiang, R. (2025). Hi-Cformer enables multi-scale chromatin contact map modeling for single-cell Hi-C data analysis. bioRxiv 10.1101/2025.08.04.668453.</a:t>
-            </a:r>
-          </a:p>
-          <a:p>
-            <a:pPr marL="342900" lvl="0" indent="-342900" algn="l">
-              <a:spcAft>
-                <a:spcPts val="280"/>
-              </a:spcAft>
-              <a:buNone/>
-            </a:pPr>
-            <a:r>
-              <a:rPr lang="en-US" sz="1200" b="1" dirty="0">
-                <a:solidFill>
-                  <a:srgbClr val="252525"/>
-                </a:solidFill>
-                <a:latin typeface="Calisto MT" panose="02040603050505030304" pitchFamily="18" charset="0"/>
-              </a:rPr>
-              <a:t xml:space="preserve">[8] </a:t>
-            </a:r>
-            <a:r>
-              <a:rPr lang="en-US" sz="1200" dirty="0">
-                <a:solidFill>
-                  <a:srgbClr val="252525"/>
-                </a:solidFill>
-                <a:latin typeface="Calisto MT" panose="02040603050505030304" pitchFamily="18" charset="0"/>
-              </a:rPr>
-              <a:t>Karbalayghareh, A., et al. (2022). Chromatin interaction–aware gene regulatory modeling with graph attention networks. Genome Research, 32(5), 930–944.</a:t>
-            </a:r>
-          </a:p>
-          <a:p>
-            <a:pPr marL="342900" lvl="0" indent="-342900" algn="l">
-              <a:spcAft>
-                <a:spcPts val="280"/>
-              </a:spcAft>
-              <a:buNone/>
-            </a:pPr>
-            <a:r>
-              <a:rPr lang="en-US" sz="1200" b="1" dirty="0">
-                <a:solidFill>
-                  <a:srgbClr val="252525"/>
-                </a:solidFill>
-                <a:latin typeface="Calisto MT" panose="02040603050505030304" pitchFamily="18" charset="0"/>
-              </a:rPr>
-              <a:t xml:space="preserve">[9] </a:t>
-            </a:r>
-            <a:r>
-              <a:rPr lang="en-US" sz="1200" dirty="0">
-                <a:solidFill>
-                  <a:srgbClr val="252525"/>
-                </a:solidFill>
-                <a:latin typeface="Calisto MT" panose="02040603050505030304" pitchFamily="18" charset="0"/>
-              </a:rPr>
-              <a:t>Ye, F., et al. (2026). A chromatin-structure-guided framework for predictive and interpretable regulatory genomics. Briefings in Bioinformatics, 27(4), bbag360.</a:t>
-            </a:r>
-          </a:p>
-          <a:p>
-            <a:pPr marL="342900" lvl="0" indent="-342900" algn="l">
-              <a:spcAft>
-                <a:spcPts val="280"/>
-              </a:spcAft>
-              <a:buNone/>
-            </a:pPr>
-            <a:r>
-              <a:rPr lang="en-US" sz="1200" b="1" dirty="0">
-                <a:solidFill>
-                  <a:srgbClr val="252525"/>
-                </a:solidFill>
-                <a:latin typeface="Calisto MT" panose="02040603050505030304" pitchFamily="18" charset="0"/>
-              </a:rPr>
-              <a:t xml:space="preserve">[10] </a:t>
-            </a:r>
-            <a:r>
-              <a:rPr lang="en-US" sz="1200" dirty="0">
-                <a:solidFill>
-                  <a:srgbClr val="252525"/>
-                </a:solidFill>
-                <a:latin typeface="Calisto MT" panose="02040603050505030304" pitchFamily="18" charset="0"/>
-              </a:rPr>
-              <a:t>Fang, T., Wang, X., Xiao, Z., et al. (2025). Evo2HiC: A multimodal foundation model for integrative analysis of genome sequence and architecture. bioRxiv 10.1101/2025.11.18.689171.</a:t>
-            </a:r>
-          </a:p>
-          <a:p>
-            <a:pPr marL="342900" lvl="0" indent="-342900" algn="l">
-              <a:spcAft>
-                <a:spcPts val="280"/>
-              </a:spcAft>
-              <a:buNone/>
-            </a:pPr>
-            <a:r>
-              <a:rPr lang="en-US" sz="1200" b="1" dirty="0">
-                <a:solidFill>
-                  <a:srgbClr val="252525"/>
-                </a:solidFill>
-                <a:latin typeface="Calisto MT" panose="02040603050505030304" pitchFamily="18" charset="0"/>
-              </a:rPr>
-              <a:t xml:space="preserve">[11] </a:t>
-            </a:r>
-            <a:r>
-              <a:rPr lang="en-US" sz="1200" dirty="0">
-                <a:solidFill>
-                  <a:srgbClr val="252525"/>
-                </a:solidFill>
-                <a:latin typeface="Calisto MT" panose="02040603050505030304" pitchFamily="18" charset="0"/>
-              </a:rPr>
-              <a:t>Fudenberg, G., Kelley, D. R., &amp; Pollard, K. S. (2020). Predicting 3D genome folding from DNA sequence with Akita. Nature Methods, 17, 1111–1117.</a:t>
-            </a:r>
-          </a:p>
-          <a:p>
-            <a:pPr marL="342900" lvl="0" indent="-342900" algn="l">
-              <a:spcAft>
-                <a:spcPts val="280"/>
-              </a:spcAft>
-              <a:buNone/>
-            </a:pPr>
-            <a:r>
-              <a:rPr lang="en-US" sz="1200" b="1" dirty="0">
-                <a:solidFill>
-                  <a:srgbClr val="252525"/>
-                </a:solidFill>
-                <a:latin typeface="Calisto MT" panose="02040603050505030304" pitchFamily="18" charset="0"/>
-              </a:rPr>
-              <a:t xml:space="preserve">[12] </a:t>
-            </a:r>
-            <a:r>
-              <a:rPr lang="en-US" sz="1200" dirty="0">
-                <a:solidFill>
-                  <a:srgbClr val="252525"/>
-                </a:solidFill>
-                <a:latin typeface="Calisto MT" panose="02040603050505030304" pitchFamily="18" charset="0"/>
-              </a:rPr>
-              <a:t>Zhou, J. (2022). Sequence-based modeling of three-dimensional genome architecture from kilobase to chromosome scale. Nature Genetics, 54, 725–734.</a:t>
-            </a:r>
-          </a:p>
-          <a:p>
-            <a:pPr marL="342900" lvl="0" indent="-342900" algn="l">
-              <a:spcAft>
-                <a:spcPts val="280"/>
-              </a:spcAft>
-              <a:buNone/>
-            </a:pPr>
-            <a:r>
-              <a:rPr lang="en-US" sz="1200" b="1" dirty="0">
-                <a:solidFill>
-                  <a:srgbClr val="252525"/>
-                </a:solidFill>
-                <a:latin typeface="Calisto MT" panose="02040603050505030304" pitchFamily="18" charset="0"/>
-              </a:rPr>
-              <a:t xml:space="preserve">[13] </a:t>
-            </a:r>
-            <a:r>
-              <a:rPr lang="en-US" sz="1200" dirty="0">
-                <a:solidFill>
-                  <a:srgbClr val="252525"/>
-                </a:solidFill>
-                <a:latin typeface="Calisto MT" panose="02040603050505030304" pitchFamily="18" charset="0"/>
-              </a:rPr>
-              <a:t>Lee, U. (2026). Probing 3D chromatin structure awareness in Evo2 DNA language model. arXiv:2604.07196.</a:t>
-            </a:r>
-          </a:p>
-          <a:p>
-            <a:pPr marL="342900" lvl="0" indent="-342900" algn="l">
-              <a:spcAft>
-                <a:spcPts val="0"/>
-              </a:spcAft>
-              <a:buNone/>
-            </a:pPr>
-            <a:r>
-              <a:rPr lang="en-US" sz="1200" b="1" dirty="0">
-                <a:solidFill>
-                  <a:srgbClr val="252525"/>
-                </a:solidFill>
-                <a:latin typeface="Calisto MT" panose="02040603050505030304" pitchFamily="18" charset="0"/>
-              </a:rPr>
-              <a:t xml:space="preserve">[14] </a:t>
-            </a:r>
-            <a:r>
-              <a:rPr lang="en-US" sz="1200" dirty="0">
-                <a:solidFill>
-                  <a:srgbClr val="252525"/>
-                </a:solidFill>
-                <a:latin typeface="Calisto MT" panose="02040603050505030304" pitchFamily="18" charset="0"/>
-              </a:rPr>
-              <a:t>Cheng, W., et al. (2025). DNALongBench: A benchmark suite for long-range DNA prediction tasks. Nature Communications, 16(1), 10108.</a:t>
-            </a:r>
-          </a:p>
-        </p:txBody>
-      </p:sp>
-      <p:sp>
-        <p:nvSpPr>
-          <p:cNvPr id="6" name="Slide Number Placeholder 5">
-            <a:extLst>
-              <a:ext uri="{FF2B5EF4-FFF2-40B4-BE49-F238E27FC236}">
-                <a16:creationId xmlns:a16="http://schemas.microsoft.com/office/drawing/2014/main" id="{1F9ED706-BAAD-007D-D4CC-247F422DF465}"/>
-              </a:ext>
-            </a:extLst>
-          </p:cNvPr>
-          <p:cNvSpPr>
-            <a:spLocks noGrp="1"/>
-          </p:cNvSpPr>
-          <p:nvPr>
-            <p:ph type="sldNum" sz="quarter" idx="12"/>
-          </p:nvPr>
-        </p:nvSpPr>
-        <p:spPr/>
-        <p:txBody>
-          <a:bodyPr/>
-          <a:lstStyle/>
-          <a:p>
-            <a:fld id="{D90542D4-23E8-43E0-BA8E-C972DA1A005D}" type="slidenum">
-              <a:rPr lang="en-US" sz="1400" b="1" smtClean="0">
-                <a:solidFill>
-                  <a:schemeClr val="tx1"/>
-                </a:solidFill>
-                <a:latin typeface="Calisto MT" panose="02040603050505030304" pitchFamily="18" charset="0"/>
-              </a:rPr>
-              <a:pPr/>
-              <a:t>38</a:t>
-            </a:fld>
-            <a:endParaRPr lang="en-US" sz="1400" b="1" dirty="0">
-              <a:solidFill>
-                <a:schemeClr val="tx1"/>
-              </a:solidFill>
-              <a:latin typeface="Calisto MT" panose="02040603050505030304" pitchFamily="18" charset="0"/>
-            </a:endParaRPr>
-          </a:p>
-        </p:txBody>
-      </p:sp>
-    </p:spTree>
-    <p:extLst>
-      <p:ext uri="{BB962C8B-B14F-4D97-AF65-F5344CB8AC3E}">
-        <p14:creationId xmlns:p14="http://schemas.microsoft.com/office/powerpoint/2010/main" val="4037050892"/>
-      </p:ext>
-    </p:extLst>
-  </p:cSld>
-  <p:clrMapOvr>
-    <a:masterClrMapping/>
-  </p:clrMapOvr>
-</p:sld>
-</file>
-
-<file path=ppt/slides/slide4.xml><?xml version="1.0" encoding="utf-8"?>
-<p:sld xmlns:a="http://schemas.openxmlformats.org/drawingml/2006/main" xmlns:r="http://schemas.openxmlformats.org/officeDocument/2006/relationships" xmlns:p="http://schemas.openxmlformats.org/presentationml/2006/main">
-  <p:cSld>
-    <p:spTree>
-      <p:nvGrpSpPr>
-        <p:cNvPr id="1" name=""/>
-        <p:cNvGrpSpPr/>
-        <p:nvPr/>
-      </p:nvGrpSpPr>
-      <p:grpSpPr>
-        <a:xfrm>
-          <a:off x="0" y="0"/>
-          <a:ext cx="0" cy="0"/>
-          <a:chOff x="0" y="0"/>
-          <a:chExt cx="0" cy="0"/>
-        </a:xfrm>
-      </p:grpSpPr>
-      <p:sp>
-        <p:nvSpPr>
-          <p:cNvPr id="2" name="Title 1">
-            <a:extLst>
-              <a:ext uri="{FF2B5EF4-FFF2-40B4-BE49-F238E27FC236}">
-                <a16:creationId xmlns:a16="http://schemas.microsoft.com/office/drawing/2014/main" id="{5B738971-B764-E045-F92B-01E3322A0123}"/>
-              </a:ext>
-            </a:extLst>
-          </p:cNvPr>
-          <p:cNvSpPr>
-            <a:spLocks noGrp="1"/>
-          </p:cNvSpPr>
-          <p:nvPr>
-            <p:ph type="title"/>
-          </p:nvPr>
-        </p:nvSpPr>
-        <p:spPr>
-          <a:xfrm>
-            <a:off x="405352" y="120030"/>
-            <a:ext cx="7886700" cy="549273"/>
-          </a:xfrm>
-        </p:spPr>
-        <p:txBody>
-          <a:bodyPr>
-            <a:normAutofit fontScale="90000"/>
-          </a:bodyPr>
-          <a:lstStyle/>
-          <a:p>
-            <a:r>
-              <a:rPr lang="en-US" sz="4000" b="1">
-                <a:solidFill>
-                  <a:schemeClr val="accent2">
-                    <a:lumMod val="50000"/>
-                  </a:schemeClr>
-                </a:solidFill>
-                <a:latin typeface="Calisto MT" panose="02040603050505030304" pitchFamily="18" charset="0"/>
-              </a:rPr>
-              <a:t>Presentation Outline</a:t>
-            </a:r>
-            <a:endParaRPr lang="en-US" sz="4000" b="1" dirty="0">
-              <a:solidFill>
-                <a:schemeClr val="accent2">
-                  <a:lumMod val="50000"/>
-                </a:schemeClr>
-              </a:solidFill>
-              <a:latin typeface="Calisto MT" panose="02040603050505030304" pitchFamily="18" charset="0"/>
-            </a:endParaRPr>
-          </a:p>
-        </p:txBody>
-      </p:sp>
-      <p:sp>
-        <p:nvSpPr>
-          <p:cNvPr id="3" name="Content Placeholder 2">
-            <a:extLst>
-              <a:ext uri="{FF2B5EF4-FFF2-40B4-BE49-F238E27FC236}">
-                <a16:creationId xmlns:a16="http://schemas.microsoft.com/office/drawing/2014/main" id="{E5D502BE-F636-7D1D-85F0-BAFFD3E05E1C}"/>
-              </a:ext>
-            </a:extLst>
-          </p:cNvPr>
-          <p:cNvSpPr>
-            <a:spLocks noGrp="1"/>
-          </p:cNvSpPr>
-          <p:nvPr>
-            <p:ph idx="1"/>
-          </p:nvPr>
-        </p:nvSpPr>
-        <p:spPr>
-          <a:xfrm>
             <a:off x="405352" y="687062"/>
             <a:ext cx="8634953" cy="5851851"/>
           </a:xfrm>
         </p:spPr>
         <p:txBody>
           <a:bodyPr numCol="2">
-            <a:normAutofit fontScale="25000" lnSpcReduction="20000"/>
+            <a:normAutofit/>
           </a:bodyPr>
           <a:lstStyle/>
           <a:p>
@@ -7315,7 +7333,7 @@
               <a:buNone/>
             </a:pPr>
             <a:r>
-              <a:rPr lang="en-US" sz="1600" b="1" dirty="0">
+              <a:rPr lang="en-US" sz="2400" b="1" dirty="0">
                 <a:solidFill>
                   <a:srgbClr val="252525"/>
                 </a:solidFill>
@@ -7332,7 +7350,7 @@
               <a:buNone/>
             </a:pPr>
             <a:r>
-              <a:rPr lang="en-US" sz="1600" b="1" dirty="0">
+              <a:rPr lang="en-US" sz="2400" b="1" dirty="0">
                 <a:solidFill>
                   <a:srgbClr val="252525"/>
                 </a:solidFill>
@@ -7349,7 +7367,7 @@
               <a:buNone/>
             </a:pPr>
             <a:r>
-              <a:rPr lang="en-US" sz="1600" b="1" dirty="0">
+              <a:rPr lang="en-US" sz="2400" b="1" dirty="0">
                 <a:solidFill>
                   <a:srgbClr val="252525"/>
                 </a:solidFill>
@@ -7366,7 +7384,7 @@
               <a:buNone/>
             </a:pPr>
             <a:r>
-              <a:rPr lang="en-US" sz="1600" b="1" dirty="0">
+              <a:rPr lang="en-US" sz="2400" b="1" dirty="0">
                 <a:solidFill>
                   <a:srgbClr val="252525"/>
                 </a:solidFill>
@@ -7383,7 +7401,7 @@
               <a:buNone/>
             </a:pPr>
             <a:r>
-              <a:rPr lang="en-US" sz="1600" b="1" dirty="0">
+              <a:rPr lang="en-US" sz="2400" b="1" dirty="0">
                 <a:solidFill>
                   <a:srgbClr val="252525"/>
                 </a:solidFill>
@@ -7400,7 +7418,7 @@
               <a:buNone/>
             </a:pPr>
             <a:r>
-              <a:rPr lang="en-US" sz="1600" b="1" dirty="0">
+              <a:rPr lang="en-US" sz="2400" b="1" dirty="0">
                 <a:solidFill>
                   <a:srgbClr val="252525"/>
                 </a:solidFill>
@@ -7417,7 +7435,7 @@
               <a:buNone/>
             </a:pPr>
             <a:r>
-              <a:rPr lang="en-US" sz="1600" b="1" dirty="0">
+              <a:rPr lang="en-US" sz="2400" b="1" dirty="0">
                 <a:solidFill>
                   <a:srgbClr val="252525"/>
                 </a:solidFill>
@@ -7434,7 +7452,7 @@
               <a:buNone/>
             </a:pPr>
             <a:r>
-              <a:rPr lang="en-US" sz="1600" b="1" dirty="0">
+              <a:rPr lang="en-US" sz="2400" b="1" dirty="0">
                 <a:solidFill>
                   <a:srgbClr val="252525"/>
                 </a:solidFill>
@@ -7451,330 +7469,7 @@
               <a:buNone/>
             </a:pPr>
             <a:r>
-              <a:rPr lang="en-US" sz="1600" b="1" dirty="0">
-                <a:solidFill>
-                  <a:srgbClr val="252525"/>
-                </a:solidFill>
-                <a:latin typeface="Calisto MT" panose="02040603050505030304" pitchFamily="18" charset="0"/>
-              </a:rPr>
-              <a:t>9. Introduction</a:t>
-            </a:r>
-          </a:p>
-          <a:p>
-            <a:pPr marL="0" lvl="0" indent="0" algn="l">
-              <a:spcAft>
-                <a:spcPts val="200"/>
-              </a:spcAft>
-              <a:buNone/>
-            </a:pPr>
-            <a:r>
-              <a:rPr lang="en-US" sz="1400" dirty="0">
-                <a:solidFill>
-                  <a:srgbClr val="252525"/>
-                </a:solidFill>
-                <a:latin typeface="Calisto MT" panose="02040603050505030304" pitchFamily="18" charset="0"/>
-              </a:rPr>
-              <a:t xml:space="preserve">      9.1. The 3D Genome and Hi-C</a:t>
-            </a:r>
-          </a:p>
-          <a:p>
-            <a:pPr marL="0" lvl="0" indent="0" algn="l">
-              <a:spcAft>
-                <a:spcPts val="200"/>
-              </a:spcAft>
-              <a:buNone/>
-            </a:pPr>
-            <a:r>
-              <a:rPr lang="en-US" sz="1400" dirty="0">
-                <a:solidFill>
-                  <a:srgbClr val="252525"/>
-                </a:solidFill>
-                <a:latin typeface="Calisto MT" panose="02040603050505030304" pitchFamily="18" charset="0"/>
-              </a:rPr>
-              <a:t xml:space="preserve">      9.2. Genomic FMs and SSMs</a:t>
-            </a:r>
-          </a:p>
-          <a:p>
-            <a:pPr marL="0" lvl="0" indent="0" algn="l">
-              <a:spcAft>
-                <a:spcPts val="250"/>
-              </a:spcAft>
-              <a:buNone/>
-            </a:pPr>
-            <a:r>
-              <a:rPr lang="en-US" sz="1600" b="1" dirty="0">
-                <a:solidFill>
-                  <a:srgbClr val="252525"/>
-                </a:solidFill>
-                <a:latin typeface="Calisto MT" panose="02040603050505030304" pitchFamily="18" charset="0"/>
-              </a:rPr>
-              <a:t>10. Study on Existing Technologies</a:t>
-            </a:r>
-          </a:p>
-          <a:p>
-            <a:pPr marL="0" lvl="0" indent="0" algn="l">
-              <a:spcAft>
-                <a:spcPts val="250"/>
-              </a:spcAft>
-              <a:buNone/>
-            </a:pPr>
-            <a:r>
-              <a:rPr lang="en-US" sz="1600" b="1" dirty="0">
-                <a:solidFill>
-                  <a:srgbClr val="252525"/>
-                </a:solidFill>
-                <a:latin typeface="Calisto MT" panose="02040603050505030304" pitchFamily="18" charset="0"/>
-              </a:rPr>
-              <a:t>11. Gap Analysis</a:t>
-            </a:r>
-          </a:p>
-          <a:p>
-            <a:pPr marL="0" lvl="0" indent="0" algn="l">
-              <a:spcAft>
-                <a:spcPts val="250"/>
-              </a:spcAft>
-              <a:buNone/>
-            </a:pPr>
-            <a:r>
-              <a:rPr lang="en-US" sz="1600" b="1" dirty="0">
-                <a:solidFill>
-                  <a:srgbClr val="252525"/>
-                </a:solidFill>
-                <a:latin typeface="Calisto MT" panose="02040603050505030304" pitchFamily="18" charset="0"/>
-              </a:rPr>
-              <a:t>12. SDLC Model (ML Life Cycle)</a:t>
-            </a:r>
-          </a:p>
-          <a:p>
-            <a:pPr marL="0" lvl="0" indent="0" algn="l">
-              <a:spcAft>
-                <a:spcPts val="250"/>
-              </a:spcAft>
-              <a:buNone/>
-            </a:pPr>
-            <a:r>
-              <a:rPr lang="en-US" sz="1600" b="1" dirty="0">
-                <a:solidFill>
-                  <a:srgbClr val="252525"/>
-                </a:solidFill>
-                <a:latin typeface="Calisto MT" panose="02040603050505030304" pitchFamily="18" charset="0"/>
-              </a:rPr>
-              <a:t>13. Functional and Non-Functional Requirements</a:t>
-            </a:r>
-          </a:p>
-          <a:p>
-            <a:pPr marL="0" lvl="0" indent="0" algn="l">
-              <a:spcAft>
-                <a:spcPts val="250"/>
-              </a:spcAft>
-              <a:buNone/>
-            </a:pPr>
-            <a:r>
-              <a:rPr lang="en-US" sz="1600" b="1" dirty="0">
-                <a:solidFill>
-                  <a:srgbClr val="252525"/>
-                </a:solidFill>
-                <a:latin typeface="Calisto MT" panose="02040603050505030304" pitchFamily="18" charset="0"/>
-              </a:rPr>
-              <a:t>14. Data Collection</a:t>
-            </a:r>
-          </a:p>
-          <a:p>
-            <a:pPr marL="0" lvl="0" indent="0" algn="l">
-              <a:spcAft>
-                <a:spcPts val="250"/>
-              </a:spcAft>
-              <a:buNone/>
-            </a:pPr>
-            <a:r>
-              <a:rPr lang="en-US" sz="1600" b="1" dirty="0">
-                <a:solidFill>
-                  <a:srgbClr val="252525"/>
-                </a:solidFill>
-                <a:latin typeface="Calisto MT" panose="02040603050505030304" pitchFamily="18" charset="0"/>
-              </a:rPr>
-              <a:t>15. Data Preparation</a:t>
-            </a:r>
-          </a:p>
-          <a:p>
-            <a:pPr marL="0" lvl="0" indent="0" algn="l">
-              <a:spcAft>
-                <a:spcPts val="250"/>
-              </a:spcAft>
-              <a:buNone/>
-            </a:pPr>
-            <a:r>
-              <a:rPr lang="en-US" sz="1600" b="1" dirty="0">
-                <a:solidFill>
-                  <a:srgbClr val="252525"/>
-                </a:solidFill>
-                <a:latin typeface="Calisto MT" panose="02040603050505030304" pitchFamily="18" charset="0"/>
-              </a:rPr>
-              <a:t>16. Proposed Methodology</a:t>
-            </a:r>
-          </a:p>
-          <a:p>
-            <a:pPr marL="0" lvl="0" indent="0" algn="l">
-              <a:spcAft>
-                <a:spcPts val="200"/>
-              </a:spcAft>
-              <a:buNone/>
-            </a:pPr>
-            <a:r>
-              <a:rPr lang="en-US" sz="1400" dirty="0">
-                <a:solidFill>
-                  <a:srgbClr val="252525"/>
-                </a:solidFill>
-                <a:latin typeface="Calisto MT" panose="02040603050505030304" pitchFamily="18" charset="0"/>
-              </a:rPr>
-              <a:t xml:space="preserve">      16.1. Proposed System Architecture</a:t>
-            </a:r>
-          </a:p>
-          <a:p>
-            <a:pPr marL="0" lvl="0" indent="0" algn="l">
-              <a:spcAft>
-                <a:spcPts val="200"/>
-              </a:spcAft>
-              <a:buNone/>
-            </a:pPr>
-            <a:r>
-              <a:rPr lang="en-US" sz="1400" dirty="0">
-                <a:solidFill>
-                  <a:srgbClr val="252525"/>
-                </a:solidFill>
-                <a:latin typeface="Calisto MT" panose="02040603050505030304" pitchFamily="18" charset="0"/>
-              </a:rPr>
-              <a:t xml:space="preserve">      16.2. Different Modules</a:t>
-            </a:r>
-          </a:p>
-          <a:p>
-            <a:pPr marL="0" lvl="0" indent="0" algn="l">
-              <a:spcAft>
-                <a:spcPts val="200"/>
-              </a:spcAft>
-              <a:buNone/>
-            </a:pPr>
-            <a:r>
-              <a:rPr lang="en-US" sz="1400" dirty="0">
-                <a:solidFill>
-                  <a:srgbClr val="252525"/>
-                </a:solidFill>
-                <a:latin typeface="Calisto MT" panose="02040603050505030304" pitchFamily="18" charset="0"/>
-              </a:rPr>
-              <a:t xml:space="preserve">      16.3. Proposed Model and Algorithm</a:t>
-            </a:r>
-          </a:p>
-          <a:p>
-            <a:pPr marL="0" lvl="0" indent="0" algn="l">
-              <a:spcAft>
-                <a:spcPts val="250"/>
-              </a:spcAft>
-              <a:buNone/>
-            </a:pPr>
-            <a:r>
-              <a:rPr lang="en-US" sz="1600" b="1" dirty="0">
-                <a:solidFill>
-                  <a:srgbClr val="252525"/>
-                </a:solidFill>
-                <a:latin typeface="Calisto MT" panose="02040603050505030304" pitchFamily="18" charset="0"/>
-              </a:rPr>
-              <a:t>17. Results and Discussion</a:t>
-            </a:r>
-          </a:p>
-          <a:p>
-            <a:pPr marL="0" lvl="0" indent="0" algn="l">
-              <a:spcAft>
-                <a:spcPts val="200"/>
-              </a:spcAft>
-              <a:buNone/>
-            </a:pPr>
-            <a:r>
-              <a:rPr lang="en-US" sz="1400" dirty="0">
-                <a:solidFill>
-                  <a:srgbClr val="252525"/>
-                </a:solidFill>
-                <a:latin typeface="Calisto MT" panose="02040603050505030304" pitchFamily="18" charset="0"/>
-              </a:rPr>
-              <a:t xml:space="preserve">      17.1. Experimental Setup</a:t>
-            </a:r>
-          </a:p>
-          <a:p>
-            <a:pPr marL="0" lvl="0" indent="0" algn="l">
-              <a:spcAft>
-                <a:spcPts val="200"/>
-              </a:spcAft>
-              <a:buNone/>
-            </a:pPr>
-            <a:r>
-              <a:rPr lang="en-US" sz="1400" dirty="0">
-                <a:solidFill>
-                  <a:srgbClr val="252525"/>
-                </a:solidFill>
-                <a:latin typeface="Calisto MT" panose="02040603050505030304" pitchFamily="18" charset="0"/>
-              </a:rPr>
-              <a:t xml:space="preserve">      17.2. Results and Analysis</a:t>
-            </a:r>
-          </a:p>
-          <a:p>
-            <a:pPr marL="0" lvl="0" indent="0" algn="l">
-              <a:spcAft>
-                <a:spcPts val="200"/>
-              </a:spcAft>
-              <a:buNone/>
-            </a:pPr>
-            <a:r>
-              <a:rPr lang="en-US" sz="1400" dirty="0">
-                <a:solidFill>
-                  <a:srgbClr val="252525"/>
-                </a:solidFill>
-                <a:latin typeface="Calisto MT" panose="02040603050505030304" pitchFamily="18" charset="0"/>
-              </a:rPr>
-              <a:t xml:space="preserve">      17.3. Comparison with Previous Work</a:t>
-            </a:r>
-          </a:p>
-          <a:p>
-            <a:pPr marL="0" lvl="0" indent="0" algn="l">
-              <a:spcAft>
-                <a:spcPts val="250"/>
-              </a:spcAft>
-              <a:buNone/>
-            </a:pPr>
-            <a:r>
-              <a:rPr lang="en-US" sz="1600" b="1" dirty="0">
-                <a:solidFill>
-                  <a:srgbClr val="252525"/>
-                </a:solidFill>
-                <a:latin typeface="Calisto MT" panose="02040603050505030304" pitchFamily="18" charset="0"/>
-              </a:rPr>
-              <a:t>18. Project Outcomes</a:t>
-            </a:r>
-          </a:p>
-          <a:p>
-            <a:pPr marL="0" lvl="0" indent="0" algn="l">
-              <a:spcAft>
-                <a:spcPts val="250"/>
-              </a:spcAft>
-              <a:buNone/>
-            </a:pPr>
-            <a:r>
-              <a:rPr lang="en-US" sz="1600" b="1" dirty="0">
-                <a:solidFill>
-                  <a:srgbClr val="252525"/>
-                </a:solidFill>
-                <a:latin typeface="Calisto MT" panose="02040603050505030304" pitchFamily="18" charset="0"/>
-              </a:rPr>
-              <a:t>19. Conclusion and Future Work</a:t>
-            </a:r>
-          </a:p>
-          <a:p>
-            <a:pPr marL="0" lvl="0" indent="0" algn="l">
-              <a:spcAft>
-                <a:spcPts val="250"/>
-              </a:spcAft>
-              <a:buNone/>
-            </a:pPr>
-            <a:r>
-              <a:rPr lang="en-US" sz="1600" b="1" dirty="0">
+              <a:rPr lang="en-US" sz="2400" b="1" dirty="0">
                 <a:solidFill>
                   <a:srgbClr val="252525"/>
                 </a:solidFill>
@@ -7814,7 +7509,7 @@
                 <a:latin typeface="Calisto MT" panose="02040603050505030304" pitchFamily="18" charset="0"/>
               </a:rPr>
               <a:pPr/>
-              <a:t>4</a:t>
+              <a:t>3</a:t>
             </a:fld>
             <a:endParaRPr lang="en-US" sz="1400" b="1" dirty="0">
               <a:solidFill>
@@ -7838,7 +7533,7 @@
 </p:sld>
 </file>
 
-<file path=ppt/slides/slide5.xml><?xml version="1.0" encoding="utf-8"?>
+<file path=ppt/slides/slide4.xml><?xml version="1.0" encoding="utf-8"?>
 <p:sld xmlns:a="http://schemas.openxmlformats.org/drawingml/2006/main" xmlns:r="http://schemas.openxmlformats.org/officeDocument/2006/relationships" xmlns:p="http://schemas.openxmlformats.org/presentationml/2006/main">
   <p:cSld>
     <p:spTree>
@@ -7943,7 +7638,7 @@
                 </a:solidFill>
                 <a:latin typeface="Calisto MT" panose="02040603050505030304" pitchFamily="18" charset="0"/>
               </a:rPr>
-              <a:t xml:space="preserve">Primary Domain: </a:t>
+              <a:t>Primary Domain: </a:t>
             </a:r>
             <a:r>
               <a:rPr lang="en-US" sz="2000" dirty="0">
@@ -7952,7 +7647,7 @@
                 </a:solidFill>
                 <a:latin typeface="Calisto MT" panose="02040603050505030304" pitchFamily="18" charset="0"/>
               </a:rPr>
-              <a:t xml:space="preserve"> Artificial Intelligence and Machine Learning — Foundation Models and Self-Supervised Learning</a:t>
+              <a:t> Artificial Intelligence and Machine Learning — Foundation Models and Self-Supervised Learning</a:t>
             </a:r>
           </a:p>
           <a:p>
@@ -7968,7 +7663,7 @@
                 </a:solidFill>
                 <a:latin typeface="Calisto MT" panose="02040603050505030304" pitchFamily="18" charset="0"/>
               </a:rPr>
-              <a:t xml:space="preserve">Sub-Domain: </a:t>
+              <a:t>Sub-Domain: </a:t>
             </a:r>
             <a:r>
               <a:rPr lang="en-US" sz="2000" dirty="0">
@@ -7977,7 +7672,7 @@
                 </a:solidFill>
                 <a:latin typeface="Calisto MT" panose="02040603050505030304" pitchFamily="18" charset="0"/>
               </a:rPr>
-              <a:t xml:space="preserve"> Computational Genomics and Long-Range DNA Sequence Modeling with State Space Models (Mamba/SSM)</a:t>
+              <a:t> Computational Genomics and Long-Range DNA Sequence Modeling with State Space Models (Mamba/SSM)</a:t>
             </a:r>
           </a:p>
           <a:p>
@@ -7993,7 +7688,7 @@
                 </a:solidFill>
                 <a:latin typeface="Calisto MT" panose="02040603050505030304" pitchFamily="18" charset="0"/>
               </a:rPr>
-              <a:t xml:space="preserve">Application Area: </a:t>
+              <a:t>Application Area: </a:t>
             </a:r>
             <a:r>
               <a:rPr lang="en-US" sz="2000" dirty="0">
@@ -8002,7 +7697,7 @@
                 </a:solidFill>
                 <a:latin typeface="Calisto MT" panose="02040603050505030304" pitchFamily="18" charset="0"/>
               </a:rPr>
-              <a:t xml:space="preserve"> Regulatory genomics — enhancer–promoter interaction, regulatory element association — and clinical variant-effect interpretation (ClinVar)</a:t>
+              <a:t> Regulatory genomics enhancer–promoter interaction, regulatory element association and clinical variant-effect interpretation (ClinVar)</a:t>
             </a:r>
           </a:p>
           <a:p>
@@ -8014,7 +7709,7 @@
                 </a:solidFill>
                 <a:latin typeface="Calisto MT" panose="02040603050505030304" pitchFamily="18" charset="0"/>
               </a:rPr>
-              <a:t xml:space="preserve">Interdisciplinary basis: </a:t>
+              <a:t>Interdisciplinary basis: </a:t>
             </a:r>
             <a:r>
               <a:rPr lang="en-US" sz="2000" dirty="0">
@@ -8023,7 +7718,7 @@
                 </a:solidFill>
                 <a:latin typeface="Calisto MT" panose="02040603050505030304" pitchFamily="18" charset="0"/>
               </a:rPr>
-              <a:t xml:space="preserve"> 3D genome biology (Hi-C, TADs, chromatin loops) supplies the structural signal that the machine-learning contribution conditions on.</a:t>
+              <a:t> 3D genome biology (Hi-C, TADs, chromatin loops) supplies the structural signal that the machine-learning contribution conditions on.</a:t>
             </a:r>
           </a:p>
         </p:txBody>
@@ -8057,7 +7752,7 @@
                 <a:latin typeface="Calisto MT" panose="02040603050505030304" pitchFamily="18" charset="0"/>
               </a:rPr>
               <a:pPr/>
-              <a:t>5</a:t>
+              <a:t>4</a:t>
             </a:fld>
             <a:endParaRPr lang="en-US" sz="1400" b="1" dirty="0">
               <a:solidFill>
@@ -8081,7 +7776,7 @@
 </p:sld>
 </file>
 
-<file path=ppt/slides/slide6.xml><?xml version="1.0" encoding="utf-8"?>
+<file path=ppt/slides/slide5.xml><?xml version="1.0" encoding="utf-8"?>
 <p:sld xmlns:a="http://schemas.openxmlformats.org/drawingml/2006/main" xmlns:r="http://schemas.openxmlformats.org/officeDocument/2006/relationships" xmlns:p="http://schemas.openxmlformats.org/presentationml/2006/main">
   <p:cSld>
     <p:spTree>
@@ -8205,7 +7900,7 @@
                 </a:solidFill>
                 <a:latin typeface="Calisto MT" panose="02040603050505030304" pitchFamily="18" charset="0"/>
               </a:rPr>
-              <a:t xml:space="preserve">SDG 3 — Good Health and Well-Being: </a:t>
+              <a:t>SDG 3 — Good Health and Well-Being: </a:t>
             </a:r>
             <a:r>
               <a:rPr lang="en-US" sz="1600" dirty="0">
@@ -8214,7 +7909,7 @@
                 </a:solidFill>
                 <a:latin typeface="Calisto MT" panose="02040603050505030304" pitchFamily="18" charset="0"/>
               </a:rPr>
-              <a:t xml:space="preserve"> improved interpretation of non-coding and pathogenic variants (ClinVar evaluation) supports precision-medicine and disease-mechanism research.</a:t>
+              <a:t> improved interpretation of non-coding and pathogenic variants (ClinVar evaluation) supports precision-medicine and disease-mechanism research.</a:t>
             </a:r>
           </a:p>
           <a:p>
@@ -8232,7 +7927,7 @@
                 </a:solidFill>
                 <a:latin typeface="Calisto MT" panose="02040603050505030304" pitchFamily="18" charset="0"/>
               </a:rPr>
-              <a:t xml:space="preserve">SDG 9 — Industry, Innovation and Infrastructure: </a:t>
+              <a:t>SDG 9 — Industry, Innovation and Infrastructure: </a:t>
             </a:r>
             <a:r>
               <a:rPr lang="en-US" sz="1600" dirty="0">
@@ -8241,7 +7936,7 @@
                 </a:solidFill>
                 <a:latin typeface="Calisto MT" panose="02040603050505030304" pitchFamily="18" charset="0"/>
               </a:rPr>
-              <a:t xml:space="preserve"> open, reproducible AI research infrastructure — released pipeline, data card and matched-compute benchmark protocol.</a:t>
+              <a:t> open, reproducible AI research infrastructure  released pipeline, data card and matched-compute benchmark protocol.</a:t>
             </a:r>
           </a:p>
           <a:p>
@@ -8255,7 +7950,7 @@
                 </a:solidFill>
                 <a:latin typeface="Calisto MT" panose="02040603050505030304" pitchFamily="18" charset="0"/>
               </a:rPr>
-              <a:t>Only SDGs directly aligned with the project objectives and outcomes are claimed.</a:t>
+              <a:t>*Only SDGs directly aligned with the project objectives and outcomes are claimed.</a:t>
             </a:r>
           </a:p>
         </p:txBody>
@@ -8289,7 +7984,7 @@
                 <a:latin typeface="Calisto MT" panose="02040603050505030304" pitchFamily="18" charset="0"/>
               </a:rPr>
               <a:pPr/>
-              <a:t>6</a:t>
+              <a:t>5</a:t>
             </a:fld>
             <a:endParaRPr lang="en-US" sz="1400" b="1" dirty="0">
               <a:solidFill>
@@ -8343,6 +8038,357 @@
 </p:sld>
 </file>
 
+<file path=ppt/slides/slide6.xml><?xml version="1.0" encoding="utf-8"?>
+<p:sld xmlns:a="http://schemas.openxmlformats.org/drawingml/2006/main" xmlns:r="http://schemas.openxmlformats.org/officeDocument/2006/relationships" xmlns:p="http://schemas.openxmlformats.org/presentationml/2006/main">
+  <p:cSld>
+    <p:spTree>
+      <p:nvGrpSpPr>
+        <p:cNvPr id="1" name=""/>
+        <p:cNvGrpSpPr/>
+        <p:nvPr/>
+      </p:nvGrpSpPr>
+      <p:grpSpPr>
+        <a:xfrm>
+          <a:off x="0" y="0"/>
+          <a:ext cx="0" cy="0"/>
+          <a:chOff x="0" y="0"/>
+          <a:chExt cx="0" cy="0"/>
+        </a:xfrm>
+      </p:grpSpPr>
+      <p:sp>
+        <p:nvSpPr>
+          <p:cNvPr id="2" name="Title 1">
+            <a:extLst>
+              <a:ext uri="{FF2B5EF4-FFF2-40B4-BE49-F238E27FC236}">
+                <a16:creationId xmlns:a16="http://schemas.microsoft.com/office/drawing/2014/main" id="{5B738971-B764-E045-F92B-01E3322A0123}"/>
+              </a:ext>
+            </a:extLst>
+          </p:cNvPr>
+          <p:cNvSpPr>
+            <a:spLocks noGrp="1"/>
+          </p:cNvSpPr>
+          <p:nvPr>
+            <p:ph type="title"/>
+          </p:nvPr>
+        </p:nvSpPr>
+        <p:spPr>
+          <a:xfrm>
+            <a:off x="202676" y="120029"/>
+            <a:ext cx="8738648" cy="747237"/>
+          </a:xfrm>
+        </p:spPr>
+        <p:txBody>
+          <a:bodyPr>
+            <a:noAutofit/>
+          </a:bodyPr>
+          <a:lstStyle/>
+          <a:p>
+            <a:r>
+              <a:rPr lang="en-US" sz="3000" b="1" dirty="0">
+                <a:solidFill>
+                  <a:schemeClr val="accent2">
+                    <a:lumMod val="50000"/>
+                  </a:schemeClr>
+                </a:solidFill>
+                <a:latin typeface="Calisto MT" panose="02040603050505030304" pitchFamily="18" charset="0"/>
+              </a:rPr>
+              <a:t>3. Aim and Motivation</a:t>
+            </a:r>
+          </a:p>
+        </p:txBody>
+      </p:sp>
+      <p:sp>
+        <p:nvSpPr>
+          <p:cNvPr id="3" name="Content Placeholder 2">
+            <a:extLst>
+              <a:ext uri="{FF2B5EF4-FFF2-40B4-BE49-F238E27FC236}">
+                <a16:creationId xmlns:a16="http://schemas.microsoft.com/office/drawing/2014/main" id="{E5D502BE-F636-7D1D-85F0-BAFFD3E05E1C}"/>
+              </a:ext>
+            </a:extLst>
+          </p:cNvPr>
+          <p:cNvSpPr>
+            <a:spLocks noGrp="1"/>
+          </p:cNvSpPr>
+          <p:nvPr>
+            <p:ph idx="1"/>
+          </p:nvPr>
+        </p:nvSpPr>
+        <p:spPr>
+          <a:xfrm>
+            <a:off x="358218" y="867265"/>
+            <a:ext cx="8314441" cy="5870705"/>
+          </a:xfrm>
+        </p:spPr>
+        <p:txBody>
+          <a:bodyPr numCol="1">
+            <a:normAutofit/>
+          </a:bodyPr>
+          <a:lstStyle/>
+          <a:p>
+            <a:pPr marL="0" lvl="0" indent="0" algn="l">
+              <a:spcAft>
+                <a:spcPts val="400"/>
+              </a:spcAft>
+              <a:buNone/>
+            </a:pPr>
+            <a:r>
+              <a:rPr lang="en-US" sz="2200" b="1" i="1" dirty="0">
+                <a:solidFill>
+                  <a:srgbClr val="C00000"/>
+                </a:solidFill>
+                <a:latin typeface="Calisto MT" panose="02040603050505030304" pitchFamily="18" charset="0"/>
+              </a:rPr>
+              <a:t>Aim</a:t>
+            </a:r>
+          </a:p>
+          <a:p>
+            <a:pPr marL="0" lvl="0" indent="0" algn="just">
+              <a:spcAft>
+                <a:spcPts val="700"/>
+              </a:spcAft>
+              <a:buNone/>
+            </a:pPr>
+            <a:r>
+              <a:rPr lang="en-US" sz="1800" dirty="0">
+                <a:solidFill>
+                  <a:srgbClr val="252525"/>
+                </a:solidFill>
+                <a:latin typeface="Calisto MT" panose="02040603050505030304" pitchFamily="18" charset="0"/>
+              </a:rPr>
+              <a:t>To build and evaluate a </a:t>
+            </a:r>
+            <a:r>
+              <a:rPr lang="en-US" sz="1800" b="1" dirty="0">
+                <a:solidFill>
+                  <a:srgbClr val="252525"/>
+                </a:solidFill>
+                <a:latin typeface="Calisto MT" panose="02040603050505030304" pitchFamily="18" charset="0"/>
+              </a:rPr>
+              <a:t>genomic foundation model</a:t>
+            </a:r>
+            <a:r>
+              <a:rPr lang="en-US" sz="1800" dirty="0">
+                <a:solidFill>
+                  <a:srgbClr val="252525"/>
+                </a:solidFill>
+                <a:latin typeface="Calisto MT" panose="02040603050505030304" pitchFamily="18" charset="0"/>
+              </a:rPr>
+              <a:t> whose </a:t>
+            </a:r>
+            <a:r>
+              <a:rPr lang="en-US" sz="1800" b="1" dirty="0">
+                <a:solidFill>
+                  <a:srgbClr val="252525"/>
+                </a:solidFill>
+                <a:latin typeface="Calisto MT" panose="02040603050505030304" pitchFamily="18" charset="0"/>
+              </a:rPr>
+              <a:t>self-supervised pretraining is conditioned on 3D chromatin structure</a:t>
+            </a:r>
+            <a:r>
+              <a:rPr lang="en-US" sz="1800" dirty="0">
+                <a:solidFill>
+                  <a:srgbClr val="252525"/>
+                </a:solidFill>
+                <a:latin typeface="Calisto MT" panose="02040603050505030304" pitchFamily="18" charset="0"/>
+              </a:rPr>
+              <a:t> (Hi-C), so that structural information shapes the learned sequence representation itself not merely a layer added after training.</a:t>
+            </a:r>
+          </a:p>
+          <a:p>
+            <a:pPr marL="0" lvl="0" indent="0" algn="l">
+              <a:spcAft>
+                <a:spcPts val="400"/>
+              </a:spcAft>
+              <a:buNone/>
+            </a:pPr>
+            <a:r>
+              <a:rPr lang="en-US" sz="2200" b="1" i="1" dirty="0">
+                <a:solidFill>
+                  <a:srgbClr val="C00000"/>
+                </a:solidFill>
+                <a:latin typeface="Calisto MT" panose="02040603050505030304" pitchFamily="18" charset="0"/>
+              </a:rPr>
+              <a:t>Motivation</a:t>
+            </a:r>
+          </a:p>
+          <a:p>
+            <a:pPr marL="457200" lvl="0" indent="-457200" algn="just">
+              <a:spcAft>
+                <a:spcPts val="600"/>
+              </a:spcAft>
+              <a:buFont typeface="+mj-lt"/>
+              <a:buAutoNum type="arabicPeriod"/>
+            </a:pPr>
+            <a:r>
+              <a:rPr lang="en-US" sz="1800" dirty="0">
+                <a:solidFill>
+                  <a:srgbClr val="252525"/>
+                </a:solidFill>
+                <a:latin typeface="Calisto MT" panose="02040603050505030304" pitchFamily="18" charset="0"/>
+              </a:rPr>
+              <a:t>The genome operates in 3D: </a:t>
+            </a:r>
+            <a:r>
+              <a:rPr lang="en-US" sz="1800" b="1" dirty="0">
+                <a:solidFill>
+                  <a:srgbClr val="252525"/>
+                </a:solidFill>
+                <a:latin typeface="Calisto MT" panose="02040603050505030304" pitchFamily="18" charset="0"/>
+              </a:rPr>
+              <a:t>TADs and loops</a:t>
+            </a:r>
+            <a:r>
+              <a:rPr lang="en-US" sz="1800" dirty="0">
+                <a:solidFill>
+                  <a:srgbClr val="252525"/>
+                </a:solidFill>
+                <a:latin typeface="Calisto MT" panose="02040603050505030304" pitchFamily="18" charset="0"/>
+              </a:rPr>
+              <a:t> physically decide which enhancers reach which promoters.</a:t>
+            </a:r>
+          </a:p>
+          <a:p>
+            <a:pPr marL="457200" lvl="0" indent="-457200" algn="just">
+              <a:spcAft>
+                <a:spcPts val="600"/>
+              </a:spcAft>
+              <a:buFont typeface="+mj-lt"/>
+              <a:buAutoNum type="arabicPeriod"/>
+            </a:pPr>
+            <a:r>
+              <a:rPr lang="en-US" sz="1800" dirty="0">
+                <a:solidFill>
+                  <a:srgbClr val="252525"/>
+                </a:solidFill>
+                <a:latin typeface="Calisto MT" panose="02040603050505030304" pitchFamily="18" charset="0"/>
+              </a:rPr>
+              <a:t>Current genomic FMs read DNA as a 1D string and </a:t>
+            </a:r>
+            <a:r>
+              <a:rPr lang="en-US" sz="1800" b="1" dirty="0">
+                <a:solidFill>
+                  <a:srgbClr val="252525"/>
+                </a:solidFill>
+                <a:latin typeface="Calisto MT" panose="02040603050505030304" pitchFamily="18" charset="0"/>
+              </a:rPr>
+              <a:t>Evo 2-7B provably misses TAD/loop-scale organization</a:t>
+            </a:r>
+            <a:r>
+              <a:rPr lang="en-US" sz="1800" dirty="0">
+                <a:solidFill>
+                  <a:srgbClr val="252525"/>
+                </a:solidFill>
+                <a:latin typeface="Calisto MT" panose="02040603050505030304" pitchFamily="18" charset="0"/>
+              </a:rPr>
+              <a:t> despite 9.3T training tokens.</a:t>
+            </a:r>
+          </a:p>
+          <a:p>
+            <a:pPr marL="457200" lvl="0" indent="-457200" algn="just">
+              <a:buFont typeface="+mj-lt"/>
+              <a:buAutoNum type="arabicPeriod"/>
+            </a:pPr>
+            <a:r>
+              <a:rPr lang="en-US" sz="1800" dirty="0">
+                <a:solidFill>
+                  <a:srgbClr val="252525"/>
+                </a:solidFill>
+                <a:latin typeface="Calisto MT" panose="02040603050505030304" pitchFamily="18" charset="0"/>
+              </a:rPr>
+              <a:t>Existing fixes are </a:t>
+            </a:r>
+            <a:r>
+              <a:rPr lang="en-US" sz="1800" b="1" dirty="0">
+                <a:solidFill>
+                  <a:srgbClr val="252525"/>
+                </a:solidFill>
+                <a:latin typeface="Calisto MT" panose="02040603050505030304" pitchFamily="18" charset="0"/>
+              </a:rPr>
+              <a:t>post-hoc</a:t>
+            </a:r>
+            <a:r>
+              <a:rPr lang="en-US" sz="1800" dirty="0">
+                <a:solidFill>
+                  <a:srgbClr val="252525"/>
+                </a:solidFill>
+                <a:latin typeface="Calisto MT" panose="02040603050505030304" pitchFamily="18" charset="0"/>
+              </a:rPr>
+              <a:t> (CHROME) or </a:t>
+            </a:r>
+            <a:r>
+              <a:rPr lang="en-US" sz="1800" b="1" dirty="0">
+                <a:solidFill>
+                  <a:srgbClr val="252525"/>
+                </a:solidFill>
+                <a:latin typeface="Calisto MT" panose="02040603050505030304" pitchFamily="18" charset="0"/>
+              </a:rPr>
+              <a:t>embedding alignment</a:t>
+            </a:r>
+            <a:r>
+              <a:rPr lang="en-US" sz="1800" dirty="0">
+                <a:solidFill>
+                  <a:srgbClr val="252525"/>
+                </a:solidFill>
+                <a:latin typeface="Calisto MT" panose="02040603050505030304" pitchFamily="18" charset="0"/>
+              </a:rPr>
+              <a:t> (Evo2HiC) the pretraining objective itself has never seen structure.</a:t>
+            </a:r>
+          </a:p>
+        </p:txBody>
+      </p:sp>
+      <p:sp>
+        <p:nvSpPr>
+          <p:cNvPr id="7" name="Slide Number Placeholder 6">
+            <a:extLst>
+              <a:ext uri="{FF2B5EF4-FFF2-40B4-BE49-F238E27FC236}">
+                <a16:creationId xmlns:a16="http://schemas.microsoft.com/office/drawing/2014/main" id="{14F45621-8939-04E9-03B4-11AF180D5862}"/>
+              </a:ext>
+            </a:extLst>
+          </p:cNvPr>
+          <p:cNvSpPr>
+            <a:spLocks noGrp="1"/>
+          </p:cNvSpPr>
+          <p:nvPr>
+            <p:ph type="sldNum" sz="quarter" idx="12"/>
+          </p:nvPr>
+        </p:nvSpPr>
+        <p:spPr/>
+        <p:txBody>
+          <a:bodyPr/>
+          <a:lstStyle/>
+          <a:p>
+            <a:fld id="{D90542D4-23E8-43E0-BA8E-C972DA1A005D}" type="slidenum">
+              <a:rPr lang="en-US" sz="1400" b="1" smtClean="0">
+                <a:solidFill>
+                  <a:schemeClr val="tx1"/>
+                </a:solidFill>
+                <a:latin typeface="Calisto MT" panose="02040603050505030304" pitchFamily="18" charset="0"/>
+              </a:rPr>
+              <a:pPr/>
+              <a:t>6</a:t>
+            </a:fld>
+            <a:endParaRPr lang="en-US" sz="1400" b="1" dirty="0">
+              <a:solidFill>
+                <a:schemeClr val="tx1"/>
+              </a:solidFill>
+              <a:latin typeface="Calisto MT" panose="02040603050505030304" pitchFamily="18" charset="0"/>
+            </a:endParaRPr>
+          </a:p>
+        </p:txBody>
+      </p:sp>
+    </p:spTree>
+    <p:extLst>
+      <p:ext uri="{BB962C8B-B14F-4D97-AF65-F5344CB8AC3E}">
+        <p14:creationId xmlns:p14="http://schemas.microsoft.com/office/powerpoint/2010/main" val="3338637167"/>
+      </p:ext>
+    </p:extLst>
+  </p:cSld>
+  <p:clrMapOvr>
+    <a:masterClrMapping/>
+  </p:clrMapOvr>
+</p:sld>
+</file>
+
 <file path=ppt/slides/slide7.xml><?xml version="1.0" encoding="utf-8"?>
 <p:sld xmlns:a="http://schemas.openxmlformats.org/drawingml/2006/main" xmlns:r="http://schemas.openxmlformats.org/officeDocument/2006/relationships" xmlns:p="http://schemas.openxmlformats.org/presentationml/2006/main">
   <p:cSld>
@@ -8378,8 +8424,8 @@
         </p:nvSpPr>
         <p:spPr>
           <a:xfrm>
-            <a:off x="202676" y="120029"/>
-            <a:ext cx="8738648" cy="747237"/>
+            <a:off x="202676" y="71961"/>
+            <a:ext cx="8738648" cy="634115"/>
           </a:xfrm>
         </p:spPr>
         <p:txBody>
@@ -8397,7 +8443,7 @@
                 </a:solidFill>
                 <a:latin typeface="Calisto MT" panose="02040603050505030304" pitchFamily="18" charset="0"/>
               </a:rPr>
-              <a:t>3. Aim and Motivation</a:t>
+              <a:t>4. Research Questions</a:t>
             </a:r>
           </a:p>
         </p:txBody>
@@ -8420,8 +8466,8 @@
         </p:nvSpPr>
         <p:spPr>
           <a:xfrm>
-            <a:off x="358218" y="867265"/>
-            <a:ext cx="8314441" cy="5870705"/>
+            <a:off x="273377" y="631596"/>
+            <a:ext cx="8578391" cy="6106375"/>
           </a:xfrm>
         </p:spPr>
         <p:txBody>
@@ -8430,96 +8476,9 @@
           </a:bodyPr>
           <a:lstStyle/>
           <a:p>
-            <a:pPr marL="0" lvl="0" indent="0" algn="l">
-              <a:spcAft>
-                <a:spcPts val="400"/>
-              </a:spcAft>
-              <a:buNone/>
-            </a:pPr>
-            <a:r>
-              <a:rPr lang="en-US" sz="2200" b="1" i="1" dirty="0">
-                <a:solidFill>
-                  <a:srgbClr val="C00000"/>
-                </a:solidFill>
-                <a:latin typeface="Calisto MT" panose="02040603050505030304" pitchFamily="18" charset="0"/>
-              </a:rPr>
-              <a:t>Aim</a:t>
-            </a:r>
-          </a:p>
-          <a:p>
-            <a:pPr marL="0" lvl="0" indent="0" algn="just">
-              <a:spcAft>
-                <a:spcPts val="700"/>
-              </a:spcAft>
-              <a:buNone/>
-            </a:pPr>
-            <a:r>
-              <a:rPr lang="en-US" sz="1800" dirty="0">
-                <a:solidFill>
-                  <a:srgbClr val="252525"/>
-                </a:solidFill>
-                <a:latin typeface="Calisto MT" panose="02040603050505030304" pitchFamily="18" charset="0"/>
-              </a:rPr>
-              <a:t xml:space="preserve">To build and evaluate a </a:t>
-            </a:r>
-            <a:r>
-              <a:rPr lang="en-US" sz="1800" b="1" dirty="0">
-                <a:solidFill>
-                  <a:srgbClr val="252525"/>
-                </a:solidFill>
-                <a:latin typeface="Calisto MT" panose="02040603050505030304" pitchFamily="18" charset="0"/>
-              </a:rPr>
-              <a:t>genomic foundation model</a:t>
-            </a:r>
-            <a:r>
-              <a:rPr lang="en-US" sz="1800" dirty="0">
-                <a:solidFill>
-                  <a:srgbClr val="252525"/>
-                </a:solidFill>
-                <a:latin typeface="Calisto MT" panose="02040603050505030304" pitchFamily="18" charset="0"/>
-              </a:rPr>
-              <a:t xml:space="preserve"> whose </a:t>
-            </a:r>
-            <a:r>
-              <a:rPr lang="en-US" sz="1800" b="1" dirty="0">
-                <a:solidFill>
-                  <a:srgbClr val="252525"/>
-                </a:solidFill>
-                <a:latin typeface="Calisto MT" panose="02040603050505030304" pitchFamily="18" charset="0"/>
-              </a:rPr>
-              <a:t>self-supervised pretraining is conditioned on 3D chromatin structure</a:t>
-            </a:r>
-            <a:r>
-              <a:rPr lang="en-US" sz="1800" dirty="0">
-                <a:solidFill>
-                  <a:srgbClr val="252525"/>
-                </a:solidFill>
-                <a:latin typeface="Calisto MT" panose="02040603050505030304" pitchFamily="18" charset="0"/>
-              </a:rPr>
-              <a:t xml:space="preserve"> (Hi-C), so that structural information shapes the learned sequence representation itself — not merely a layer added after training.</a:t>
-            </a:r>
-          </a:p>
-          <a:p>
-            <a:pPr marL="0" lvl="0" indent="0" algn="l">
-              <a:spcAft>
-                <a:spcPts val="400"/>
-              </a:spcAft>
-              <a:buNone/>
-            </a:pPr>
-            <a:r>
-              <a:rPr lang="en-US" sz="2200" b="1" i="1" dirty="0">
-                <a:solidFill>
-                  <a:srgbClr val="C00000"/>
-                </a:solidFill>
-                <a:latin typeface="Calisto MT" panose="02040603050505030304" pitchFamily="18" charset="0"/>
-              </a:rPr>
-              <a:t>Motivation</a:t>
-            </a:r>
-          </a:p>
-          <a:p>
             <a:pPr marL="457200" lvl="0" indent="-457200" algn="just">
               <a:spcAft>
-                <a:spcPts val="600"/>
+                <a:spcPts val="900"/>
               </a:spcAft>
               <a:buFont typeface="+mj-lt"/>
               <a:buAutoNum type="arabicPeriod"/>
@@ -8531,31 +8490,13 @@
                 </a:solidFill>
                 <a:latin typeface="Calisto MT" panose="02040603050505030304" pitchFamily="18" charset="0"/>
               </a:rPr>
-              <a:t xml:space="preserve">The genome operates in 3D: </a:t>
-            </a:r>
-            <a:r>
-              <a:rPr lang="en-US" sz="1800" b="1" dirty="0">
-                <a:solidFill>
-                  <a:srgbClr val="252525"/>
-                </a:solidFill>
-                <a:latin typeface="Calisto MT" panose="02040603050505030304" pitchFamily="18" charset="0"/>
-              </a:rPr>
-              <a:t>TADs and loops</a:t>
-            </a:r>
-            <a:r>
-              <a:rPr lang="en-US" sz="1800" dirty="0">
-                <a:solidFill>
-                  <a:srgbClr val="252525"/>
-                </a:solidFill>
-                <a:latin typeface="Calisto MT" panose="02040603050505030304" pitchFamily="18" charset="0"/>
-              </a:rPr>
-              <a:t xml:space="preserve"> physically decide which enhancers reach which promoters.</a:t>
+              <a:t>Does conditioning self-supervised masked-token pretraining on Hi-C-derived structural features improve a DNA language model over a sequence-only baseline at matched parameters and compute?</a:t>
             </a:r>
           </a:p>
           <a:p>
             <a:pPr marL="457200" lvl="0" indent="-457200" algn="just">
               <a:spcAft>
-                <a:spcPts val="600"/>
+                <a:spcPts val="900"/>
               </a:spcAft>
               <a:buFont typeface="+mj-lt"/>
               <a:buAutoNum type="arabicPeriod"/>
@@ -8567,25 +8508,7 @@
                 </a:solidFill>
                 <a:latin typeface="Calisto MT" panose="02040603050505030304" pitchFamily="18" charset="0"/>
               </a:rPr>
-              <a:t xml:space="preserve">Current genomic FMs read DNA as a 1D string — and </a:t>
-            </a:r>
-            <a:r>
-              <a:rPr lang="en-US" sz="1800" b="1" dirty="0">
-                <a:solidFill>
-                  <a:srgbClr val="252525"/>
-                </a:solidFill>
-                <a:latin typeface="Calisto MT" panose="02040603050505030304" pitchFamily="18" charset="0"/>
-              </a:rPr>
-              <a:t>Evo 2-7B provably misses TAD/loop-scale organization</a:t>
-            </a:r>
-            <a:r>
-              <a:rPr lang="en-US" sz="1800" dirty="0">
-                <a:solidFill>
-                  <a:srgbClr val="252525"/>
-                </a:solidFill>
-                <a:latin typeface="Calisto MT" panose="02040603050505030304" pitchFamily="18" charset="0"/>
-              </a:rPr>
-              <a:t xml:space="preserve"> despite 9.3T training tokens.</a:t>
+              <a:t>Does structure entering the SSM recurrence during pretraining outperform post-hoc integration (CHROME-style) and contrastive distillation (Evo2HiC-style) on regulatory and variant-effect transfer tasks?</a:t>
             </a:r>
           </a:p>
           <a:p>
@@ -8600,43 +8523,7 @@
                 </a:solidFill>
                 <a:latin typeface="Calisto MT" panose="02040603050505030304" pitchFamily="18" charset="0"/>
               </a:rPr>
-              <a:t xml:space="preserve">Existing fixes are </a:t>
-            </a:r>
-            <a:r>
-              <a:rPr lang="en-US" sz="1800" b="1" dirty="0">
-                <a:solidFill>
-                  <a:srgbClr val="252525"/>
-                </a:solidFill>
-                <a:latin typeface="Calisto MT" panose="02040603050505030304" pitchFamily="18" charset="0"/>
-              </a:rPr>
-              <a:t>post-hoc</a:t>
-            </a:r>
-            <a:r>
-              <a:rPr lang="en-US" sz="1800" dirty="0">
-                <a:solidFill>
-                  <a:srgbClr val="252525"/>
-                </a:solidFill>
-                <a:latin typeface="Calisto MT" panose="02040603050505030304" pitchFamily="18" charset="0"/>
-              </a:rPr>
-              <a:t xml:space="preserve"> (CHROME) or </a:t>
-            </a:r>
-            <a:r>
-              <a:rPr lang="en-US" sz="1800" b="1" dirty="0">
-                <a:solidFill>
-                  <a:srgbClr val="252525"/>
-                </a:solidFill>
-                <a:latin typeface="Calisto MT" panose="02040603050505030304" pitchFamily="18" charset="0"/>
-              </a:rPr>
-              <a:t>embedding alignment</a:t>
-            </a:r>
-            <a:r>
-              <a:rPr lang="en-US" sz="1800" dirty="0">
-                <a:solidFill>
-                  <a:srgbClr val="252525"/>
-                </a:solidFill>
-                <a:latin typeface="Calisto MT" panose="02040603050505030304" pitchFamily="18" charset="0"/>
-              </a:rPr>
-              <a:t xml:space="preserve"> (Evo2HiC) — the pretraining objective itself has never seen structure.</a:t>
+              <a:t>Are the observed gains attributable to genuine locus-specific 3D structure rather than to genomic distance decay  i.e., do shuffled-structure and distance-matched controls (S0–S3) degrade performance?</a:t>
             </a:r>
           </a:p>
         </p:txBody>
@@ -8684,7 +8571,7 @@
     </p:spTree>
     <p:extLst>
       <p:ext uri="{BB962C8B-B14F-4D97-AF65-F5344CB8AC3E}">
-        <p14:creationId xmlns:p14="http://schemas.microsoft.com/office/powerpoint/2010/main" val="3338637167"/>
+        <p14:creationId xmlns:p14="http://schemas.microsoft.com/office/powerpoint/2010/main" val="2481146048"/>
       </p:ext>
     </p:extLst>
   </p:cSld>
@@ -8729,8 +8616,8 @@
         </p:nvSpPr>
         <p:spPr>
           <a:xfrm>
-            <a:off x="202676" y="71961"/>
-            <a:ext cx="8738648" cy="634115"/>
+            <a:off x="202676" y="120029"/>
+            <a:ext cx="8738648" cy="747237"/>
           </a:xfrm>
         </p:spPr>
         <p:txBody>
@@ -8748,7 +8635,7 @@
                 </a:solidFill>
                 <a:latin typeface="Calisto MT" panose="02040603050505030304" pitchFamily="18" charset="0"/>
               </a:rPr>
-              <a:t>4. Research Questions</a:t>
+              <a:t>5. Title Justification</a:t>
             </a:r>
           </a:p>
         </p:txBody>
@@ -8771,8 +8658,8 @@
         </p:nvSpPr>
         <p:spPr>
           <a:xfrm>
-            <a:off x="273377" y="631596"/>
-            <a:ext cx="8578391" cy="6106375"/>
+            <a:off x="358218" y="867265"/>
+            <a:ext cx="8314441" cy="5870705"/>
           </a:xfrm>
         </p:spPr>
         <p:txBody>
@@ -8783,37 +8670,82 @@
           <a:p>
             <a:pPr marL="457200" lvl="0" indent="-457200" algn="just">
               <a:spcAft>
-                <a:spcPts val="900"/>
+                <a:spcPts val="700"/>
               </a:spcAft>
               <a:buFont typeface="+mj-lt"/>
               <a:buAutoNum type="arabicPeriod"/>
             </a:pPr>
             <a:r>
+              <a:rPr lang="en-US" sz="1800" b="1" dirty="0">
+                <a:solidFill>
+                  <a:srgbClr val="252525"/>
+                </a:solidFill>
+                <a:latin typeface="Calisto MT" panose="02040603050505030304" pitchFamily="18" charset="0"/>
+              </a:rPr>
+              <a:t>"3D-Chromatin-Aware"</a:t>
+            </a:r>
+            <a:r>
               <a:rPr lang="en-US" sz="1800" dirty="0">
                 <a:solidFill>
                   <a:srgbClr val="252525"/>
                 </a:solidFill>
                 <a:latin typeface="Calisto MT" panose="02040603050505030304" pitchFamily="18" charset="0"/>
               </a:rPr>
-              <a:t>Does conditioning self-supervised masked-token pretraining on Hi-C-derived structural features improve a DNA language model over a sequence-only baseline at matched parameters and compute?</a:t>
+              <a:t> — the model consumes measured Hi-C contact structure (insulation, directionality, contact density, A/B compartments), not just the linear sequence.</a:t>
             </a:r>
           </a:p>
           <a:p>
             <a:pPr marL="457200" lvl="0" indent="-457200" algn="just">
               <a:spcAft>
-                <a:spcPts val="900"/>
+                <a:spcPts val="700"/>
               </a:spcAft>
               <a:buFont typeface="+mj-lt"/>
               <a:buAutoNum type="arabicPeriod"/>
             </a:pPr>
             <a:r>
+              <a:rPr lang="en-US" sz="1800" b="1" dirty="0">
+                <a:solidFill>
+                  <a:srgbClr val="252525"/>
+                </a:solidFill>
+                <a:latin typeface="Calisto MT" panose="02040603050505030304" pitchFamily="18" charset="0"/>
+              </a:rPr>
+              <a:t>"Genomic"</a:t>
+            </a:r>
+            <a:r>
               <a:rPr lang="en-US" sz="1800" dirty="0">
                 <a:solidFill>
                   <a:srgbClr val="252525"/>
                 </a:solidFill>
                 <a:latin typeface="Calisto MT" panose="02040603050505030304" pitchFamily="18" charset="0"/>
               </a:rPr>
-              <a:t>Does structure entering the SSM recurrence during pretraining outperform post-hoc integration (CHROME-style) and contrastive distillation (Evo2HiC-style) on regulatory and variant-effect transfer tasks?</a:t>
+              <a:t> — it operates on nucleotide-resolution DNA, where CTCF motif orientation the actual loop grammar is representable (impossible at CHROME’s 5 kb bins).</a:t>
+            </a:r>
+          </a:p>
+          <a:p>
+            <a:pPr marL="457200" lvl="0" indent="-457200" algn="just">
+              <a:spcAft>
+                <a:spcPts val="700"/>
+              </a:spcAft>
+              <a:buFont typeface="+mj-lt"/>
+              <a:buAutoNum type="arabicPeriod"/>
+            </a:pPr>
+            <a:r>
+              <a:rPr lang="en-US" sz="1800" b="1" dirty="0">
+                <a:solidFill>
+                  <a:srgbClr val="252525"/>
+                </a:solidFill>
+                <a:latin typeface="Calisto MT" panose="02040603050505030304" pitchFamily="18" charset="0"/>
+              </a:rPr>
+              <a:t>"Foundation Model"</a:t>
+            </a:r>
+            <a:r>
+              <a:rPr lang="en-US" sz="1800" dirty="0">
+                <a:solidFill>
+                  <a:srgbClr val="252525"/>
+                </a:solidFill>
+                <a:latin typeface="Calisto MT" panose="02040603050505030304" pitchFamily="18" charset="0"/>
+              </a:rPr>
+              <a:t> — general-purpose self-supervised pretraining evaluated by transfer, unlike supervised single-task predictors (Akita, Orca, CHROME).</a:t>
             </a:r>
           </a:p>
           <a:p>
@@ -8828,7 +8760,25 @@
                 </a:solidFill>
                 <a:latin typeface="Calisto MT" panose="02040603050505030304" pitchFamily="18" charset="0"/>
               </a:rPr>
-              <a:t>Are the observed gains attributable to genuine locus-specific 3D structure rather than to genomic distance decay — i.e., do shuffled-structure and distance-matched controls (S0–S3) degrade performance?</a:t>
+              <a:t>The title states the mechanism precisely that is awareness of 3D chromatin </a:t>
+            </a:r>
+            <a:r>
+              <a:rPr lang="en-US" sz="1800" b="1" dirty="0">
+                <a:solidFill>
+                  <a:srgbClr val="252525"/>
+                </a:solidFill>
+                <a:latin typeface="Calisto MT" panose="02040603050505030304" pitchFamily="18" charset="0"/>
+              </a:rPr>
+              <a:t>during pretraining</a:t>
+            </a:r>
+            <a:r>
+              <a:rPr lang="en-US" sz="1800" dirty="0">
+                <a:solidFill>
+                  <a:srgbClr val="252525"/>
+                </a:solidFill>
+                <a:latin typeface="Calisto MT" panose="02040603050505030304" pitchFamily="18" charset="0"/>
+              </a:rPr>
+              <a:t> is what no alternative title in this space already covers.</a:t>
             </a:r>
           </a:p>
         </p:txBody>
@@ -8876,7 +8826,7 @@
     </p:spTree>
     <p:extLst>
       <p:ext uri="{BB962C8B-B14F-4D97-AF65-F5344CB8AC3E}">
-        <p14:creationId xmlns:p14="http://schemas.microsoft.com/office/powerpoint/2010/main" val="2481146048"/>
+        <p14:creationId xmlns:p14="http://schemas.microsoft.com/office/powerpoint/2010/main" val="3066301131"/>
       </p:ext>
     </p:extLst>
   </p:cSld>
@@ -8940,7 +8890,7 @@
                 </a:solidFill>
                 <a:latin typeface="Calisto MT" panose="02040603050505030304" pitchFamily="18" charset="0"/>
               </a:rPr>
-              <a:t>5. Title Justification</a:t>
+              <a:t>6. Objectives</a:t>
             </a:r>
           </a:p>
         </p:txBody>
@@ -8975,82 +8925,55 @@
           <a:p>
             <a:pPr marL="457200" lvl="0" indent="-457200" algn="just">
               <a:spcAft>
-                <a:spcPts val="700"/>
+                <a:spcPts val="800"/>
               </a:spcAft>
               <a:buFont typeface="+mj-lt"/>
               <a:buAutoNum type="arabicPeriod"/>
             </a:pPr>
             <a:r>
-              <a:rPr lang="en-US" sz="1800" b="1" dirty="0">
-                <a:solidFill>
-                  <a:srgbClr val="252525"/>
-                </a:solidFill>
-                <a:latin typeface="Calisto MT" panose="02040603050505030304" pitchFamily="18" charset="0"/>
-              </a:rPr>
-              <a:t>"3D-Chromatin-Aware"</a:t>
-            </a:r>
-            <a:r>
               <a:rPr lang="en-US" sz="1800" dirty="0">
                 <a:solidFill>
                   <a:srgbClr val="252525"/>
                 </a:solidFill>
                 <a:latin typeface="Calisto MT" panose="02040603050505030304" pitchFamily="18" charset="0"/>
               </a:rPr>
-              <a:t xml:space="preserve"> — the model consumes measured Hi-C contact structure (insulation, directionality, contact density, A/B compartments), not just the linear sequence.</a:t>
+              <a:t>To construct a paired sequence + Hi-C pilot dataset (GM12878, chr9, GRCh38) with an 8-feature per-bin structural vector validated against independent 4D Nucleome tracks (target r &gt; 0.95).</a:t>
             </a:r>
           </a:p>
           <a:p>
             <a:pPr marL="457200" lvl="0" indent="-457200" algn="just">
               <a:spcAft>
-                <a:spcPts val="700"/>
+                <a:spcPts val="800"/>
               </a:spcAft>
               <a:buFont typeface="+mj-lt"/>
               <a:buAutoNum type="arabicPeriod"/>
             </a:pPr>
             <a:r>
-              <a:rPr lang="en-US" sz="1800" b="1" dirty="0">
-                <a:solidFill>
-                  <a:srgbClr val="252525"/>
-                </a:solidFill>
-                <a:latin typeface="Calisto MT" panose="02040603050505030304" pitchFamily="18" charset="0"/>
-              </a:rPr>
-              <a:t>"Genomic"</a:t>
-            </a:r>
-            <a:r>
               <a:rPr lang="en-US" sz="1800" dirty="0">
                 <a:solidFill>
                   <a:srgbClr val="252525"/>
                 </a:solidFill>
                 <a:latin typeface="Calisto MT" panose="02040603050505030304" pitchFamily="18" charset="0"/>
               </a:rPr>
-              <a:t xml:space="preserve"> — it operates on nucleotide-resolution DNA, where CTCF motif orientation — the actual loop grammar — is representable (impossible at CHROME’s 5 kb bins).</a:t>
+              <a:t>To design and implement a structural-bias mechanism inside a bidirectional Mamba recurrence, matching the sequence-only baseline’s parameter count within 5% (achieved: +0.43%).</a:t>
             </a:r>
           </a:p>
           <a:p>
             <a:pPr marL="457200" lvl="0" indent="-457200" algn="just">
               <a:spcAft>
-                <a:spcPts val="700"/>
+                <a:spcPts val="800"/>
               </a:spcAft>
               <a:buFont typeface="+mj-lt"/>
               <a:buAutoNum type="arabicPeriod"/>
             </a:pPr>
             <a:r>
-              <a:rPr lang="en-US" sz="1800" b="1" dirty="0">
-                <a:solidFill>
-                  <a:srgbClr val="252525"/>
-                </a:solidFill>
-                <a:latin typeface="Calisto MT" panose="02040603050505030304" pitchFamily="18" charset="0"/>
-              </a:rPr>
-              <a:t>"Foundation Model"</a:t>
-            </a:r>
-            <a:r>
               <a:rPr lang="en-US" sz="1800" dirty="0">
                 <a:solidFill>
                   <a:srgbClr val="252525"/>
                 </a:solidFill>
                 <a:latin typeface="Calisto MT" panose="02040603050505030304" pitchFamily="18" charset="0"/>
               </a:rPr>
-              <a:t xml:space="preserve"> — general-purpose self-supervised pretraining evaluated by transfer, unlike supervised single-task predictors (Akita, Orca, CHROME).</a:t>
+              <a:t>To pretrain and compare four matched arms — sequence-only, CHROME-style post-hoc, Evo2HiC-style distillation, and the proposed model — with at least 3 seeds per configuration.</a:t>
             </a:r>
           </a:p>
           <a:p>
@@ -9065,25 +8988,7 @@
                 </a:solidFill>
                 <a:latin typeface="Calisto MT" panose="02040603050505030304" pitchFamily="18" charset="0"/>
               </a:rPr>
-              <a:t xml:space="preserve">The title states the mechanism precisely: awareness of 3D chromatin </a:t>
-            </a:r>
-            <a:r>
-              <a:rPr lang="en-US" sz="1800" b="1" dirty="0">
-                <a:solidFill>
-                  <a:srgbClr val="252525"/>
-                </a:solidFill>
-                <a:latin typeface="Calisto MT" panose="02040603050505030304" pitchFamily="18" charset="0"/>
-              </a:rPr>
-              <a:t>during pretraining</a:t>
-            </a:r>
-            <a:r>
-              <a:rPr lang="en-US" sz="1800" dirty="0">
-                <a:solidFill>
-                  <a:srgbClr val="252525"/>
-                </a:solidFill>
-                <a:latin typeface="Calisto MT" panose="02040603050505030304" pitchFamily="18" charset="0"/>
-              </a:rPr>
-              <a:t xml:space="preserve"> is what no alternative title in this space already covers.</a:t>
+              <a:t>To verify via shuffled-structure controls (S0–S3) that any gain derives from genuine 3D structure, and to evaluate transfer on DNALongBench-style regulatory and variant tasks.</a:t>
             </a:r>
           </a:p>
         </p:txBody>
@@ -9131,7 +9036,7 @@
     </p:spTree>
     <p:extLst>
       <p:ext uri="{BB962C8B-B14F-4D97-AF65-F5344CB8AC3E}">
-        <p14:creationId xmlns:p14="http://schemas.microsoft.com/office/powerpoint/2010/main" val="3066301131"/>
+        <p14:creationId xmlns:p14="http://schemas.microsoft.com/office/powerpoint/2010/main" val="441088729"/>
       </p:ext>
     </p:extLst>
   </p:cSld>

</xml_diff>